<commit_message>
Add agenda and Copilot primitives slides to demo deck
- New Agenda slide (slide 2)
- New Customization Primitives table slide (instructions, prompts, skills,
  custom agents, MCP, hooks, memory) placed between Copilot and Actions
- Deck now 5 slides; runbook and README updated to match

Co-authored-by: Copilot <223556219+Copilot@users.noreply.github.com>
</commit_message>
<xml_diff>
--- a/presentation/copilot-actions-overview.pptx
+++ b/presentation/copilot-actions-overview.pptx
@@ -8,9 +8,11 @@
     <p:sldId id="256" r:id="rId2"/>
     <p:sldId id="257" r:id="rId3"/>
     <p:sldId id="258" r:id="rId4"/>
+    <p:sldId id="259" r:id="rId5"/>
+    <p:sldId id="260" r:id="rId6"/>
   </p:sldIdLst>
   <p:notesMasterIdLst>
-    <p:notesMasterId r:id="rId5"/>
+    <p:notesMasterId r:id="rId7"/>
   </p:notesMasterIdLst>
   <p:sldSz cx="12191695" cy="6858000"/>
   <p:notesSz cx="6858000" cy="12191695"/>
@@ -704,6 +706,182 @@
             <a:fld id="{F7021451-1387-4CA6-816F-3879F97B5CBC}" type="slidenum">
               <a:rPr lang="en-US"/>
               <a:t>3</a:t>
+            </a:fld>
+            <a:endParaRPr lang="en-US"/>
+          </a:p>
+        </p:txBody>
+      </p:sp>
+    </p:spTree>
+    <p:extLst>
+      <p:ext uri="{BB962C8B-B14F-4D97-AF65-F5344CB8AC3E}">
+        <p14:creationId xmlns:p14="http://schemas.microsoft.com/office/powerpoint/2010/main" val="1024086991"/>
+      </p:ext>
+    </p:extLst>
+  </p:cSld>
+  <p:clrMapOvr>
+    <a:masterClrMapping/>
+  </p:clrMapOvr>
+</p:notes>
+</file>
+
+<file path=ppt/notesSlides/notesSlide4.xml><?xml version="1.0" encoding="utf-8"?>
+<p:notes xmlns:a="http://schemas.openxmlformats.org/drawingml/2006/main" xmlns:r="http://schemas.openxmlformats.org/officeDocument/2006/relationships" xmlns:p="http://schemas.openxmlformats.org/presentationml/2006/main">
+  <p:cSld>
+    <p:spTree>
+      <p:nvGrpSpPr>
+        <p:cNvPr id="1" name=""/>
+        <p:cNvGrpSpPr/>
+        <p:nvPr/>
+      </p:nvGrpSpPr>
+      <p:grpSpPr>
+        <a:xfrm>
+          <a:off x="0" y="0"/>
+          <a:ext cx="0" cy="0"/>
+          <a:chOff x="0" y="0"/>
+          <a:chExt cx="0" cy="0"/>
+        </a:xfrm>
+      </p:grpSpPr>
+      <p:sp>
+        <p:nvSpPr>
+          <p:cNvPr id="2" name="Slide Image Placeholder 1"/>
+          <p:cNvSpPr>
+            <a:spLocks noGrp="1" noRot="1" noChangeAspect="1"/>
+          </p:cNvSpPr>
+          <p:nvPr>
+            <p:ph type="sldImg"/>
+          </p:nvPr>
+        </p:nvSpPr>
+        <p:spPr/>
+      </p:sp>
+      <p:sp>
+        <p:nvSpPr>
+          <p:cNvPr id="3" name="Notes Placeholder 2"/>
+          <p:cNvSpPr>
+            <a:spLocks noGrp="1"/>
+          </p:cNvSpPr>
+          <p:nvPr>
+            <p:ph type="body" idx="1"/>
+          </p:nvPr>
+        </p:nvSpPr>
+        <p:spPr/>
+        <p:txBody>
+          <a:bodyPr/>
+          <a:lstStyle/>
+          <a:p>
+            <a:r>
+              <a:rPr lang="en-US" dirty="0"/>
+              <a:t/>
+            </a:r>
+            <a:endParaRPr lang="en-US" dirty="0"/>
+          </a:p>
+        </p:txBody>
+      </p:sp>
+      <p:sp>
+        <p:nvSpPr>
+          <p:cNvPr id="4" name="Slide Number Placeholder 3"/>
+          <p:cNvSpPr>
+            <a:spLocks noGrp="1"/>
+          </p:cNvSpPr>
+          <p:nvPr>
+            <p:ph type="sldNum" sz="quarter" idx="10"/>
+          </p:nvPr>
+        </p:nvSpPr>
+        <p:spPr/>
+        <p:txBody>
+          <a:bodyPr/>
+          <a:lstStyle/>
+          <a:p>
+            <a:fld id="{F7021451-1387-4CA6-816F-3879F97B5CBC}" type="slidenum">
+              <a:rPr lang="en-US"/>
+              <a:t>4</a:t>
+            </a:fld>
+            <a:endParaRPr lang="en-US"/>
+          </a:p>
+        </p:txBody>
+      </p:sp>
+    </p:spTree>
+    <p:extLst>
+      <p:ext uri="{BB962C8B-B14F-4D97-AF65-F5344CB8AC3E}">
+        <p14:creationId xmlns:p14="http://schemas.microsoft.com/office/powerpoint/2010/main" val="1024086991"/>
+      </p:ext>
+    </p:extLst>
+  </p:cSld>
+  <p:clrMapOvr>
+    <a:masterClrMapping/>
+  </p:clrMapOvr>
+</p:notes>
+</file>
+
+<file path=ppt/notesSlides/notesSlide5.xml><?xml version="1.0" encoding="utf-8"?>
+<p:notes xmlns:a="http://schemas.openxmlformats.org/drawingml/2006/main" xmlns:r="http://schemas.openxmlformats.org/officeDocument/2006/relationships" xmlns:p="http://schemas.openxmlformats.org/presentationml/2006/main">
+  <p:cSld>
+    <p:spTree>
+      <p:nvGrpSpPr>
+        <p:cNvPr id="1" name=""/>
+        <p:cNvGrpSpPr/>
+        <p:nvPr/>
+      </p:nvGrpSpPr>
+      <p:grpSpPr>
+        <a:xfrm>
+          <a:off x="0" y="0"/>
+          <a:ext cx="0" cy="0"/>
+          <a:chOff x="0" y="0"/>
+          <a:chExt cx="0" cy="0"/>
+        </a:xfrm>
+      </p:grpSpPr>
+      <p:sp>
+        <p:nvSpPr>
+          <p:cNvPr id="2" name="Slide Image Placeholder 1"/>
+          <p:cNvSpPr>
+            <a:spLocks noGrp="1" noRot="1" noChangeAspect="1"/>
+          </p:cNvSpPr>
+          <p:nvPr>
+            <p:ph type="sldImg"/>
+          </p:nvPr>
+        </p:nvSpPr>
+        <p:spPr/>
+      </p:sp>
+      <p:sp>
+        <p:nvSpPr>
+          <p:cNvPr id="3" name="Notes Placeholder 2"/>
+          <p:cNvSpPr>
+            <a:spLocks noGrp="1"/>
+          </p:cNvSpPr>
+          <p:nvPr>
+            <p:ph type="body" idx="1"/>
+          </p:nvPr>
+        </p:nvSpPr>
+        <p:spPr/>
+        <p:txBody>
+          <a:bodyPr/>
+          <a:lstStyle/>
+          <a:p>
+            <a:r>
+              <a:rPr lang="en-US" dirty="0"/>
+              <a:t/>
+            </a:r>
+            <a:endParaRPr lang="en-US" dirty="0"/>
+          </a:p>
+        </p:txBody>
+      </p:sp>
+      <p:sp>
+        <p:nvSpPr>
+          <p:cNvPr id="4" name="Slide Number Placeholder 3"/>
+          <p:cNvSpPr>
+            <a:spLocks noGrp="1"/>
+          </p:cNvSpPr>
+          <p:nvPr>
+            <p:ph type="sldNum" sz="quarter" idx="10"/>
+          </p:nvPr>
+        </p:nvSpPr>
+        <p:spPr/>
+        <p:txBody>
+          <a:bodyPr/>
+          <a:lstStyle/>
+          <a:p>
+            <a:fld id="{F7021451-1387-4CA6-816F-3879F97B5CBC}" type="slidenum">
+              <a:rPr lang="en-US"/>
+              <a:t>5</a:t>
             </a:fld>
             <a:endParaRPr lang="en-US"/>
           </a:p>
@@ -1489,7 +1667,7 @@
             <a:avLst/>
           </a:prstGeom>
           <a:solidFill>
-            <a:srgbClr val="A371F7"/>
+            <a:srgbClr val="58A6FF"/>
           </a:solidFill>
           <a:ln/>
         </p:spPr>
@@ -1550,7 +1728,7 @@
             </a:avLst>
           </a:prstGeom>
           <a:solidFill>
-            <a:srgbClr val="A371F7"/>
+            <a:srgbClr val="58A6FF"/>
           </a:solidFill>
           <a:ln/>
         </p:spPr>
@@ -1570,7 +1748,7 @@
                 <a:ea typeface="Helvetica" pitchFamily="34" charset="-122"/>
                 <a:cs typeface="Helvetica" pitchFamily="34" charset="-120"/>
               </a:rPr>
-              <a:t>COPILOT</a:t>
+              <a:t>AGENDA</a:t>
             </a:r>
             <a:endParaRPr lang="en-US" sz="1200" dirty="0"/>
           </a:p>
@@ -1609,7 +1787,7 @@
                 <a:ea typeface="Helvetica" pitchFamily="34" charset="-122"/>
                 <a:cs typeface="Helvetica" pitchFamily="34" charset="-120"/>
               </a:rPr>
-              <a:t>Your AI pair programmer</a:t>
+              <a:t>What we'll cover</a:t>
             </a:r>
             <a:endParaRPr lang="en-US" sz="3600" dirty="0"/>
           </a:p>
@@ -1623,8 +1801,8 @@
         </p:nvSpPr>
         <p:spPr>
           <a:xfrm>
-            <a:off x="640080" y="1828800"/>
-            <a:ext cx="10972800" cy="457200"/>
+            <a:off x="640080" y="2240280"/>
+            <a:ext cx="914400" cy="822960"/>
           </a:xfrm>
           <a:prstGeom prst="rect">
             <a:avLst/>
@@ -1640,7 +1818,108 @@
               <a:buNone/>
             </a:pPr>
             <a:r>
-              <a:rPr lang="en-US" sz="1600" dirty="0">
+              <a:rPr lang="en-US" sz="3400" b="1" dirty="0">
+                <a:solidFill>
+                  <a:srgbClr val="A371F7"/>
+                </a:solidFill>
+                <a:latin typeface="Helvetica" pitchFamily="34" charset="0"/>
+                <a:ea typeface="Helvetica" pitchFamily="34" charset="-122"/>
+                <a:cs typeface="Helvetica" pitchFamily="34" charset="-120"/>
+              </a:rPr>
+              <a:t>01</a:t>
+            </a:r>
+            <a:endParaRPr lang="en-US" sz="3400" dirty="0"/>
+          </a:p>
+        </p:txBody>
+      </p:sp>
+      <p:sp>
+        <p:nvSpPr>
+          <p:cNvPr id="7" name="Shape 5"/>
+          <p:cNvSpPr/>
+          <p:nvPr/>
+        </p:nvSpPr>
+        <p:spPr>
+          <a:xfrm>
+            <a:off x="1691640" y="2286000"/>
+            <a:ext cx="0" cy="731520"/>
+          </a:xfrm>
+          <a:prstGeom prst="line">
+            <a:avLst/>
+          </a:prstGeom>
+          <a:noFill/>
+          <a:ln w="19050">
+            <a:solidFill>
+              <a:srgbClr val="30363D"/>
+            </a:solidFill>
+            <a:prstDash val="solid"/>
+          </a:ln>
+        </p:spPr>
+      </p:sp>
+      <p:sp>
+        <p:nvSpPr>
+          <p:cNvPr id="8" name="Text 6"/>
+          <p:cNvSpPr/>
+          <p:nvPr/>
+        </p:nvSpPr>
+        <p:spPr>
+          <a:xfrm>
+            <a:off x="1920240" y="2258568"/>
+            <a:ext cx="9601200" cy="457200"/>
+          </a:xfrm>
+          <a:prstGeom prst="rect">
+            <a:avLst/>
+          </a:prstGeom>
+          <a:noFill/>
+          <a:ln/>
+        </p:spPr>
+        <p:txBody>
+          <a:bodyPr wrap="square" rtlCol="0" anchor="ctr"/>
+          <a:lstStyle/>
+          <a:p>
+            <a:pPr indent="0" marL="0">
+              <a:buNone/>
+            </a:pPr>
+            <a:r>
+              <a:rPr lang="en-US" sz="2000" b="1" dirty="0">
+                <a:solidFill>
+                  <a:srgbClr val="E6EDF3"/>
+                </a:solidFill>
+                <a:latin typeface="Helvetica" pitchFamily="34" charset="0"/>
+                <a:ea typeface="Helvetica" pitchFamily="34" charset="-122"/>
+                <a:cs typeface="Helvetica" pitchFamily="34" charset="-120"/>
+              </a:rPr>
+              <a:t>GitHub Copilot</a:t>
+            </a:r>
+            <a:endParaRPr lang="en-US" sz="2000" dirty="0"/>
+          </a:p>
+        </p:txBody>
+      </p:sp>
+      <p:sp>
+        <p:nvSpPr>
+          <p:cNvPr id="9" name="Text 7"/>
+          <p:cNvSpPr/>
+          <p:nvPr/>
+        </p:nvSpPr>
+        <p:spPr>
+          <a:xfrm>
+            <a:off x="1920240" y="2697480"/>
+            <a:ext cx="9601200" cy="365760"/>
+          </a:xfrm>
+          <a:prstGeom prst="rect">
+            <a:avLst/>
+          </a:prstGeom>
+          <a:noFill/>
+          <a:ln/>
+        </p:spPr>
+        <p:txBody>
+          <a:bodyPr wrap="square" rtlCol="0" anchor="ctr"/>
+          <a:lstStyle/>
+          <a:p>
+            <a:pPr indent="0" marL="0">
+              <a:buNone/>
+            </a:pPr>
+            <a:r>
+              <a:rPr lang="en-US" sz="1400" dirty="0">
                 <a:solidFill>
                   <a:srgbClr val="8B949E"/>
                 </a:solidFill>
@@ -1648,32 +1927,67 @@
                 <a:ea typeface="Helvetica" pitchFamily="34" charset="-122"/>
                 <a:cs typeface="Helvetica" pitchFamily="34" charset="-120"/>
               </a:rPr>
-              <a:t>Context-aware AI across the developer workflow — from the editor to the pull request.</a:t>
-            </a:r>
-            <a:endParaRPr lang="en-US" sz="1600" dirty="0"/>
+              <a:t>Your AI pair programmer — completions, chat, and agents.</a:t>
+            </a:r>
+            <a:endParaRPr lang="en-US" sz="1400" dirty="0"/>
           </a:p>
         </p:txBody>
       </p:sp>
       <p:sp>
         <p:nvSpPr>
-          <p:cNvPr id="7" name="Shape 5"/>
-          <p:cNvSpPr/>
-          <p:nvPr/>
-        </p:nvSpPr>
-        <p:spPr>
-          <a:xfrm>
-            <a:off x="640080" y="2560320"/>
-            <a:ext cx="5303520" cy="1463040"/>
-          </a:xfrm>
-          <a:prstGeom prst="roundRect">
-            <a:avLst>
-              <a:gd name="adj" fmla="val 7500"/>
-            </a:avLst>
-          </a:prstGeom>
-          <a:solidFill>
-            <a:srgbClr val="161B22"/>
-          </a:solidFill>
-          <a:ln w="12700">
+          <p:cNvPr id="10" name="Text 8"/>
+          <p:cNvSpPr/>
+          <p:nvPr/>
+        </p:nvSpPr>
+        <p:spPr>
+          <a:xfrm>
+            <a:off x="640080" y="3200400"/>
+            <a:ext cx="914400" cy="822960"/>
+          </a:xfrm>
+          <a:prstGeom prst="rect">
+            <a:avLst/>
+          </a:prstGeom>
+          <a:noFill/>
+          <a:ln/>
+        </p:spPr>
+        <p:txBody>
+          <a:bodyPr wrap="square" rtlCol="0" anchor="ctr"/>
+          <a:lstStyle/>
+          <a:p>
+            <a:pPr indent="0" marL="0">
+              <a:buNone/>
+            </a:pPr>
+            <a:r>
+              <a:rPr lang="en-US" sz="3400" b="1" dirty="0">
+                <a:solidFill>
+                  <a:srgbClr val="58A6FF"/>
+                </a:solidFill>
+                <a:latin typeface="Helvetica" pitchFamily="34" charset="0"/>
+                <a:ea typeface="Helvetica" pitchFamily="34" charset="-122"/>
+                <a:cs typeface="Helvetica" pitchFamily="34" charset="-120"/>
+              </a:rPr>
+              <a:t>02</a:t>
+            </a:r>
+            <a:endParaRPr lang="en-US" sz="3400" dirty="0"/>
+          </a:p>
+        </p:txBody>
+      </p:sp>
+      <p:sp>
+        <p:nvSpPr>
+          <p:cNvPr id="11" name="Shape 9"/>
+          <p:cNvSpPr/>
+          <p:nvPr/>
+        </p:nvSpPr>
+        <p:spPr>
+          <a:xfrm>
+            <a:off x="1691640" y="3246120"/>
+            <a:ext cx="0" cy="731520"/>
+          </a:xfrm>
+          <a:prstGeom prst="line">
+            <a:avLst/>
+          </a:prstGeom>
+          <a:noFill/>
+          <a:ln w="19050">
             <a:solidFill>
               <a:srgbClr val="30363D"/>
             </a:solidFill>
@@ -1683,14 +1997,14 @@
       </p:sp>
       <p:sp>
         <p:nvSpPr>
-          <p:cNvPr id="8" name="Text 6"/>
-          <p:cNvSpPr/>
-          <p:nvPr/>
-        </p:nvSpPr>
-        <p:spPr>
-          <a:xfrm>
-            <a:off x="914400" y="2743200"/>
-            <a:ext cx="4754880" cy="457200"/>
+          <p:cNvPr id="12" name="Text 10"/>
+          <p:cNvSpPr/>
+          <p:nvPr/>
+        </p:nvSpPr>
+        <p:spPr>
+          <a:xfrm>
+            <a:off x="1920240" y="3218688"/>
+            <a:ext cx="9601200" cy="457200"/>
           </a:xfrm>
           <a:prstGeom prst="rect">
             <a:avLst/>
@@ -1706,46 +2020,7 @@
               <a:buNone/>
             </a:pPr>
             <a:r>
-              <a:rPr lang="en-US" sz="1800" b="1" dirty="0">
-                <a:solidFill>
-                  <a:srgbClr val="A371F7"/>
-                </a:solidFill>
-                <a:latin typeface="Helvetica" pitchFamily="34" charset="0"/>
-                <a:ea typeface="Helvetica" pitchFamily="34" charset="-122"/>
-                <a:cs typeface="Helvetica" pitchFamily="34" charset="-120"/>
-              </a:rPr>
-              <a:t>Code completions</a:t>
-            </a:r>
-            <a:endParaRPr lang="en-US" sz="1800" dirty="0"/>
-          </a:p>
-        </p:txBody>
-      </p:sp>
-      <p:sp>
-        <p:nvSpPr>
-          <p:cNvPr id="9" name="Text 7"/>
-          <p:cNvSpPr/>
-          <p:nvPr/>
-        </p:nvSpPr>
-        <p:spPr>
-          <a:xfrm>
-            <a:off x="914400" y="3218688"/>
-            <a:ext cx="4754880" cy="731520"/>
-          </a:xfrm>
-          <a:prstGeom prst="rect">
-            <a:avLst/>
-          </a:prstGeom>
-          <a:noFill/>
-          <a:ln/>
-        </p:spPr>
-        <p:txBody>
-          <a:bodyPr wrap="square" rtlCol="0" anchor="ctr"/>
-          <a:lstStyle/>
-          <a:p>
-            <a:pPr indent="0" marL="0">
-              <a:buNone/>
-            </a:pPr>
-            <a:r>
-              <a:rPr lang="en-US" sz="1400" dirty="0">
+              <a:rPr lang="en-US" sz="2000" b="1" dirty="0">
                 <a:solidFill>
                   <a:srgbClr val="E6EDF3"/>
                 </a:solidFill>
@@ -1753,7 +2028,46 @@
                 <a:ea typeface="Helvetica" pitchFamily="34" charset="-122"/>
                 <a:cs typeface="Helvetica" pitchFamily="34" charset="-120"/>
               </a:rPr>
-              <a:t>Real-time, multi-line suggestions in your IDE.</a:t>
+              <a:t>Customizing Copilot</a:t>
+            </a:r>
+            <a:endParaRPr lang="en-US" sz="2000" dirty="0"/>
+          </a:p>
+        </p:txBody>
+      </p:sp>
+      <p:sp>
+        <p:nvSpPr>
+          <p:cNvPr id="13" name="Text 11"/>
+          <p:cNvSpPr/>
+          <p:nvPr/>
+        </p:nvSpPr>
+        <p:spPr>
+          <a:xfrm>
+            <a:off x="1920240" y="3657600"/>
+            <a:ext cx="9601200" cy="365760"/>
+          </a:xfrm>
+          <a:prstGeom prst="rect">
+            <a:avLst/>
+          </a:prstGeom>
+          <a:noFill/>
+          <a:ln/>
+        </p:spPr>
+        <p:txBody>
+          <a:bodyPr wrap="square" rtlCol="0" anchor="ctr"/>
+          <a:lstStyle/>
+          <a:p>
+            <a:pPr indent="0" marL="0">
+              <a:buNone/>
+            </a:pPr>
+            <a:r>
+              <a:rPr lang="en-US" sz="1400" dirty="0">
+                <a:solidFill>
+                  <a:srgbClr val="8B949E"/>
+                </a:solidFill>
+                <a:latin typeface="Helvetica" pitchFamily="34" charset="0"/>
+                <a:ea typeface="Helvetica" pitchFamily="34" charset="-122"/>
+                <a:cs typeface="Helvetica" pitchFamily="34" charset="-120"/>
+              </a:rPr>
+              <a:t>The primitives that ground Copilot in your repo and team.</a:t>
             </a:r>
             <a:endParaRPr lang="en-US" sz="1400" dirty="0"/>
           </a:p>
@@ -1761,24 +2075,59 @@
       </p:sp>
       <p:sp>
         <p:nvSpPr>
-          <p:cNvPr id="10" name="Shape 8"/>
-          <p:cNvSpPr/>
-          <p:nvPr/>
-        </p:nvSpPr>
-        <p:spPr>
-          <a:xfrm>
-            <a:off x="6217920" y="2560320"/>
-            <a:ext cx="5303520" cy="1463040"/>
-          </a:xfrm>
-          <a:prstGeom prst="roundRect">
-            <a:avLst>
-              <a:gd name="adj" fmla="val 7500"/>
-            </a:avLst>
-          </a:prstGeom>
-          <a:solidFill>
-            <a:srgbClr val="161B22"/>
-          </a:solidFill>
-          <a:ln w="12700">
+          <p:cNvPr id="14" name="Text 12"/>
+          <p:cNvSpPr/>
+          <p:nvPr/>
+        </p:nvSpPr>
+        <p:spPr>
+          <a:xfrm>
+            <a:off x="640080" y="4160520"/>
+            <a:ext cx="914400" cy="822960"/>
+          </a:xfrm>
+          <a:prstGeom prst="rect">
+            <a:avLst/>
+          </a:prstGeom>
+          <a:noFill/>
+          <a:ln/>
+        </p:spPr>
+        <p:txBody>
+          <a:bodyPr wrap="square" rtlCol="0" anchor="ctr"/>
+          <a:lstStyle/>
+          <a:p>
+            <a:pPr indent="0" marL="0">
+              <a:buNone/>
+            </a:pPr>
+            <a:r>
+              <a:rPr lang="en-US" sz="3400" b="1" dirty="0">
+                <a:solidFill>
+                  <a:srgbClr val="3FB950"/>
+                </a:solidFill>
+                <a:latin typeface="Helvetica" pitchFamily="34" charset="0"/>
+                <a:ea typeface="Helvetica" pitchFamily="34" charset="-122"/>
+                <a:cs typeface="Helvetica" pitchFamily="34" charset="-120"/>
+              </a:rPr>
+              <a:t>03</a:t>
+            </a:r>
+            <a:endParaRPr lang="en-US" sz="3400" dirty="0"/>
+          </a:p>
+        </p:txBody>
+      </p:sp>
+      <p:sp>
+        <p:nvSpPr>
+          <p:cNvPr id="15" name="Shape 13"/>
+          <p:cNvSpPr/>
+          <p:nvPr/>
+        </p:nvSpPr>
+        <p:spPr>
+          <a:xfrm>
+            <a:off x="1691640" y="4206240"/>
+            <a:ext cx="0" cy="731520"/>
+          </a:xfrm>
+          <a:prstGeom prst="line">
+            <a:avLst/>
+          </a:prstGeom>
+          <a:noFill/>
+          <a:ln w="19050">
             <a:solidFill>
               <a:srgbClr val="30363D"/>
             </a:solidFill>
@@ -1788,14 +2137,14 @@
       </p:sp>
       <p:sp>
         <p:nvSpPr>
-          <p:cNvPr id="11" name="Text 9"/>
-          <p:cNvSpPr/>
-          <p:nvPr/>
-        </p:nvSpPr>
-        <p:spPr>
-          <a:xfrm>
-            <a:off x="6492240" y="2743200"/>
-            <a:ext cx="4754880" cy="457200"/>
+          <p:cNvPr id="16" name="Text 14"/>
+          <p:cNvSpPr/>
+          <p:nvPr/>
+        </p:nvSpPr>
+        <p:spPr>
+          <a:xfrm>
+            <a:off x="1920240" y="4178808"/>
+            <a:ext cx="9601200" cy="457200"/>
           </a:xfrm>
           <a:prstGeom prst="rect">
             <a:avLst/>
@@ -1811,46 +2160,7 @@
               <a:buNone/>
             </a:pPr>
             <a:r>
-              <a:rPr lang="en-US" sz="1800" b="1" dirty="0">
-                <a:solidFill>
-                  <a:srgbClr val="A371F7"/>
-                </a:solidFill>
-                <a:latin typeface="Helvetica" pitchFamily="34" charset="0"/>
-                <a:ea typeface="Helvetica" pitchFamily="34" charset="-122"/>
-                <a:cs typeface="Helvetica" pitchFamily="34" charset="-120"/>
-              </a:rPr>
-              <a:t>Chat &amp; /commands</a:t>
-            </a:r>
-            <a:endParaRPr lang="en-US" sz="1800" dirty="0"/>
-          </a:p>
-        </p:txBody>
-      </p:sp>
-      <p:sp>
-        <p:nvSpPr>
-          <p:cNvPr id="12" name="Text 10"/>
-          <p:cNvSpPr/>
-          <p:nvPr/>
-        </p:nvSpPr>
-        <p:spPr>
-          <a:xfrm>
-            <a:off x="6492240" y="3218688"/>
-            <a:ext cx="4754880" cy="731520"/>
-          </a:xfrm>
-          <a:prstGeom prst="rect">
-            <a:avLst/>
-          </a:prstGeom>
-          <a:noFill/>
-          <a:ln/>
-        </p:spPr>
-        <p:txBody>
-          <a:bodyPr wrap="square" rtlCol="0" anchor="ctr"/>
-          <a:lstStyle/>
-          <a:p>
-            <a:pPr indent="0" marL="0">
-              <a:buNone/>
-            </a:pPr>
-            <a:r>
-              <a:rPr lang="en-US" sz="1400" dirty="0">
+              <a:rPr lang="en-US" sz="2000" b="1" dirty="0">
                 <a:solidFill>
                   <a:srgbClr val="E6EDF3"/>
                 </a:solidFill>
@@ -1858,49 +2168,22 @@
                 <a:ea typeface="Helvetica" pitchFamily="34" charset="-122"/>
                 <a:cs typeface="Helvetica" pitchFamily="34" charset="-120"/>
               </a:rPr>
-              <a:t>Explain, refactor, write tests, fix errors in context.</a:t>
-            </a:r>
-            <a:endParaRPr lang="en-US" sz="1400" dirty="0"/>
+              <a:t>GitHub Actions</a:t>
+            </a:r>
+            <a:endParaRPr lang="en-US" sz="2000" dirty="0"/>
           </a:p>
         </p:txBody>
       </p:sp>
       <p:sp>
         <p:nvSpPr>
-          <p:cNvPr id="13" name="Shape 11"/>
-          <p:cNvSpPr/>
-          <p:nvPr/>
-        </p:nvSpPr>
-        <p:spPr>
-          <a:xfrm>
-            <a:off x="640080" y="4251960"/>
-            <a:ext cx="5303520" cy="1463040"/>
-          </a:xfrm>
-          <a:prstGeom prst="roundRect">
-            <a:avLst>
-              <a:gd name="adj" fmla="val 7500"/>
-            </a:avLst>
-          </a:prstGeom>
-          <a:solidFill>
-            <a:srgbClr val="161B22"/>
-          </a:solidFill>
-          <a:ln w="12700">
-            <a:solidFill>
-              <a:srgbClr val="30363D"/>
-            </a:solidFill>
-            <a:prstDash val="solid"/>
-          </a:ln>
-        </p:spPr>
-      </p:sp>
-      <p:sp>
-        <p:nvSpPr>
-          <p:cNvPr id="14" name="Text 12"/>
-          <p:cNvSpPr/>
-          <p:nvPr/>
-        </p:nvSpPr>
-        <p:spPr>
-          <a:xfrm>
-            <a:off x="914400" y="4434840"/>
-            <a:ext cx="4754880" cy="457200"/>
+          <p:cNvPr id="17" name="Text 15"/>
+          <p:cNvSpPr/>
+          <p:nvPr/>
+        </p:nvSpPr>
+        <p:spPr>
+          <a:xfrm>
+            <a:off x="1920240" y="4617720"/>
+            <a:ext cx="9601200" cy="365760"/>
           </a:xfrm>
           <a:prstGeom prst="rect">
             <a:avLst/>
@@ -1916,30 +2199,30 @@
               <a:buNone/>
             </a:pPr>
             <a:r>
-              <a:rPr lang="en-US" sz="1800" b="1" dirty="0">
+              <a:rPr lang="en-US" sz="1400" dirty="0">
                 <a:solidFill>
-                  <a:srgbClr val="A371F7"/>
+                  <a:srgbClr val="8B949E"/>
                 </a:solidFill>
                 <a:latin typeface="Helvetica" pitchFamily="34" charset="0"/>
                 <a:ea typeface="Helvetica" pitchFamily="34" charset="-122"/>
                 <a:cs typeface="Helvetica" pitchFamily="34" charset="-120"/>
               </a:rPr>
-              <a:t>Agents</a:t>
-            </a:r>
-            <a:endParaRPr lang="en-US" sz="1800" dirty="0"/>
+              <a:t>CI/CD native to GitHub — events, workflows, runners.</a:t>
+            </a:r>
+            <a:endParaRPr lang="en-US" sz="1400" dirty="0"/>
           </a:p>
         </p:txBody>
       </p:sp>
       <p:sp>
         <p:nvSpPr>
-          <p:cNvPr id="15" name="Text 13"/>
-          <p:cNvSpPr/>
-          <p:nvPr/>
-        </p:nvSpPr>
-        <p:spPr>
-          <a:xfrm>
-            <a:off x="914400" y="4910328"/>
-            <a:ext cx="4754880" cy="731520"/>
+          <p:cNvPr id="18" name="Text 16"/>
+          <p:cNvSpPr/>
+          <p:nvPr/>
+        </p:nvSpPr>
+        <p:spPr>
+          <a:xfrm>
+            <a:off x="640080" y="5120640"/>
+            <a:ext cx="914400" cy="822960"/>
           </a:xfrm>
           <a:prstGeom prst="rect">
             <a:avLst/>
@@ -1955,7 +2238,7 @@
               <a:buNone/>
             </a:pPr>
             <a:r>
-              <a:rPr lang="en-US" sz="1400" dirty="0">
+              <a:rPr lang="en-US" sz="3400" b="1" dirty="0">
                 <a:solidFill>
                   <a:srgbClr val="E6EDF3"/>
                 </a:solidFill>
@@ -1963,32 +2246,28 @@
                 <a:ea typeface="Helvetica" pitchFamily="34" charset="-122"/>
                 <a:cs typeface="Helvetica" pitchFamily="34" charset="-120"/>
               </a:rPr>
-              <a:t>Delegate whole tasks — Copilot plans, edits files &amp; opens PRs.</a:t>
-            </a:r>
-            <a:endParaRPr lang="en-US" sz="1400" dirty="0"/>
+              <a:t>04</a:t>
+            </a:r>
+            <a:endParaRPr lang="en-US" sz="3400" dirty="0"/>
           </a:p>
         </p:txBody>
       </p:sp>
       <p:sp>
         <p:nvSpPr>
-          <p:cNvPr id="16" name="Shape 14"/>
-          <p:cNvSpPr/>
-          <p:nvPr/>
-        </p:nvSpPr>
-        <p:spPr>
-          <a:xfrm>
-            <a:off x="6217920" y="4251960"/>
-            <a:ext cx="5303520" cy="1463040"/>
-          </a:xfrm>
-          <a:prstGeom prst="roundRect">
-            <a:avLst>
-              <a:gd name="adj" fmla="val 7500"/>
-            </a:avLst>
-          </a:prstGeom>
-          <a:solidFill>
-            <a:srgbClr val="161B22"/>
-          </a:solidFill>
-          <a:ln w="12700">
+          <p:cNvPr id="19" name="Shape 17"/>
+          <p:cNvSpPr/>
+          <p:nvPr/>
+        </p:nvSpPr>
+        <p:spPr>
+          <a:xfrm>
+            <a:off x="1691640" y="5166360"/>
+            <a:ext cx="0" cy="731520"/>
+          </a:xfrm>
+          <a:prstGeom prst="line">
+            <a:avLst/>
+          </a:prstGeom>
+          <a:noFill/>
+          <a:ln w="19050">
             <a:solidFill>
               <a:srgbClr val="30363D"/>
             </a:solidFill>
@@ -1998,14 +2277,14 @@
       </p:sp>
       <p:sp>
         <p:nvSpPr>
-          <p:cNvPr id="17" name="Text 15"/>
-          <p:cNvSpPr/>
-          <p:nvPr/>
-        </p:nvSpPr>
-        <p:spPr>
-          <a:xfrm>
-            <a:off x="6492240" y="4434840"/>
-            <a:ext cx="4754880" cy="457200"/>
+          <p:cNvPr id="20" name="Text 18"/>
+          <p:cNvSpPr/>
+          <p:nvPr/>
+        </p:nvSpPr>
+        <p:spPr>
+          <a:xfrm>
+            <a:off x="1920240" y="5138928"/>
+            <a:ext cx="9601200" cy="457200"/>
           </a:xfrm>
           <a:prstGeom prst="rect">
             <a:avLst/>
@@ -2021,46 +2300,7 @@
               <a:buNone/>
             </a:pPr>
             <a:r>
-              <a:rPr lang="en-US" sz="1800" b="1" dirty="0">
-                <a:solidFill>
-                  <a:srgbClr val="A371F7"/>
-                </a:solidFill>
-                <a:latin typeface="Helvetica" pitchFamily="34" charset="0"/>
-                <a:ea typeface="Helvetica" pitchFamily="34" charset="-122"/>
-                <a:cs typeface="Helvetica" pitchFamily="34" charset="-120"/>
-              </a:rPr>
-              <a:t>Enterprise-ready</a:t>
-            </a:r>
-            <a:endParaRPr lang="en-US" sz="1800" dirty="0"/>
-          </a:p>
-        </p:txBody>
-      </p:sp>
-      <p:sp>
-        <p:nvSpPr>
-          <p:cNvPr id="18" name="Text 16"/>
-          <p:cNvSpPr/>
-          <p:nvPr/>
-        </p:nvSpPr>
-        <p:spPr>
-          <a:xfrm>
-            <a:off x="6492240" y="4910328"/>
-            <a:ext cx="4754880" cy="731520"/>
-          </a:xfrm>
-          <a:prstGeom prst="rect">
-            <a:avLst/>
-          </a:prstGeom>
-          <a:noFill/>
-          <a:ln/>
-        </p:spPr>
-        <p:txBody>
-          <a:bodyPr wrap="square" rtlCol="0" anchor="ctr"/>
-          <a:lstStyle/>
-          <a:p>
-            <a:pPr indent="0" marL="0">
-              <a:buNone/>
-            </a:pPr>
-            <a:r>
-              <a:rPr lang="en-US" sz="1400" dirty="0">
+              <a:rPr lang="en-US" sz="2000" b="1" dirty="0">
                 <a:solidFill>
                   <a:srgbClr val="E6EDF3"/>
                 </a:solidFill>
@@ -2068,7 +2308,46 @@
                 <a:ea typeface="Helvetica" pitchFamily="34" charset="-122"/>
                 <a:cs typeface="Helvetica" pitchFamily="34" charset="-120"/>
               </a:rPr>
-              <a:t>Org policy, content exclusion, and security shift-left.</a:t>
+              <a:t>Live demo</a:t>
+            </a:r>
+            <a:endParaRPr lang="en-US" sz="2000" dirty="0"/>
+          </a:p>
+        </p:txBody>
+      </p:sp>
+      <p:sp>
+        <p:nvSpPr>
+          <p:cNvPr id="21" name="Text 19"/>
+          <p:cNvSpPr/>
+          <p:nvPr/>
+        </p:nvSpPr>
+        <p:spPr>
+          <a:xfrm>
+            <a:off x="1920240" y="5577840"/>
+            <a:ext cx="9601200" cy="365760"/>
+          </a:xfrm>
+          <a:prstGeom prst="rect">
+            <a:avLst/>
+          </a:prstGeom>
+          <a:noFill/>
+          <a:ln/>
+        </p:spPr>
+        <p:txBody>
+          <a:bodyPr wrap="square" rtlCol="0" anchor="ctr"/>
+          <a:lstStyle/>
+          <a:p>
+            <a:pPr indent="0" marL="0">
+              <a:buNone/>
+            </a:pPr>
+            <a:r>
+              <a:rPr lang="en-US" sz="1400" dirty="0">
+                <a:solidFill>
+                  <a:srgbClr val="8B949E"/>
+                </a:solidFill>
+                <a:latin typeface="Helvetica" pitchFamily="34" charset="0"/>
+                <a:ea typeface="Helvetica" pitchFamily="34" charset="-122"/>
+                <a:cs typeface="Helvetica" pitchFamily="34" charset="-120"/>
+              </a:rPr>
+              <a:t>Generate a workflow with an agent, push it, watch it run.</a:t>
             </a:r>
             <a:endParaRPr lang="en-US" sz="1400" dirty="0"/>
           </a:p>
@@ -2085,6 +2364,3309 @@
 <file path=ppt/slides/slide3.xml><?xml version="1.0" encoding="utf-8"?>
 <p:sld xmlns:a="http://schemas.openxmlformats.org/drawingml/2006/main" xmlns:r="http://schemas.openxmlformats.org/officeDocument/2006/relationships" xmlns:p="http://schemas.openxmlformats.org/presentationml/2006/main">
   <p:cSld name="Slide 3">
+    <p:bg>
+      <p:bgPr>
+        <a:solidFill>
+          <a:srgbClr val="0D1117"/>
+        </a:solidFill>
+      </p:bgPr>
+    </p:bg>
+    <p:spTree>
+      <p:nvGrpSpPr>
+        <p:cNvPr id="1" name=""/>
+        <p:cNvGrpSpPr/>
+        <p:nvPr/>
+      </p:nvGrpSpPr>
+      <p:grpSpPr>
+        <a:xfrm>
+          <a:off x="0" y="0"/>
+          <a:ext cx="0" cy="0"/>
+          <a:chOff x="0" y="0"/>
+          <a:chExt cx="0" cy="0"/>
+        </a:xfrm>
+      </p:grpSpPr>
+      <p:sp>
+        <p:nvSpPr>
+          <p:cNvPr id="2" name="Shape 0"/>
+          <p:cNvSpPr/>
+          <p:nvPr/>
+        </p:nvSpPr>
+        <p:spPr>
+          <a:xfrm>
+            <a:off x="0" y="0"/>
+            <a:ext cx="12191695" cy="109728"/>
+          </a:xfrm>
+          <a:prstGeom prst="rect">
+            <a:avLst/>
+          </a:prstGeom>
+          <a:solidFill>
+            <a:srgbClr val="A371F7"/>
+          </a:solidFill>
+          <a:ln/>
+        </p:spPr>
+      </p:sp>
+      <p:sp>
+        <p:nvSpPr>
+          <p:cNvPr id="3" name="Text 1"/>
+          <p:cNvSpPr/>
+          <p:nvPr/>
+        </p:nvSpPr>
+        <p:spPr>
+          <a:xfrm>
+            <a:off x="548640" y="6400800"/>
+            <a:ext cx="8229600" cy="274320"/>
+          </a:xfrm>
+          <a:prstGeom prst="rect">
+            <a:avLst/>
+          </a:prstGeom>
+          <a:noFill/>
+          <a:ln/>
+        </p:spPr>
+        <p:txBody>
+          <a:bodyPr wrap="square" rtlCol="0" anchor="ctr"/>
+          <a:lstStyle/>
+          <a:p>
+            <a:pPr algn="l" indent="0" marL="0">
+              <a:buNone/>
+            </a:pPr>
+            <a:r>
+              <a:rPr lang="en-US" sz="1000" dirty="0">
+                <a:solidFill>
+                  <a:srgbClr val="8B949E"/>
+                </a:solidFill>
+                <a:latin typeface="Helvetica" pitchFamily="34" charset="0"/>
+                <a:ea typeface="Helvetica" pitchFamily="34" charset="-122"/>
+                <a:cs typeface="Helvetica" pitchFamily="34" charset="-120"/>
+              </a:rPr>
+              <a:t>GitHub Copilot + GitHub Actions  ·  Live Demo</a:t>
+            </a:r>
+            <a:endParaRPr lang="en-US" sz="1000" dirty="0"/>
+          </a:p>
+        </p:txBody>
+      </p:sp>
+      <p:sp>
+        <p:nvSpPr>
+          <p:cNvPr id="4" name="Text 2"/>
+          <p:cNvSpPr/>
+          <p:nvPr/>
+        </p:nvSpPr>
+        <p:spPr>
+          <a:xfrm>
+            <a:off x="640080" y="548640"/>
+            <a:ext cx="2011680" cy="384048"/>
+          </a:xfrm>
+          <a:prstGeom prst="roundRect">
+            <a:avLst>
+              <a:gd name="adj" fmla="val 50000"/>
+            </a:avLst>
+          </a:prstGeom>
+          <a:solidFill>
+            <a:srgbClr val="A371F7"/>
+          </a:solidFill>
+          <a:ln/>
+        </p:spPr>
+        <p:txBody>
+          <a:bodyPr wrap="square" rtlCol="0" anchor="ctr"/>
+          <a:lstStyle/>
+          <a:p>
+            <a:pPr algn="ctr" indent="0" marL="0">
+              <a:buNone/>
+            </a:pPr>
+            <a:r>
+              <a:rPr lang="en-US" sz="1200" b="1" dirty="0">
+                <a:solidFill>
+                  <a:srgbClr val="0D1117"/>
+                </a:solidFill>
+                <a:latin typeface="Helvetica" pitchFamily="34" charset="0"/>
+                <a:ea typeface="Helvetica" pitchFamily="34" charset="-122"/>
+                <a:cs typeface="Helvetica" pitchFamily="34" charset="-120"/>
+              </a:rPr>
+              <a:t>COPILOT</a:t>
+            </a:r>
+            <a:endParaRPr lang="en-US" sz="1200" dirty="0"/>
+          </a:p>
+        </p:txBody>
+      </p:sp>
+      <p:sp>
+        <p:nvSpPr>
+          <p:cNvPr id="5" name="Text 3"/>
+          <p:cNvSpPr/>
+          <p:nvPr/>
+        </p:nvSpPr>
+        <p:spPr>
+          <a:xfrm>
+            <a:off x="640080" y="1051560"/>
+            <a:ext cx="10972800" cy="822960"/>
+          </a:xfrm>
+          <a:prstGeom prst="rect">
+            <a:avLst/>
+          </a:prstGeom>
+          <a:noFill/>
+          <a:ln/>
+        </p:spPr>
+        <p:txBody>
+          <a:bodyPr wrap="square" rtlCol="0" anchor="ctr"/>
+          <a:lstStyle/>
+          <a:p>
+            <a:pPr indent="0" marL="0">
+              <a:buNone/>
+            </a:pPr>
+            <a:r>
+              <a:rPr lang="en-US" sz="3600" b="1" dirty="0">
+                <a:solidFill>
+                  <a:srgbClr val="E6EDF3"/>
+                </a:solidFill>
+                <a:latin typeface="Helvetica" pitchFamily="34" charset="0"/>
+                <a:ea typeface="Helvetica" pitchFamily="34" charset="-122"/>
+                <a:cs typeface="Helvetica" pitchFamily="34" charset="-120"/>
+              </a:rPr>
+              <a:t>Your AI pair programmer</a:t>
+            </a:r>
+            <a:endParaRPr lang="en-US" sz="3600" dirty="0"/>
+          </a:p>
+        </p:txBody>
+      </p:sp>
+      <p:sp>
+        <p:nvSpPr>
+          <p:cNvPr id="6" name="Text 4"/>
+          <p:cNvSpPr/>
+          <p:nvPr/>
+        </p:nvSpPr>
+        <p:spPr>
+          <a:xfrm>
+            <a:off x="640080" y="1828800"/>
+            <a:ext cx="10972800" cy="457200"/>
+          </a:xfrm>
+          <a:prstGeom prst="rect">
+            <a:avLst/>
+          </a:prstGeom>
+          <a:noFill/>
+          <a:ln/>
+        </p:spPr>
+        <p:txBody>
+          <a:bodyPr wrap="square" rtlCol="0" anchor="ctr"/>
+          <a:lstStyle/>
+          <a:p>
+            <a:pPr indent="0" marL="0">
+              <a:buNone/>
+            </a:pPr>
+            <a:r>
+              <a:rPr lang="en-US" sz="1600" dirty="0">
+                <a:solidFill>
+                  <a:srgbClr val="8B949E"/>
+                </a:solidFill>
+                <a:latin typeface="Helvetica" pitchFamily="34" charset="0"/>
+                <a:ea typeface="Helvetica" pitchFamily="34" charset="-122"/>
+                <a:cs typeface="Helvetica" pitchFamily="34" charset="-120"/>
+              </a:rPr>
+              <a:t>Context-aware AI across the developer workflow — from the editor to the pull request.</a:t>
+            </a:r>
+            <a:endParaRPr lang="en-US" sz="1600" dirty="0"/>
+          </a:p>
+        </p:txBody>
+      </p:sp>
+      <p:sp>
+        <p:nvSpPr>
+          <p:cNvPr id="7" name="Shape 5"/>
+          <p:cNvSpPr/>
+          <p:nvPr/>
+        </p:nvSpPr>
+        <p:spPr>
+          <a:xfrm>
+            <a:off x="640080" y="2560320"/>
+            <a:ext cx="5303520" cy="1463040"/>
+          </a:xfrm>
+          <a:prstGeom prst="roundRect">
+            <a:avLst>
+              <a:gd name="adj" fmla="val 7500"/>
+            </a:avLst>
+          </a:prstGeom>
+          <a:solidFill>
+            <a:srgbClr val="161B22"/>
+          </a:solidFill>
+          <a:ln w="12700">
+            <a:solidFill>
+              <a:srgbClr val="30363D"/>
+            </a:solidFill>
+            <a:prstDash val="solid"/>
+          </a:ln>
+        </p:spPr>
+      </p:sp>
+      <p:sp>
+        <p:nvSpPr>
+          <p:cNvPr id="8" name="Text 6"/>
+          <p:cNvSpPr/>
+          <p:nvPr/>
+        </p:nvSpPr>
+        <p:spPr>
+          <a:xfrm>
+            <a:off x="914400" y="2743200"/>
+            <a:ext cx="4754880" cy="457200"/>
+          </a:xfrm>
+          <a:prstGeom prst="rect">
+            <a:avLst/>
+          </a:prstGeom>
+          <a:noFill/>
+          <a:ln/>
+        </p:spPr>
+        <p:txBody>
+          <a:bodyPr wrap="square" rtlCol="0" anchor="ctr"/>
+          <a:lstStyle/>
+          <a:p>
+            <a:pPr indent="0" marL="0">
+              <a:buNone/>
+            </a:pPr>
+            <a:r>
+              <a:rPr lang="en-US" sz="1800" b="1" dirty="0">
+                <a:solidFill>
+                  <a:srgbClr val="A371F7"/>
+                </a:solidFill>
+                <a:latin typeface="Helvetica" pitchFamily="34" charset="0"/>
+                <a:ea typeface="Helvetica" pitchFamily="34" charset="-122"/>
+                <a:cs typeface="Helvetica" pitchFamily="34" charset="-120"/>
+              </a:rPr>
+              <a:t>Code completions</a:t>
+            </a:r>
+            <a:endParaRPr lang="en-US" sz="1800" dirty="0"/>
+          </a:p>
+        </p:txBody>
+      </p:sp>
+      <p:sp>
+        <p:nvSpPr>
+          <p:cNvPr id="9" name="Text 7"/>
+          <p:cNvSpPr/>
+          <p:nvPr/>
+        </p:nvSpPr>
+        <p:spPr>
+          <a:xfrm>
+            <a:off x="914400" y="3218688"/>
+            <a:ext cx="4754880" cy="731520"/>
+          </a:xfrm>
+          <a:prstGeom prst="rect">
+            <a:avLst/>
+          </a:prstGeom>
+          <a:noFill/>
+          <a:ln/>
+        </p:spPr>
+        <p:txBody>
+          <a:bodyPr wrap="square" rtlCol="0" anchor="ctr"/>
+          <a:lstStyle/>
+          <a:p>
+            <a:pPr indent="0" marL="0">
+              <a:buNone/>
+            </a:pPr>
+            <a:r>
+              <a:rPr lang="en-US" sz="1400" dirty="0">
+                <a:solidFill>
+                  <a:srgbClr val="E6EDF3"/>
+                </a:solidFill>
+                <a:latin typeface="Helvetica" pitchFamily="34" charset="0"/>
+                <a:ea typeface="Helvetica" pitchFamily="34" charset="-122"/>
+                <a:cs typeface="Helvetica" pitchFamily="34" charset="-120"/>
+              </a:rPr>
+              <a:t>Real-time, multi-line suggestions in your IDE.</a:t>
+            </a:r>
+            <a:endParaRPr lang="en-US" sz="1400" dirty="0"/>
+          </a:p>
+        </p:txBody>
+      </p:sp>
+      <p:sp>
+        <p:nvSpPr>
+          <p:cNvPr id="10" name="Shape 8"/>
+          <p:cNvSpPr/>
+          <p:nvPr/>
+        </p:nvSpPr>
+        <p:spPr>
+          <a:xfrm>
+            <a:off x="6217920" y="2560320"/>
+            <a:ext cx="5303520" cy="1463040"/>
+          </a:xfrm>
+          <a:prstGeom prst="roundRect">
+            <a:avLst>
+              <a:gd name="adj" fmla="val 7500"/>
+            </a:avLst>
+          </a:prstGeom>
+          <a:solidFill>
+            <a:srgbClr val="161B22"/>
+          </a:solidFill>
+          <a:ln w="12700">
+            <a:solidFill>
+              <a:srgbClr val="30363D"/>
+            </a:solidFill>
+            <a:prstDash val="solid"/>
+          </a:ln>
+        </p:spPr>
+      </p:sp>
+      <p:sp>
+        <p:nvSpPr>
+          <p:cNvPr id="11" name="Text 9"/>
+          <p:cNvSpPr/>
+          <p:nvPr/>
+        </p:nvSpPr>
+        <p:spPr>
+          <a:xfrm>
+            <a:off x="6492240" y="2743200"/>
+            <a:ext cx="4754880" cy="457200"/>
+          </a:xfrm>
+          <a:prstGeom prst="rect">
+            <a:avLst/>
+          </a:prstGeom>
+          <a:noFill/>
+          <a:ln/>
+        </p:spPr>
+        <p:txBody>
+          <a:bodyPr wrap="square" rtlCol="0" anchor="ctr"/>
+          <a:lstStyle/>
+          <a:p>
+            <a:pPr indent="0" marL="0">
+              <a:buNone/>
+            </a:pPr>
+            <a:r>
+              <a:rPr lang="en-US" sz="1800" b="1" dirty="0">
+                <a:solidFill>
+                  <a:srgbClr val="A371F7"/>
+                </a:solidFill>
+                <a:latin typeface="Helvetica" pitchFamily="34" charset="0"/>
+                <a:ea typeface="Helvetica" pitchFamily="34" charset="-122"/>
+                <a:cs typeface="Helvetica" pitchFamily="34" charset="-120"/>
+              </a:rPr>
+              <a:t>Chat &amp; /commands</a:t>
+            </a:r>
+            <a:endParaRPr lang="en-US" sz="1800" dirty="0"/>
+          </a:p>
+        </p:txBody>
+      </p:sp>
+      <p:sp>
+        <p:nvSpPr>
+          <p:cNvPr id="12" name="Text 10"/>
+          <p:cNvSpPr/>
+          <p:nvPr/>
+        </p:nvSpPr>
+        <p:spPr>
+          <a:xfrm>
+            <a:off x="6492240" y="3218688"/>
+            <a:ext cx="4754880" cy="731520"/>
+          </a:xfrm>
+          <a:prstGeom prst="rect">
+            <a:avLst/>
+          </a:prstGeom>
+          <a:noFill/>
+          <a:ln/>
+        </p:spPr>
+        <p:txBody>
+          <a:bodyPr wrap="square" rtlCol="0" anchor="ctr"/>
+          <a:lstStyle/>
+          <a:p>
+            <a:pPr indent="0" marL="0">
+              <a:buNone/>
+            </a:pPr>
+            <a:r>
+              <a:rPr lang="en-US" sz="1400" dirty="0">
+                <a:solidFill>
+                  <a:srgbClr val="E6EDF3"/>
+                </a:solidFill>
+                <a:latin typeface="Helvetica" pitchFamily="34" charset="0"/>
+                <a:ea typeface="Helvetica" pitchFamily="34" charset="-122"/>
+                <a:cs typeface="Helvetica" pitchFamily="34" charset="-120"/>
+              </a:rPr>
+              <a:t>Explain, refactor, write tests, fix errors in context.</a:t>
+            </a:r>
+            <a:endParaRPr lang="en-US" sz="1400" dirty="0"/>
+          </a:p>
+        </p:txBody>
+      </p:sp>
+      <p:sp>
+        <p:nvSpPr>
+          <p:cNvPr id="13" name="Shape 11"/>
+          <p:cNvSpPr/>
+          <p:nvPr/>
+        </p:nvSpPr>
+        <p:spPr>
+          <a:xfrm>
+            <a:off x="640080" y="4251960"/>
+            <a:ext cx="5303520" cy="1463040"/>
+          </a:xfrm>
+          <a:prstGeom prst="roundRect">
+            <a:avLst>
+              <a:gd name="adj" fmla="val 7500"/>
+            </a:avLst>
+          </a:prstGeom>
+          <a:solidFill>
+            <a:srgbClr val="161B22"/>
+          </a:solidFill>
+          <a:ln w="12700">
+            <a:solidFill>
+              <a:srgbClr val="30363D"/>
+            </a:solidFill>
+            <a:prstDash val="solid"/>
+          </a:ln>
+        </p:spPr>
+      </p:sp>
+      <p:sp>
+        <p:nvSpPr>
+          <p:cNvPr id="14" name="Text 12"/>
+          <p:cNvSpPr/>
+          <p:nvPr/>
+        </p:nvSpPr>
+        <p:spPr>
+          <a:xfrm>
+            <a:off x="914400" y="4434840"/>
+            <a:ext cx="4754880" cy="457200"/>
+          </a:xfrm>
+          <a:prstGeom prst="rect">
+            <a:avLst/>
+          </a:prstGeom>
+          <a:noFill/>
+          <a:ln/>
+        </p:spPr>
+        <p:txBody>
+          <a:bodyPr wrap="square" rtlCol="0" anchor="ctr"/>
+          <a:lstStyle/>
+          <a:p>
+            <a:pPr indent="0" marL="0">
+              <a:buNone/>
+            </a:pPr>
+            <a:r>
+              <a:rPr lang="en-US" sz="1800" b="1" dirty="0">
+                <a:solidFill>
+                  <a:srgbClr val="A371F7"/>
+                </a:solidFill>
+                <a:latin typeface="Helvetica" pitchFamily="34" charset="0"/>
+                <a:ea typeface="Helvetica" pitchFamily="34" charset="-122"/>
+                <a:cs typeface="Helvetica" pitchFamily="34" charset="-120"/>
+              </a:rPr>
+              <a:t>Agents</a:t>
+            </a:r>
+            <a:endParaRPr lang="en-US" sz="1800" dirty="0"/>
+          </a:p>
+        </p:txBody>
+      </p:sp>
+      <p:sp>
+        <p:nvSpPr>
+          <p:cNvPr id="15" name="Text 13"/>
+          <p:cNvSpPr/>
+          <p:nvPr/>
+        </p:nvSpPr>
+        <p:spPr>
+          <a:xfrm>
+            <a:off x="914400" y="4910328"/>
+            <a:ext cx="4754880" cy="731520"/>
+          </a:xfrm>
+          <a:prstGeom prst="rect">
+            <a:avLst/>
+          </a:prstGeom>
+          <a:noFill/>
+          <a:ln/>
+        </p:spPr>
+        <p:txBody>
+          <a:bodyPr wrap="square" rtlCol="0" anchor="ctr"/>
+          <a:lstStyle/>
+          <a:p>
+            <a:pPr indent="0" marL="0">
+              <a:buNone/>
+            </a:pPr>
+            <a:r>
+              <a:rPr lang="en-US" sz="1400" dirty="0">
+                <a:solidFill>
+                  <a:srgbClr val="E6EDF3"/>
+                </a:solidFill>
+                <a:latin typeface="Helvetica" pitchFamily="34" charset="0"/>
+                <a:ea typeface="Helvetica" pitchFamily="34" charset="-122"/>
+                <a:cs typeface="Helvetica" pitchFamily="34" charset="-120"/>
+              </a:rPr>
+              <a:t>Delegate whole tasks — Copilot plans, edits files &amp; opens PRs.</a:t>
+            </a:r>
+            <a:endParaRPr lang="en-US" sz="1400" dirty="0"/>
+          </a:p>
+        </p:txBody>
+      </p:sp>
+      <p:sp>
+        <p:nvSpPr>
+          <p:cNvPr id="16" name="Shape 14"/>
+          <p:cNvSpPr/>
+          <p:nvPr/>
+        </p:nvSpPr>
+        <p:spPr>
+          <a:xfrm>
+            <a:off x="6217920" y="4251960"/>
+            <a:ext cx="5303520" cy="1463040"/>
+          </a:xfrm>
+          <a:prstGeom prst="roundRect">
+            <a:avLst>
+              <a:gd name="adj" fmla="val 7500"/>
+            </a:avLst>
+          </a:prstGeom>
+          <a:solidFill>
+            <a:srgbClr val="161B22"/>
+          </a:solidFill>
+          <a:ln w="12700">
+            <a:solidFill>
+              <a:srgbClr val="30363D"/>
+            </a:solidFill>
+            <a:prstDash val="solid"/>
+          </a:ln>
+        </p:spPr>
+      </p:sp>
+      <p:sp>
+        <p:nvSpPr>
+          <p:cNvPr id="17" name="Text 15"/>
+          <p:cNvSpPr/>
+          <p:nvPr/>
+        </p:nvSpPr>
+        <p:spPr>
+          <a:xfrm>
+            <a:off x="6492240" y="4434840"/>
+            <a:ext cx="4754880" cy="457200"/>
+          </a:xfrm>
+          <a:prstGeom prst="rect">
+            <a:avLst/>
+          </a:prstGeom>
+          <a:noFill/>
+          <a:ln/>
+        </p:spPr>
+        <p:txBody>
+          <a:bodyPr wrap="square" rtlCol="0" anchor="ctr"/>
+          <a:lstStyle/>
+          <a:p>
+            <a:pPr indent="0" marL="0">
+              <a:buNone/>
+            </a:pPr>
+            <a:r>
+              <a:rPr lang="en-US" sz="1800" b="1" dirty="0">
+                <a:solidFill>
+                  <a:srgbClr val="A371F7"/>
+                </a:solidFill>
+                <a:latin typeface="Helvetica" pitchFamily="34" charset="0"/>
+                <a:ea typeface="Helvetica" pitchFamily="34" charset="-122"/>
+                <a:cs typeface="Helvetica" pitchFamily="34" charset="-120"/>
+              </a:rPr>
+              <a:t>Enterprise-ready</a:t>
+            </a:r>
+            <a:endParaRPr lang="en-US" sz="1800" dirty="0"/>
+          </a:p>
+        </p:txBody>
+      </p:sp>
+      <p:sp>
+        <p:nvSpPr>
+          <p:cNvPr id="18" name="Text 16"/>
+          <p:cNvSpPr/>
+          <p:nvPr/>
+        </p:nvSpPr>
+        <p:spPr>
+          <a:xfrm>
+            <a:off x="6492240" y="4910328"/>
+            <a:ext cx="4754880" cy="731520"/>
+          </a:xfrm>
+          <a:prstGeom prst="rect">
+            <a:avLst/>
+          </a:prstGeom>
+          <a:noFill/>
+          <a:ln/>
+        </p:spPr>
+        <p:txBody>
+          <a:bodyPr wrap="square" rtlCol="0" anchor="ctr"/>
+          <a:lstStyle/>
+          <a:p>
+            <a:pPr indent="0" marL="0">
+              <a:buNone/>
+            </a:pPr>
+            <a:r>
+              <a:rPr lang="en-US" sz="1400" dirty="0">
+                <a:solidFill>
+                  <a:srgbClr val="E6EDF3"/>
+                </a:solidFill>
+                <a:latin typeface="Helvetica" pitchFamily="34" charset="0"/>
+                <a:ea typeface="Helvetica" pitchFamily="34" charset="-122"/>
+                <a:cs typeface="Helvetica" pitchFamily="34" charset="-120"/>
+              </a:rPr>
+              <a:t>Org policy, content exclusion, and security shift-left.</a:t>
+            </a:r>
+            <a:endParaRPr lang="en-US" sz="1400" dirty="0"/>
+          </a:p>
+        </p:txBody>
+      </p:sp>
+    </p:spTree>
+  </p:cSld>
+  <p:clrMapOvr>
+    <a:masterClrMapping/>
+  </p:clrMapOvr>
+</p:sld>
+</file>
+
+<file path=ppt/slides/slide4.xml><?xml version="1.0" encoding="utf-8"?>
+<p:sld xmlns:a="http://schemas.openxmlformats.org/drawingml/2006/main" xmlns:r="http://schemas.openxmlformats.org/officeDocument/2006/relationships" xmlns:p="http://schemas.openxmlformats.org/presentationml/2006/main">
+  <p:cSld name="Slide 4">
+    <p:bg>
+      <p:bgPr>
+        <a:solidFill>
+          <a:srgbClr val="0D1117"/>
+        </a:solidFill>
+      </p:bgPr>
+    </p:bg>
+    <p:spTree>
+      <p:nvGrpSpPr>
+        <p:cNvPr id="1" name=""/>
+        <p:cNvGrpSpPr/>
+        <p:nvPr/>
+      </p:nvGrpSpPr>
+      <p:grpSpPr>
+        <a:xfrm>
+          <a:off x="0" y="0"/>
+          <a:ext cx="0" cy="0"/>
+          <a:chOff x="0" y="0"/>
+          <a:chExt cx="0" cy="0"/>
+        </a:xfrm>
+      </p:grpSpPr>
+      <p:sp>
+        <p:nvSpPr>
+          <p:cNvPr id="2" name="Shape 0"/>
+          <p:cNvSpPr/>
+          <p:nvPr/>
+        </p:nvSpPr>
+        <p:spPr>
+          <a:xfrm>
+            <a:off x="0" y="0"/>
+            <a:ext cx="12191695" cy="109728"/>
+          </a:xfrm>
+          <a:prstGeom prst="rect">
+            <a:avLst/>
+          </a:prstGeom>
+          <a:solidFill>
+            <a:srgbClr val="58A6FF"/>
+          </a:solidFill>
+          <a:ln/>
+        </p:spPr>
+      </p:sp>
+      <p:sp>
+        <p:nvSpPr>
+          <p:cNvPr id="3" name="Text 1"/>
+          <p:cNvSpPr/>
+          <p:nvPr/>
+        </p:nvSpPr>
+        <p:spPr>
+          <a:xfrm>
+            <a:off x="548640" y="6400800"/>
+            <a:ext cx="8229600" cy="274320"/>
+          </a:xfrm>
+          <a:prstGeom prst="rect">
+            <a:avLst/>
+          </a:prstGeom>
+          <a:noFill/>
+          <a:ln/>
+        </p:spPr>
+        <p:txBody>
+          <a:bodyPr wrap="square" rtlCol="0" anchor="ctr"/>
+          <a:lstStyle/>
+          <a:p>
+            <a:pPr algn="l" indent="0" marL="0">
+              <a:buNone/>
+            </a:pPr>
+            <a:r>
+              <a:rPr lang="en-US" sz="1000" dirty="0">
+                <a:solidFill>
+                  <a:srgbClr val="8B949E"/>
+                </a:solidFill>
+                <a:latin typeface="Helvetica" pitchFamily="34" charset="0"/>
+                <a:ea typeface="Helvetica" pitchFamily="34" charset="-122"/>
+                <a:cs typeface="Helvetica" pitchFamily="34" charset="-120"/>
+              </a:rPr>
+              <a:t>GitHub Copilot + GitHub Actions  ·  Live Demo</a:t>
+            </a:r>
+            <a:endParaRPr lang="en-US" sz="1000" dirty="0"/>
+          </a:p>
+        </p:txBody>
+      </p:sp>
+      <p:sp>
+        <p:nvSpPr>
+          <p:cNvPr id="4" name="Text 2"/>
+          <p:cNvSpPr/>
+          <p:nvPr/>
+        </p:nvSpPr>
+        <p:spPr>
+          <a:xfrm>
+            <a:off x="640080" y="457200"/>
+            <a:ext cx="2011680" cy="384048"/>
+          </a:xfrm>
+          <a:prstGeom prst="roundRect">
+            <a:avLst>
+              <a:gd name="adj" fmla="val 50000"/>
+            </a:avLst>
+          </a:prstGeom>
+          <a:solidFill>
+            <a:srgbClr val="58A6FF"/>
+          </a:solidFill>
+          <a:ln/>
+        </p:spPr>
+        <p:txBody>
+          <a:bodyPr wrap="square" rtlCol="0" anchor="ctr"/>
+          <a:lstStyle/>
+          <a:p>
+            <a:pPr algn="ctr" indent="0" marL="0">
+              <a:buNone/>
+            </a:pPr>
+            <a:r>
+              <a:rPr lang="en-US" sz="1200" b="1" dirty="0">
+                <a:solidFill>
+                  <a:srgbClr val="0D1117"/>
+                </a:solidFill>
+                <a:latin typeface="Helvetica" pitchFamily="34" charset="0"/>
+                <a:ea typeface="Helvetica" pitchFamily="34" charset="-122"/>
+                <a:cs typeface="Helvetica" pitchFamily="34" charset="-120"/>
+              </a:rPr>
+              <a:t>PRIMITIVES</a:t>
+            </a:r>
+            <a:endParaRPr lang="en-US" sz="1200" dirty="0"/>
+          </a:p>
+        </p:txBody>
+      </p:sp>
+      <p:sp>
+        <p:nvSpPr>
+          <p:cNvPr id="5" name="Text 3"/>
+          <p:cNvSpPr/>
+          <p:nvPr/>
+        </p:nvSpPr>
+        <p:spPr>
+          <a:xfrm>
+            <a:off x="640080" y="914400"/>
+            <a:ext cx="10972800" cy="640080"/>
+          </a:xfrm>
+          <a:prstGeom prst="rect">
+            <a:avLst/>
+          </a:prstGeom>
+          <a:noFill/>
+          <a:ln/>
+        </p:spPr>
+        <p:txBody>
+          <a:bodyPr wrap="square" rtlCol="0" anchor="ctr"/>
+          <a:lstStyle/>
+          <a:p>
+            <a:pPr indent="0" marL="0">
+              <a:buNone/>
+            </a:pPr>
+            <a:r>
+              <a:rPr lang="en-US" sz="3000" b="1" dirty="0">
+                <a:solidFill>
+                  <a:srgbClr val="E6EDF3"/>
+                </a:solidFill>
+                <a:latin typeface="Helvetica" pitchFamily="34" charset="0"/>
+                <a:ea typeface="Helvetica" pitchFamily="34" charset="-122"/>
+                <a:cs typeface="Helvetica" pitchFamily="34" charset="-120"/>
+              </a:rPr>
+              <a:t>Customizing Copilot for your repo</a:t>
+            </a:r>
+            <a:endParaRPr lang="en-US" sz="3000" dirty="0"/>
+          </a:p>
+        </p:txBody>
+      </p:sp>
+      <p:graphicFrame>
+        <p:nvGraphicFramePr>
+          <p:cNvPr id="5" name="Table 0"/>
+          <p:cNvGraphicFramePr>
+            <a:graphicFrameLocks noGrp="1"/>
+          </p:cNvGraphicFramePr>
+          <p:nvPr>
+            <p:extLst>
+              <p:ext uri="{D42A27DB-BD31-4B8C-83A1-F6EECF244321}">
+                <p14:modId xmlns:p14="http://schemas.microsoft.com/office/powerpoint/2010/main" val="1579011935"/>
+              </p:ext>
+            </p:extLst>
+          </p:nvPr>
+        </p:nvGraphicFramePr>
+        <p:xfrm>
+          <a:off x="548640" y="1691640"/>
+          <a:ext cx="11064240" cy="4572000"/>
+        </p:xfrm>
+        <a:graphic>
+          <a:graphicData uri="http://schemas.openxmlformats.org/drawingml/2006/table">
+            <a:tbl>
+              <a:tblPr/>
+              <a:tblGrid>
+                <a:gridCol w="2286000"/>
+                <a:gridCol w="2194560"/>
+                <a:gridCol w="3200400"/>
+                <a:gridCol w="3383280"/>
+              </a:tblGrid>
+              <a:tr h="508000">
+                <a:tc>
+                  <a:txBody>
+                    <a:bodyPr/>
+                    <a:lstStyle/>
+                    <a:p>
+                      <a:pPr algn="l" indent="0" marL="0">
+                        <a:buNone/>
+                      </a:pPr>
+                      <a:r>
+                        <a:rPr lang="en-US" sz="1200" b="1" dirty="0">
+                          <a:solidFill>
+                            <a:srgbClr val="0D1117"/>
+                          </a:solidFill>
+                          <a:latin typeface="Helvetica" pitchFamily="34" charset="0"/>
+                          <a:ea typeface="Helvetica" pitchFamily="34" charset="-122"/>
+                          <a:cs typeface="Helvetica" pitchFamily="34" charset="-120"/>
+                        </a:rPr>
+                        <a:t>Primitive</a:t>
+                      </a:r>
+                      <a:endParaRPr lang="en-US" sz="1200" dirty="0">
+                        <a:latin typeface="Helvetica" charset="0"/>
+                        <a:ea typeface="Helvetica" charset="0"/>
+                        <a:cs typeface="Helvetica" charset="0"/>
+                      </a:endParaRPr>
+                    </a:p>
+                  </a:txBody>
+                  <a:tcPr marL="63500" marR="63500" marT="38100" marB="38100" anchor="ctr">
+                    <a:lnL w="12700" cap="flat" cmpd="sng" algn="ctr">
+                      <a:solidFill>
+                        <a:srgbClr val="30363D"/>
+                      </a:solidFill>
+                      <a:prstDash val="solid"/>
+                      <a:round/>
+                      <a:headEnd type="none" w="med" len="med"/>
+                      <a:tailEnd type="none" w="med" len="med"/>
+                    </a:lnL>
+                    <a:lnR w="12700" cap="flat" cmpd="sng" algn="ctr">
+                      <a:solidFill>
+                        <a:srgbClr val="30363D"/>
+                      </a:solidFill>
+                      <a:prstDash val="solid"/>
+                      <a:round/>
+                      <a:headEnd type="none" w="med" len="med"/>
+                      <a:tailEnd type="none" w="med" len="med"/>
+                    </a:lnR>
+                    <a:lnT w="12700" cap="flat" cmpd="sng" algn="ctr">
+                      <a:solidFill>
+                        <a:srgbClr val="30363D"/>
+                      </a:solidFill>
+                      <a:prstDash val="solid"/>
+                      <a:round/>
+                      <a:headEnd type="none" w="med" len="med"/>
+                      <a:tailEnd type="none" w="med" len="med"/>
+                    </a:lnT>
+                    <a:lnB w="12700" cap="flat" cmpd="sng" algn="ctr">
+                      <a:solidFill>
+                        <a:srgbClr val="30363D"/>
+                      </a:solidFill>
+                      <a:prstDash val="solid"/>
+                      <a:round/>
+                      <a:headEnd type="none" w="med" len="med"/>
+                      <a:tailEnd type="none" w="med" len="med"/>
+                    </a:lnB>
+                    <a:solidFill>
+                      <a:srgbClr val="58A6FF"/>
+                    </a:solidFill>
+                  </a:tcPr>
+                </a:tc>
+                <a:tc>
+                  <a:txBody>
+                    <a:bodyPr/>
+                    <a:lstStyle/>
+                    <a:p>
+                      <a:pPr algn="l" indent="0" marL="0">
+                        <a:buNone/>
+                      </a:pPr>
+                      <a:r>
+                        <a:rPr lang="en-US" sz="1200" b="1" dirty="0">
+                          <a:solidFill>
+                            <a:srgbClr val="0D1117"/>
+                          </a:solidFill>
+                          <a:latin typeface="Helvetica" pitchFamily="34" charset="0"/>
+                          <a:ea typeface="Helvetica" pitchFamily="34" charset="-122"/>
+                          <a:cs typeface="Helvetica" pitchFamily="34" charset="-120"/>
+                        </a:rPr>
+                        <a:t>Primary Job</a:t>
+                      </a:r>
+                      <a:endParaRPr lang="en-US" sz="1200" dirty="0">
+                        <a:latin typeface="Helvetica" charset="0"/>
+                        <a:ea typeface="Helvetica" charset="0"/>
+                        <a:cs typeface="Helvetica" charset="0"/>
+                      </a:endParaRPr>
+                    </a:p>
+                  </a:txBody>
+                  <a:tcPr marL="63500" marR="63500" marT="38100" marB="38100" anchor="ctr">
+                    <a:lnL w="12700" cap="flat" cmpd="sng" algn="ctr">
+                      <a:solidFill>
+                        <a:srgbClr val="30363D"/>
+                      </a:solidFill>
+                      <a:prstDash val="solid"/>
+                      <a:round/>
+                      <a:headEnd type="none" w="med" len="med"/>
+                      <a:tailEnd type="none" w="med" len="med"/>
+                    </a:lnL>
+                    <a:lnR w="12700" cap="flat" cmpd="sng" algn="ctr">
+                      <a:solidFill>
+                        <a:srgbClr val="30363D"/>
+                      </a:solidFill>
+                      <a:prstDash val="solid"/>
+                      <a:round/>
+                      <a:headEnd type="none" w="med" len="med"/>
+                      <a:tailEnd type="none" w="med" len="med"/>
+                    </a:lnR>
+                    <a:lnT w="12700" cap="flat" cmpd="sng" algn="ctr">
+                      <a:solidFill>
+                        <a:srgbClr val="30363D"/>
+                      </a:solidFill>
+                      <a:prstDash val="solid"/>
+                      <a:round/>
+                      <a:headEnd type="none" w="med" len="med"/>
+                      <a:tailEnd type="none" w="med" len="med"/>
+                    </a:lnT>
+                    <a:lnB w="12700" cap="flat" cmpd="sng" algn="ctr">
+                      <a:solidFill>
+                        <a:srgbClr val="30363D"/>
+                      </a:solidFill>
+                      <a:prstDash val="solid"/>
+                      <a:round/>
+                      <a:headEnd type="none" w="med" len="med"/>
+                      <a:tailEnd type="none" w="med" len="med"/>
+                    </a:lnB>
+                    <a:solidFill>
+                      <a:srgbClr val="58A6FF"/>
+                    </a:solidFill>
+                  </a:tcPr>
+                </a:tc>
+                <a:tc>
+                  <a:txBody>
+                    <a:bodyPr/>
+                    <a:lstStyle/>
+                    <a:p>
+                      <a:pPr algn="l" indent="0" marL="0">
+                        <a:buNone/>
+                      </a:pPr>
+                      <a:r>
+                        <a:rPr lang="en-US" sz="1200" b="1" dirty="0">
+                          <a:solidFill>
+                            <a:srgbClr val="0D1117"/>
+                          </a:solidFill>
+                          <a:latin typeface="Helvetica" pitchFamily="34" charset="0"/>
+                          <a:ea typeface="Helvetica" pitchFamily="34" charset="-122"/>
+                          <a:cs typeface="Helvetica" pitchFamily="34" charset="-120"/>
+                        </a:rPr>
+                        <a:t>Where It Enters the Loop</a:t>
+                      </a:r>
+                      <a:endParaRPr lang="en-US" sz="1200" dirty="0">
+                        <a:latin typeface="Helvetica" charset="0"/>
+                        <a:ea typeface="Helvetica" charset="0"/>
+                        <a:cs typeface="Helvetica" charset="0"/>
+                      </a:endParaRPr>
+                    </a:p>
+                  </a:txBody>
+                  <a:tcPr marL="63500" marR="63500" marT="38100" marB="38100" anchor="ctr">
+                    <a:lnL w="12700" cap="flat" cmpd="sng" algn="ctr">
+                      <a:solidFill>
+                        <a:srgbClr val="30363D"/>
+                      </a:solidFill>
+                      <a:prstDash val="solid"/>
+                      <a:round/>
+                      <a:headEnd type="none" w="med" len="med"/>
+                      <a:tailEnd type="none" w="med" len="med"/>
+                    </a:lnL>
+                    <a:lnR w="12700" cap="flat" cmpd="sng" algn="ctr">
+                      <a:solidFill>
+                        <a:srgbClr val="30363D"/>
+                      </a:solidFill>
+                      <a:prstDash val="solid"/>
+                      <a:round/>
+                      <a:headEnd type="none" w="med" len="med"/>
+                      <a:tailEnd type="none" w="med" len="med"/>
+                    </a:lnR>
+                    <a:lnT w="12700" cap="flat" cmpd="sng" algn="ctr">
+                      <a:solidFill>
+                        <a:srgbClr val="30363D"/>
+                      </a:solidFill>
+                      <a:prstDash val="solid"/>
+                      <a:round/>
+                      <a:headEnd type="none" w="med" len="med"/>
+                      <a:tailEnd type="none" w="med" len="med"/>
+                    </a:lnT>
+                    <a:lnB w="12700" cap="flat" cmpd="sng" algn="ctr">
+                      <a:solidFill>
+                        <a:srgbClr val="30363D"/>
+                      </a:solidFill>
+                      <a:prstDash val="solid"/>
+                      <a:round/>
+                      <a:headEnd type="none" w="med" len="med"/>
+                      <a:tailEnd type="none" w="med" len="med"/>
+                    </a:lnB>
+                    <a:solidFill>
+                      <a:srgbClr val="58A6FF"/>
+                    </a:solidFill>
+                  </a:tcPr>
+                </a:tc>
+                <a:tc>
+                  <a:txBody>
+                    <a:bodyPr/>
+                    <a:lstStyle/>
+                    <a:p>
+                      <a:pPr algn="l" indent="0" marL="0">
+                        <a:buNone/>
+                      </a:pPr>
+                      <a:r>
+                        <a:rPr lang="en-US" sz="1200" b="1" dirty="0">
+                          <a:solidFill>
+                            <a:srgbClr val="0D1117"/>
+                          </a:solidFill>
+                          <a:latin typeface="Helvetica" pitchFamily="34" charset="0"/>
+                          <a:ea typeface="Helvetica" pitchFamily="34" charset="-122"/>
+                          <a:cs typeface="Helvetica" pitchFamily="34" charset="-120"/>
+                        </a:rPr>
+                        <a:t>Best Used For</a:t>
+                      </a:r>
+                      <a:endParaRPr lang="en-US" sz="1200" dirty="0">
+                        <a:latin typeface="Helvetica" charset="0"/>
+                        <a:ea typeface="Helvetica" charset="0"/>
+                        <a:cs typeface="Helvetica" charset="0"/>
+                      </a:endParaRPr>
+                    </a:p>
+                  </a:txBody>
+                  <a:tcPr marL="63500" marR="63500" marT="38100" marB="38100" anchor="ctr">
+                    <a:lnL w="12700" cap="flat" cmpd="sng" algn="ctr">
+                      <a:solidFill>
+                        <a:srgbClr val="30363D"/>
+                      </a:solidFill>
+                      <a:prstDash val="solid"/>
+                      <a:round/>
+                      <a:headEnd type="none" w="med" len="med"/>
+                      <a:tailEnd type="none" w="med" len="med"/>
+                    </a:lnL>
+                    <a:lnR w="12700" cap="flat" cmpd="sng" algn="ctr">
+                      <a:solidFill>
+                        <a:srgbClr val="30363D"/>
+                      </a:solidFill>
+                      <a:prstDash val="solid"/>
+                      <a:round/>
+                      <a:headEnd type="none" w="med" len="med"/>
+                      <a:tailEnd type="none" w="med" len="med"/>
+                    </a:lnR>
+                    <a:lnT w="12700" cap="flat" cmpd="sng" algn="ctr">
+                      <a:solidFill>
+                        <a:srgbClr val="30363D"/>
+                      </a:solidFill>
+                      <a:prstDash val="solid"/>
+                      <a:round/>
+                      <a:headEnd type="none" w="med" len="med"/>
+                      <a:tailEnd type="none" w="med" len="med"/>
+                    </a:lnT>
+                    <a:lnB w="12700" cap="flat" cmpd="sng" algn="ctr">
+                      <a:solidFill>
+                        <a:srgbClr val="30363D"/>
+                      </a:solidFill>
+                      <a:prstDash val="solid"/>
+                      <a:round/>
+                      <a:headEnd type="none" w="med" len="med"/>
+                      <a:tailEnd type="none" w="med" len="med"/>
+                    </a:lnB>
+                    <a:solidFill>
+                      <a:srgbClr val="58A6FF"/>
+                    </a:solidFill>
+                  </a:tcPr>
+                </a:tc>
+              </a:tr>
+              <a:tr h="508000">
+                <a:tc>
+                  <a:txBody>
+                    <a:bodyPr/>
+                    <a:lstStyle/>
+                    <a:p>
+                      <a:pPr algn="l" indent="0" marL="0">
+                        <a:buNone/>
+                      </a:pPr>
+                      <a:r>
+                        <a:rPr lang="en-US" sz="1100" b="1" dirty="0">
+                          <a:solidFill>
+                            <a:srgbClr val="58A6FF"/>
+                          </a:solidFill>
+                          <a:latin typeface="Helvetica" pitchFamily="34" charset="0"/>
+                          <a:ea typeface="Helvetica" pitchFamily="34" charset="-122"/>
+                          <a:cs typeface="Helvetica" pitchFamily="34" charset="-120"/>
+                        </a:rPr>
+                        <a:t>Always-on Instructions</a:t>
+                      </a:r>
+                      <a:endParaRPr lang="en-US" sz="1100" dirty="0">
+                        <a:latin typeface="Helvetica" charset="0"/>
+                        <a:ea typeface="Helvetica" charset="0"/>
+                        <a:cs typeface="Helvetica" charset="0"/>
+                      </a:endParaRPr>
+                    </a:p>
+                  </a:txBody>
+                  <a:tcPr marL="63500" marR="63500" marT="38100" marB="38100" anchor="ctr">
+                    <a:lnL w="12700" cap="flat" cmpd="sng" algn="ctr">
+                      <a:solidFill>
+                        <a:srgbClr val="30363D"/>
+                      </a:solidFill>
+                      <a:prstDash val="solid"/>
+                      <a:round/>
+                      <a:headEnd type="none" w="med" len="med"/>
+                      <a:tailEnd type="none" w="med" len="med"/>
+                    </a:lnL>
+                    <a:lnR w="12700" cap="flat" cmpd="sng" algn="ctr">
+                      <a:solidFill>
+                        <a:srgbClr val="30363D"/>
+                      </a:solidFill>
+                      <a:prstDash val="solid"/>
+                      <a:round/>
+                      <a:headEnd type="none" w="med" len="med"/>
+                      <a:tailEnd type="none" w="med" len="med"/>
+                    </a:lnR>
+                    <a:lnT w="12700" cap="flat" cmpd="sng" algn="ctr">
+                      <a:solidFill>
+                        <a:srgbClr val="30363D"/>
+                      </a:solidFill>
+                      <a:prstDash val="solid"/>
+                      <a:round/>
+                      <a:headEnd type="none" w="med" len="med"/>
+                      <a:tailEnd type="none" w="med" len="med"/>
+                    </a:lnT>
+                    <a:lnB w="12700" cap="flat" cmpd="sng" algn="ctr">
+                      <a:solidFill>
+                        <a:srgbClr val="30363D"/>
+                      </a:solidFill>
+                      <a:prstDash val="solid"/>
+                      <a:round/>
+                      <a:headEnd type="none" w="med" len="med"/>
+                      <a:tailEnd type="none" w="med" len="med"/>
+                    </a:lnB>
+                    <a:solidFill>
+                      <a:srgbClr val="161B22"/>
+                    </a:solidFill>
+                  </a:tcPr>
+                </a:tc>
+                <a:tc>
+                  <a:txBody>
+                    <a:bodyPr/>
+                    <a:lstStyle/>
+                    <a:p>
+                      <a:pPr algn="l" indent="0" marL="0">
+                        <a:buNone/>
+                      </a:pPr>
+                      <a:r>
+                        <a:rPr lang="en-US" sz="1100" dirty="0">
+                          <a:solidFill>
+                            <a:srgbClr val="E6EDF3"/>
+                          </a:solidFill>
+                          <a:latin typeface="Helvetica" pitchFamily="34" charset="0"/>
+                          <a:ea typeface="Helvetica" pitchFamily="34" charset="-122"/>
+                          <a:cs typeface="Helvetica" pitchFamily="34" charset="-120"/>
+                        </a:rPr>
+                        <a:t>Base defaults</a:t>
+                      </a:r>
+                      <a:endParaRPr lang="en-US" sz="1100" dirty="0">
+                        <a:latin typeface="Helvetica" charset="0"/>
+                        <a:ea typeface="Helvetica" charset="0"/>
+                        <a:cs typeface="Helvetica" charset="0"/>
+                      </a:endParaRPr>
+                    </a:p>
+                  </a:txBody>
+                  <a:tcPr marL="63500" marR="63500" marT="38100" marB="38100" anchor="ctr">
+                    <a:lnL w="12700" cap="flat" cmpd="sng" algn="ctr">
+                      <a:solidFill>
+                        <a:srgbClr val="30363D"/>
+                      </a:solidFill>
+                      <a:prstDash val="solid"/>
+                      <a:round/>
+                      <a:headEnd type="none" w="med" len="med"/>
+                      <a:tailEnd type="none" w="med" len="med"/>
+                    </a:lnL>
+                    <a:lnR w="12700" cap="flat" cmpd="sng" algn="ctr">
+                      <a:solidFill>
+                        <a:srgbClr val="30363D"/>
+                      </a:solidFill>
+                      <a:prstDash val="solid"/>
+                      <a:round/>
+                      <a:headEnd type="none" w="med" len="med"/>
+                      <a:tailEnd type="none" w="med" len="med"/>
+                    </a:lnR>
+                    <a:lnT w="12700" cap="flat" cmpd="sng" algn="ctr">
+                      <a:solidFill>
+                        <a:srgbClr val="30363D"/>
+                      </a:solidFill>
+                      <a:prstDash val="solid"/>
+                      <a:round/>
+                      <a:headEnd type="none" w="med" len="med"/>
+                      <a:tailEnd type="none" w="med" len="med"/>
+                    </a:lnT>
+                    <a:lnB w="12700" cap="flat" cmpd="sng" algn="ctr">
+                      <a:solidFill>
+                        <a:srgbClr val="30363D"/>
+                      </a:solidFill>
+                      <a:prstDash val="solid"/>
+                      <a:round/>
+                      <a:headEnd type="none" w="med" len="med"/>
+                      <a:tailEnd type="none" w="med" len="med"/>
+                    </a:lnB>
+                    <a:solidFill>
+                      <a:srgbClr val="161B22"/>
+                    </a:solidFill>
+                  </a:tcPr>
+                </a:tc>
+                <a:tc>
+                  <a:txBody>
+                    <a:bodyPr/>
+                    <a:lstStyle/>
+                    <a:p>
+                      <a:pPr algn="l" indent="0" marL="0">
+                        <a:buNone/>
+                      </a:pPr>
+                      <a:r>
+                        <a:rPr lang="en-US" sz="1100" dirty="0">
+                          <a:solidFill>
+                            <a:srgbClr val="E6EDF3"/>
+                          </a:solidFill>
+                          <a:latin typeface="Helvetica" pitchFamily="34" charset="0"/>
+                          <a:ea typeface="Helvetica" pitchFamily="34" charset="-122"/>
+                          <a:cs typeface="Helvetica" pitchFamily="34" charset="-120"/>
+                        </a:rPr>
+                        <a:t>Context assembly</a:t>
+                      </a:r>
+                      <a:endParaRPr lang="en-US" sz="1100" dirty="0">
+                        <a:latin typeface="Helvetica" charset="0"/>
+                        <a:ea typeface="Helvetica" charset="0"/>
+                        <a:cs typeface="Helvetica" charset="0"/>
+                      </a:endParaRPr>
+                    </a:p>
+                  </a:txBody>
+                  <a:tcPr marL="63500" marR="63500" marT="38100" marB="38100" anchor="ctr">
+                    <a:lnL w="12700" cap="flat" cmpd="sng" algn="ctr">
+                      <a:solidFill>
+                        <a:srgbClr val="30363D"/>
+                      </a:solidFill>
+                      <a:prstDash val="solid"/>
+                      <a:round/>
+                      <a:headEnd type="none" w="med" len="med"/>
+                      <a:tailEnd type="none" w="med" len="med"/>
+                    </a:lnL>
+                    <a:lnR w="12700" cap="flat" cmpd="sng" algn="ctr">
+                      <a:solidFill>
+                        <a:srgbClr val="30363D"/>
+                      </a:solidFill>
+                      <a:prstDash val="solid"/>
+                      <a:round/>
+                      <a:headEnd type="none" w="med" len="med"/>
+                      <a:tailEnd type="none" w="med" len="med"/>
+                    </a:lnR>
+                    <a:lnT w="12700" cap="flat" cmpd="sng" algn="ctr">
+                      <a:solidFill>
+                        <a:srgbClr val="30363D"/>
+                      </a:solidFill>
+                      <a:prstDash val="solid"/>
+                      <a:round/>
+                      <a:headEnd type="none" w="med" len="med"/>
+                      <a:tailEnd type="none" w="med" len="med"/>
+                    </a:lnT>
+                    <a:lnB w="12700" cap="flat" cmpd="sng" algn="ctr">
+                      <a:solidFill>
+                        <a:srgbClr val="30363D"/>
+                      </a:solidFill>
+                      <a:prstDash val="solid"/>
+                      <a:round/>
+                      <a:headEnd type="none" w="med" len="med"/>
+                      <a:tailEnd type="none" w="med" len="med"/>
+                    </a:lnB>
+                    <a:solidFill>
+                      <a:srgbClr val="161B22"/>
+                    </a:solidFill>
+                  </a:tcPr>
+                </a:tc>
+                <a:tc>
+                  <a:txBody>
+                    <a:bodyPr/>
+                    <a:lstStyle/>
+                    <a:p>
+                      <a:pPr algn="l" indent="0" marL="0">
+                        <a:buNone/>
+                      </a:pPr>
+                      <a:r>
+                        <a:rPr lang="en-US" sz="1100" dirty="0">
+                          <a:solidFill>
+                            <a:srgbClr val="E6EDF3"/>
+                          </a:solidFill>
+                          <a:latin typeface="Helvetica" pitchFamily="34" charset="0"/>
+                          <a:ea typeface="Helvetica" pitchFamily="34" charset="-122"/>
+                          <a:cs typeface="Helvetica" pitchFamily="34" charset="-120"/>
+                        </a:rPr>
+                        <a:t>Team-wide conventions and stack choices</a:t>
+                      </a:r>
+                      <a:endParaRPr lang="en-US" sz="1100" dirty="0">
+                        <a:latin typeface="Helvetica" charset="0"/>
+                        <a:ea typeface="Helvetica" charset="0"/>
+                        <a:cs typeface="Helvetica" charset="0"/>
+                      </a:endParaRPr>
+                    </a:p>
+                  </a:txBody>
+                  <a:tcPr marL="63500" marR="63500" marT="38100" marB="38100" anchor="ctr">
+                    <a:lnL w="12700" cap="flat" cmpd="sng" algn="ctr">
+                      <a:solidFill>
+                        <a:srgbClr val="30363D"/>
+                      </a:solidFill>
+                      <a:prstDash val="solid"/>
+                      <a:round/>
+                      <a:headEnd type="none" w="med" len="med"/>
+                      <a:tailEnd type="none" w="med" len="med"/>
+                    </a:lnL>
+                    <a:lnR w="12700" cap="flat" cmpd="sng" algn="ctr">
+                      <a:solidFill>
+                        <a:srgbClr val="30363D"/>
+                      </a:solidFill>
+                      <a:prstDash val="solid"/>
+                      <a:round/>
+                      <a:headEnd type="none" w="med" len="med"/>
+                      <a:tailEnd type="none" w="med" len="med"/>
+                    </a:lnR>
+                    <a:lnT w="12700" cap="flat" cmpd="sng" algn="ctr">
+                      <a:solidFill>
+                        <a:srgbClr val="30363D"/>
+                      </a:solidFill>
+                      <a:prstDash val="solid"/>
+                      <a:round/>
+                      <a:headEnd type="none" w="med" len="med"/>
+                      <a:tailEnd type="none" w="med" len="med"/>
+                    </a:lnT>
+                    <a:lnB w="12700" cap="flat" cmpd="sng" algn="ctr">
+                      <a:solidFill>
+                        <a:srgbClr val="30363D"/>
+                      </a:solidFill>
+                      <a:prstDash val="solid"/>
+                      <a:round/>
+                      <a:headEnd type="none" w="med" len="med"/>
+                      <a:tailEnd type="none" w="med" len="med"/>
+                    </a:lnB>
+                    <a:solidFill>
+                      <a:srgbClr val="161B22"/>
+                    </a:solidFill>
+                  </a:tcPr>
+                </a:tc>
+              </a:tr>
+              <a:tr h="508000">
+                <a:tc>
+                  <a:txBody>
+                    <a:bodyPr/>
+                    <a:lstStyle/>
+                    <a:p>
+                      <a:pPr algn="l" indent="0" marL="0">
+                        <a:buNone/>
+                      </a:pPr>
+                      <a:r>
+                        <a:rPr lang="en-US" sz="1100" b="1" dirty="0">
+                          <a:solidFill>
+                            <a:srgbClr val="58A6FF"/>
+                          </a:solidFill>
+                          <a:latin typeface="Helvetica" pitchFamily="34" charset="0"/>
+                          <a:ea typeface="Helvetica" pitchFamily="34" charset="-122"/>
+                          <a:cs typeface="Helvetica" pitchFamily="34" charset="-120"/>
+                        </a:rPr>
+                        <a:t>File-based Instructions</a:t>
+                      </a:r>
+                      <a:endParaRPr lang="en-US" sz="1100" dirty="0">
+                        <a:latin typeface="Helvetica" charset="0"/>
+                        <a:ea typeface="Helvetica" charset="0"/>
+                        <a:cs typeface="Helvetica" charset="0"/>
+                      </a:endParaRPr>
+                    </a:p>
+                  </a:txBody>
+                  <a:tcPr marL="63500" marR="63500" marT="38100" marB="38100" anchor="ctr">
+                    <a:lnL w="12700" cap="flat" cmpd="sng" algn="ctr">
+                      <a:solidFill>
+                        <a:srgbClr val="30363D"/>
+                      </a:solidFill>
+                      <a:prstDash val="solid"/>
+                      <a:round/>
+                      <a:headEnd type="none" w="med" len="med"/>
+                      <a:tailEnd type="none" w="med" len="med"/>
+                    </a:lnL>
+                    <a:lnR w="12700" cap="flat" cmpd="sng" algn="ctr">
+                      <a:solidFill>
+                        <a:srgbClr val="30363D"/>
+                      </a:solidFill>
+                      <a:prstDash val="solid"/>
+                      <a:round/>
+                      <a:headEnd type="none" w="med" len="med"/>
+                      <a:tailEnd type="none" w="med" len="med"/>
+                    </a:lnR>
+                    <a:lnT w="12700" cap="flat" cmpd="sng" algn="ctr">
+                      <a:solidFill>
+                        <a:srgbClr val="30363D"/>
+                      </a:solidFill>
+                      <a:prstDash val="solid"/>
+                      <a:round/>
+                      <a:headEnd type="none" w="med" len="med"/>
+                      <a:tailEnd type="none" w="med" len="med"/>
+                    </a:lnT>
+                    <a:lnB w="12700" cap="flat" cmpd="sng" algn="ctr">
+                      <a:solidFill>
+                        <a:srgbClr val="30363D"/>
+                      </a:solidFill>
+                      <a:prstDash val="solid"/>
+                      <a:round/>
+                      <a:headEnd type="none" w="med" len="med"/>
+                      <a:tailEnd type="none" w="med" len="med"/>
+                    </a:lnB>
+                    <a:solidFill>
+                      <a:srgbClr val="0D1117"/>
+                    </a:solidFill>
+                  </a:tcPr>
+                </a:tc>
+                <a:tc>
+                  <a:txBody>
+                    <a:bodyPr/>
+                    <a:lstStyle/>
+                    <a:p>
+                      <a:pPr algn="l" indent="0" marL="0">
+                        <a:buNone/>
+                      </a:pPr>
+                      <a:r>
+                        <a:rPr lang="en-US" sz="1100" dirty="0">
+                          <a:solidFill>
+                            <a:srgbClr val="E6EDF3"/>
+                          </a:solidFill>
+                          <a:latin typeface="Helvetica" pitchFamily="34" charset="0"/>
+                          <a:ea typeface="Helvetica" pitchFamily="34" charset="-122"/>
+                          <a:cs typeface="Helvetica" pitchFamily="34" charset="-120"/>
+                        </a:rPr>
+                        <a:t>Scoped defaults</a:t>
+                      </a:r>
+                      <a:endParaRPr lang="en-US" sz="1100" dirty="0">
+                        <a:latin typeface="Helvetica" charset="0"/>
+                        <a:ea typeface="Helvetica" charset="0"/>
+                        <a:cs typeface="Helvetica" charset="0"/>
+                      </a:endParaRPr>
+                    </a:p>
+                  </a:txBody>
+                  <a:tcPr marL="63500" marR="63500" marT="38100" marB="38100" anchor="ctr">
+                    <a:lnL w="12700" cap="flat" cmpd="sng" algn="ctr">
+                      <a:solidFill>
+                        <a:srgbClr val="30363D"/>
+                      </a:solidFill>
+                      <a:prstDash val="solid"/>
+                      <a:round/>
+                      <a:headEnd type="none" w="med" len="med"/>
+                      <a:tailEnd type="none" w="med" len="med"/>
+                    </a:lnL>
+                    <a:lnR w="12700" cap="flat" cmpd="sng" algn="ctr">
+                      <a:solidFill>
+                        <a:srgbClr val="30363D"/>
+                      </a:solidFill>
+                      <a:prstDash val="solid"/>
+                      <a:round/>
+                      <a:headEnd type="none" w="med" len="med"/>
+                      <a:tailEnd type="none" w="med" len="med"/>
+                    </a:lnR>
+                    <a:lnT w="12700" cap="flat" cmpd="sng" algn="ctr">
+                      <a:solidFill>
+                        <a:srgbClr val="30363D"/>
+                      </a:solidFill>
+                      <a:prstDash val="solid"/>
+                      <a:round/>
+                      <a:headEnd type="none" w="med" len="med"/>
+                      <a:tailEnd type="none" w="med" len="med"/>
+                    </a:lnT>
+                    <a:lnB w="12700" cap="flat" cmpd="sng" algn="ctr">
+                      <a:solidFill>
+                        <a:srgbClr val="30363D"/>
+                      </a:solidFill>
+                      <a:prstDash val="solid"/>
+                      <a:round/>
+                      <a:headEnd type="none" w="med" len="med"/>
+                      <a:tailEnd type="none" w="med" len="med"/>
+                    </a:lnB>
+                    <a:solidFill>
+                      <a:srgbClr val="0D1117"/>
+                    </a:solidFill>
+                  </a:tcPr>
+                </a:tc>
+                <a:tc>
+                  <a:txBody>
+                    <a:bodyPr/>
+                    <a:lstStyle/>
+                    <a:p>
+                      <a:pPr algn="l" indent="0" marL="0">
+                        <a:buNone/>
+                      </a:pPr>
+                      <a:r>
+                        <a:rPr lang="en-US" sz="1100" dirty="0">
+                          <a:solidFill>
+                            <a:srgbClr val="E6EDF3"/>
+                          </a:solidFill>
+                          <a:latin typeface="Helvetica" pitchFamily="34" charset="0"/>
+                          <a:ea typeface="Helvetica" pitchFamily="34" charset="-122"/>
+                          <a:cs typeface="Helvetica" pitchFamily="34" charset="-120"/>
+                        </a:rPr>
+                        <a:t>Context assembly for matching files</a:t>
+                      </a:r>
+                      <a:endParaRPr lang="en-US" sz="1100" dirty="0">
+                        <a:latin typeface="Helvetica" charset="0"/>
+                        <a:ea typeface="Helvetica" charset="0"/>
+                        <a:cs typeface="Helvetica" charset="0"/>
+                      </a:endParaRPr>
+                    </a:p>
+                  </a:txBody>
+                  <a:tcPr marL="63500" marR="63500" marT="38100" marB="38100" anchor="ctr">
+                    <a:lnL w="12700" cap="flat" cmpd="sng" algn="ctr">
+                      <a:solidFill>
+                        <a:srgbClr val="30363D"/>
+                      </a:solidFill>
+                      <a:prstDash val="solid"/>
+                      <a:round/>
+                      <a:headEnd type="none" w="med" len="med"/>
+                      <a:tailEnd type="none" w="med" len="med"/>
+                    </a:lnL>
+                    <a:lnR w="12700" cap="flat" cmpd="sng" algn="ctr">
+                      <a:solidFill>
+                        <a:srgbClr val="30363D"/>
+                      </a:solidFill>
+                      <a:prstDash val="solid"/>
+                      <a:round/>
+                      <a:headEnd type="none" w="med" len="med"/>
+                      <a:tailEnd type="none" w="med" len="med"/>
+                    </a:lnR>
+                    <a:lnT w="12700" cap="flat" cmpd="sng" algn="ctr">
+                      <a:solidFill>
+                        <a:srgbClr val="30363D"/>
+                      </a:solidFill>
+                      <a:prstDash val="solid"/>
+                      <a:round/>
+                      <a:headEnd type="none" w="med" len="med"/>
+                      <a:tailEnd type="none" w="med" len="med"/>
+                    </a:lnT>
+                    <a:lnB w="12700" cap="flat" cmpd="sng" algn="ctr">
+                      <a:solidFill>
+                        <a:srgbClr val="30363D"/>
+                      </a:solidFill>
+                      <a:prstDash val="solid"/>
+                      <a:round/>
+                      <a:headEnd type="none" w="med" len="med"/>
+                      <a:tailEnd type="none" w="med" len="med"/>
+                    </a:lnB>
+                    <a:solidFill>
+                      <a:srgbClr val="0D1117"/>
+                    </a:solidFill>
+                  </a:tcPr>
+                </a:tc>
+                <a:tc>
+                  <a:txBody>
+                    <a:bodyPr/>
+                    <a:lstStyle/>
+                    <a:p>
+                      <a:pPr algn="l" indent="0" marL="0">
+                        <a:buNone/>
+                      </a:pPr>
+                      <a:r>
+                        <a:rPr lang="en-US" sz="1100" dirty="0">
+                          <a:solidFill>
+                            <a:srgbClr val="E6EDF3"/>
+                          </a:solidFill>
+                          <a:latin typeface="Helvetica" pitchFamily="34" charset="0"/>
+                          <a:ea typeface="Helvetica" pitchFamily="34" charset="-122"/>
+                          <a:cs typeface="Helvetica" pitchFamily="34" charset="-120"/>
+                        </a:rPr>
+                        <a:t>Path-specific rules</a:t>
+                      </a:r>
+                      <a:endParaRPr lang="en-US" sz="1100" dirty="0">
+                        <a:latin typeface="Helvetica" charset="0"/>
+                        <a:ea typeface="Helvetica" charset="0"/>
+                        <a:cs typeface="Helvetica" charset="0"/>
+                      </a:endParaRPr>
+                    </a:p>
+                  </a:txBody>
+                  <a:tcPr marL="63500" marR="63500" marT="38100" marB="38100" anchor="ctr">
+                    <a:lnL w="12700" cap="flat" cmpd="sng" algn="ctr">
+                      <a:solidFill>
+                        <a:srgbClr val="30363D"/>
+                      </a:solidFill>
+                      <a:prstDash val="solid"/>
+                      <a:round/>
+                      <a:headEnd type="none" w="med" len="med"/>
+                      <a:tailEnd type="none" w="med" len="med"/>
+                    </a:lnL>
+                    <a:lnR w="12700" cap="flat" cmpd="sng" algn="ctr">
+                      <a:solidFill>
+                        <a:srgbClr val="30363D"/>
+                      </a:solidFill>
+                      <a:prstDash val="solid"/>
+                      <a:round/>
+                      <a:headEnd type="none" w="med" len="med"/>
+                      <a:tailEnd type="none" w="med" len="med"/>
+                    </a:lnR>
+                    <a:lnT w="12700" cap="flat" cmpd="sng" algn="ctr">
+                      <a:solidFill>
+                        <a:srgbClr val="30363D"/>
+                      </a:solidFill>
+                      <a:prstDash val="solid"/>
+                      <a:round/>
+                      <a:headEnd type="none" w="med" len="med"/>
+                      <a:tailEnd type="none" w="med" len="med"/>
+                    </a:lnT>
+                    <a:lnB w="12700" cap="flat" cmpd="sng" algn="ctr">
+                      <a:solidFill>
+                        <a:srgbClr val="30363D"/>
+                      </a:solidFill>
+                      <a:prstDash val="solid"/>
+                      <a:round/>
+                      <a:headEnd type="none" w="med" len="med"/>
+                      <a:tailEnd type="none" w="med" len="med"/>
+                    </a:lnB>
+                    <a:solidFill>
+                      <a:srgbClr val="0D1117"/>
+                    </a:solidFill>
+                  </a:tcPr>
+                </a:tc>
+              </a:tr>
+              <a:tr h="508000">
+                <a:tc>
+                  <a:txBody>
+                    <a:bodyPr/>
+                    <a:lstStyle/>
+                    <a:p>
+                      <a:pPr algn="l" indent="0" marL="0">
+                        <a:buNone/>
+                      </a:pPr>
+                      <a:r>
+                        <a:rPr lang="en-US" sz="1100" b="1" dirty="0">
+                          <a:solidFill>
+                            <a:srgbClr val="58A6FF"/>
+                          </a:solidFill>
+                          <a:latin typeface="Helvetica" pitchFamily="34" charset="0"/>
+                          <a:ea typeface="Helvetica" pitchFamily="34" charset="-122"/>
+                          <a:cs typeface="Helvetica" pitchFamily="34" charset="-120"/>
+                        </a:rPr>
+                        <a:t>Prompts</a:t>
+                      </a:r>
+                      <a:endParaRPr lang="en-US" sz="1100" dirty="0">
+                        <a:latin typeface="Helvetica" charset="0"/>
+                        <a:ea typeface="Helvetica" charset="0"/>
+                        <a:cs typeface="Helvetica" charset="0"/>
+                      </a:endParaRPr>
+                    </a:p>
+                  </a:txBody>
+                  <a:tcPr marL="63500" marR="63500" marT="38100" marB="38100" anchor="ctr">
+                    <a:lnL w="12700" cap="flat" cmpd="sng" algn="ctr">
+                      <a:solidFill>
+                        <a:srgbClr val="30363D"/>
+                      </a:solidFill>
+                      <a:prstDash val="solid"/>
+                      <a:round/>
+                      <a:headEnd type="none" w="med" len="med"/>
+                      <a:tailEnd type="none" w="med" len="med"/>
+                    </a:lnL>
+                    <a:lnR w="12700" cap="flat" cmpd="sng" algn="ctr">
+                      <a:solidFill>
+                        <a:srgbClr val="30363D"/>
+                      </a:solidFill>
+                      <a:prstDash val="solid"/>
+                      <a:round/>
+                      <a:headEnd type="none" w="med" len="med"/>
+                      <a:tailEnd type="none" w="med" len="med"/>
+                    </a:lnR>
+                    <a:lnT w="12700" cap="flat" cmpd="sng" algn="ctr">
+                      <a:solidFill>
+                        <a:srgbClr val="30363D"/>
+                      </a:solidFill>
+                      <a:prstDash val="solid"/>
+                      <a:round/>
+                      <a:headEnd type="none" w="med" len="med"/>
+                      <a:tailEnd type="none" w="med" len="med"/>
+                    </a:lnT>
+                    <a:lnB w="12700" cap="flat" cmpd="sng" algn="ctr">
+                      <a:solidFill>
+                        <a:srgbClr val="30363D"/>
+                      </a:solidFill>
+                      <a:prstDash val="solid"/>
+                      <a:round/>
+                      <a:headEnd type="none" w="med" len="med"/>
+                      <a:tailEnd type="none" w="med" len="med"/>
+                    </a:lnB>
+                    <a:solidFill>
+                      <a:srgbClr val="161B22"/>
+                    </a:solidFill>
+                  </a:tcPr>
+                </a:tc>
+                <a:tc>
+                  <a:txBody>
+                    <a:bodyPr/>
+                    <a:lstStyle/>
+                    <a:p>
+                      <a:pPr algn="l" indent="0" marL="0">
+                        <a:buNone/>
+                      </a:pPr>
+                      <a:r>
+                        <a:rPr lang="en-US" sz="1100" dirty="0">
+                          <a:solidFill>
+                            <a:srgbClr val="E6EDF3"/>
+                          </a:solidFill>
+                          <a:latin typeface="Helvetica" pitchFamily="34" charset="0"/>
+                          <a:ea typeface="Helvetica" pitchFamily="34" charset="-122"/>
+                          <a:cs typeface="Helvetica" pitchFamily="34" charset="-120"/>
+                        </a:rPr>
+                        <a:t>Explicit task framing</a:t>
+                      </a:r>
+                      <a:endParaRPr lang="en-US" sz="1100" dirty="0">
+                        <a:latin typeface="Helvetica" charset="0"/>
+                        <a:ea typeface="Helvetica" charset="0"/>
+                        <a:cs typeface="Helvetica" charset="0"/>
+                      </a:endParaRPr>
+                    </a:p>
+                  </a:txBody>
+                  <a:tcPr marL="63500" marR="63500" marT="38100" marB="38100" anchor="ctr">
+                    <a:lnL w="12700" cap="flat" cmpd="sng" algn="ctr">
+                      <a:solidFill>
+                        <a:srgbClr val="30363D"/>
+                      </a:solidFill>
+                      <a:prstDash val="solid"/>
+                      <a:round/>
+                      <a:headEnd type="none" w="med" len="med"/>
+                      <a:tailEnd type="none" w="med" len="med"/>
+                    </a:lnL>
+                    <a:lnR w="12700" cap="flat" cmpd="sng" algn="ctr">
+                      <a:solidFill>
+                        <a:srgbClr val="30363D"/>
+                      </a:solidFill>
+                      <a:prstDash val="solid"/>
+                      <a:round/>
+                      <a:headEnd type="none" w="med" len="med"/>
+                      <a:tailEnd type="none" w="med" len="med"/>
+                    </a:lnR>
+                    <a:lnT w="12700" cap="flat" cmpd="sng" algn="ctr">
+                      <a:solidFill>
+                        <a:srgbClr val="30363D"/>
+                      </a:solidFill>
+                      <a:prstDash val="solid"/>
+                      <a:round/>
+                      <a:headEnd type="none" w="med" len="med"/>
+                      <a:tailEnd type="none" w="med" len="med"/>
+                    </a:lnT>
+                    <a:lnB w="12700" cap="flat" cmpd="sng" algn="ctr">
+                      <a:solidFill>
+                        <a:srgbClr val="30363D"/>
+                      </a:solidFill>
+                      <a:prstDash val="solid"/>
+                      <a:round/>
+                      <a:headEnd type="none" w="med" len="med"/>
+                      <a:tailEnd type="none" w="med" len="med"/>
+                    </a:lnB>
+                    <a:solidFill>
+                      <a:srgbClr val="161B22"/>
+                    </a:solidFill>
+                  </a:tcPr>
+                </a:tc>
+                <a:tc>
+                  <a:txBody>
+                    <a:bodyPr/>
+                    <a:lstStyle/>
+                    <a:p>
+                      <a:pPr algn="l" indent="0" marL="0">
+                        <a:buNone/>
+                      </a:pPr>
+                      <a:r>
+                        <a:rPr lang="en-US" sz="1100" dirty="0">
+                          <a:solidFill>
+                            <a:srgbClr val="E6EDF3"/>
+                          </a:solidFill>
+                          <a:latin typeface="Helvetica" pitchFamily="34" charset="0"/>
+                          <a:ea typeface="Helvetica" pitchFamily="34" charset="-122"/>
+                          <a:cs typeface="Helvetica" pitchFamily="34" charset="-120"/>
+                        </a:rPr>
+                        <a:t>Task shaping</a:t>
+                      </a:r>
+                      <a:endParaRPr lang="en-US" sz="1100" dirty="0">
+                        <a:latin typeface="Helvetica" charset="0"/>
+                        <a:ea typeface="Helvetica" charset="0"/>
+                        <a:cs typeface="Helvetica" charset="0"/>
+                      </a:endParaRPr>
+                    </a:p>
+                  </a:txBody>
+                  <a:tcPr marL="63500" marR="63500" marT="38100" marB="38100" anchor="ctr">
+                    <a:lnL w="12700" cap="flat" cmpd="sng" algn="ctr">
+                      <a:solidFill>
+                        <a:srgbClr val="30363D"/>
+                      </a:solidFill>
+                      <a:prstDash val="solid"/>
+                      <a:round/>
+                      <a:headEnd type="none" w="med" len="med"/>
+                      <a:tailEnd type="none" w="med" len="med"/>
+                    </a:lnL>
+                    <a:lnR w="12700" cap="flat" cmpd="sng" algn="ctr">
+                      <a:solidFill>
+                        <a:srgbClr val="30363D"/>
+                      </a:solidFill>
+                      <a:prstDash val="solid"/>
+                      <a:round/>
+                      <a:headEnd type="none" w="med" len="med"/>
+                      <a:tailEnd type="none" w="med" len="med"/>
+                    </a:lnR>
+                    <a:lnT w="12700" cap="flat" cmpd="sng" algn="ctr">
+                      <a:solidFill>
+                        <a:srgbClr val="30363D"/>
+                      </a:solidFill>
+                      <a:prstDash val="solid"/>
+                      <a:round/>
+                      <a:headEnd type="none" w="med" len="med"/>
+                      <a:tailEnd type="none" w="med" len="med"/>
+                    </a:lnT>
+                    <a:lnB w="12700" cap="flat" cmpd="sng" algn="ctr">
+                      <a:solidFill>
+                        <a:srgbClr val="30363D"/>
+                      </a:solidFill>
+                      <a:prstDash val="solid"/>
+                      <a:round/>
+                      <a:headEnd type="none" w="med" len="med"/>
+                      <a:tailEnd type="none" w="med" len="med"/>
+                    </a:lnB>
+                    <a:solidFill>
+                      <a:srgbClr val="161B22"/>
+                    </a:solidFill>
+                  </a:tcPr>
+                </a:tc>
+                <a:tc>
+                  <a:txBody>
+                    <a:bodyPr/>
+                    <a:lstStyle/>
+                    <a:p>
+                      <a:pPr algn="l" indent="0" marL="0">
+                        <a:buNone/>
+                      </a:pPr>
+                      <a:r>
+                        <a:rPr lang="en-US" sz="1100" dirty="0">
+                          <a:solidFill>
+                            <a:srgbClr val="E6EDF3"/>
+                          </a:solidFill>
+                          <a:latin typeface="Helvetica" pitchFamily="34" charset="0"/>
+                          <a:ea typeface="Helvetica" pitchFamily="34" charset="-122"/>
+                          <a:cs typeface="Helvetica" pitchFamily="34" charset="-120"/>
+                        </a:rPr>
+                        <a:t>User-invoked templates</a:t>
+                      </a:r>
+                      <a:endParaRPr lang="en-US" sz="1100" dirty="0">
+                        <a:latin typeface="Helvetica" charset="0"/>
+                        <a:ea typeface="Helvetica" charset="0"/>
+                        <a:cs typeface="Helvetica" charset="0"/>
+                      </a:endParaRPr>
+                    </a:p>
+                  </a:txBody>
+                  <a:tcPr marL="63500" marR="63500" marT="38100" marB="38100" anchor="ctr">
+                    <a:lnL w="12700" cap="flat" cmpd="sng" algn="ctr">
+                      <a:solidFill>
+                        <a:srgbClr val="30363D"/>
+                      </a:solidFill>
+                      <a:prstDash val="solid"/>
+                      <a:round/>
+                      <a:headEnd type="none" w="med" len="med"/>
+                      <a:tailEnd type="none" w="med" len="med"/>
+                    </a:lnL>
+                    <a:lnR w="12700" cap="flat" cmpd="sng" algn="ctr">
+                      <a:solidFill>
+                        <a:srgbClr val="30363D"/>
+                      </a:solidFill>
+                      <a:prstDash val="solid"/>
+                      <a:round/>
+                      <a:headEnd type="none" w="med" len="med"/>
+                      <a:tailEnd type="none" w="med" len="med"/>
+                    </a:lnR>
+                    <a:lnT w="12700" cap="flat" cmpd="sng" algn="ctr">
+                      <a:solidFill>
+                        <a:srgbClr val="30363D"/>
+                      </a:solidFill>
+                      <a:prstDash val="solid"/>
+                      <a:round/>
+                      <a:headEnd type="none" w="med" len="med"/>
+                      <a:tailEnd type="none" w="med" len="med"/>
+                    </a:lnT>
+                    <a:lnB w="12700" cap="flat" cmpd="sng" algn="ctr">
+                      <a:solidFill>
+                        <a:srgbClr val="30363D"/>
+                      </a:solidFill>
+                      <a:prstDash val="solid"/>
+                      <a:round/>
+                      <a:headEnd type="none" w="med" len="med"/>
+                      <a:tailEnd type="none" w="med" len="med"/>
+                    </a:lnB>
+                    <a:solidFill>
+                      <a:srgbClr val="161B22"/>
+                    </a:solidFill>
+                  </a:tcPr>
+                </a:tc>
+              </a:tr>
+              <a:tr h="508000">
+                <a:tc>
+                  <a:txBody>
+                    <a:bodyPr/>
+                    <a:lstStyle/>
+                    <a:p>
+                      <a:pPr algn="l" indent="0" marL="0">
+                        <a:buNone/>
+                      </a:pPr>
+                      <a:r>
+                        <a:rPr lang="en-US" sz="1100" b="1" dirty="0">
+                          <a:solidFill>
+                            <a:srgbClr val="58A6FF"/>
+                          </a:solidFill>
+                          <a:latin typeface="Helvetica" pitchFamily="34" charset="0"/>
+                          <a:ea typeface="Helvetica" pitchFamily="34" charset="-122"/>
+                          <a:cs typeface="Helvetica" pitchFamily="34" charset="-120"/>
+                        </a:rPr>
+                        <a:t>Skills</a:t>
+                      </a:r>
+                      <a:endParaRPr lang="en-US" sz="1100" dirty="0">
+                        <a:latin typeface="Helvetica" charset="0"/>
+                        <a:ea typeface="Helvetica" charset="0"/>
+                        <a:cs typeface="Helvetica" charset="0"/>
+                      </a:endParaRPr>
+                    </a:p>
+                  </a:txBody>
+                  <a:tcPr marL="63500" marR="63500" marT="38100" marB="38100" anchor="ctr">
+                    <a:lnL w="12700" cap="flat" cmpd="sng" algn="ctr">
+                      <a:solidFill>
+                        <a:srgbClr val="30363D"/>
+                      </a:solidFill>
+                      <a:prstDash val="solid"/>
+                      <a:round/>
+                      <a:headEnd type="none" w="med" len="med"/>
+                      <a:tailEnd type="none" w="med" len="med"/>
+                    </a:lnL>
+                    <a:lnR w="12700" cap="flat" cmpd="sng" algn="ctr">
+                      <a:solidFill>
+                        <a:srgbClr val="30363D"/>
+                      </a:solidFill>
+                      <a:prstDash val="solid"/>
+                      <a:round/>
+                      <a:headEnd type="none" w="med" len="med"/>
+                      <a:tailEnd type="none" w="med" len="med"/>
+                    </a:lnR>
+                    <a:lnT w="12700" cap="flat" cmpd="sng" algn="ctr">
+                      <a:solidFill>
+                        <a:srgbClr val="30363D"/>
+                      </a:solidFill>
+                      <a:prstDash val="solid"/>
+                      <a:round/>
+                      <a:headEnd type="none" w="med" len="med"/>
+                      <a:tailEnd type="none" w="med" len="med"/>
+                    </a:lnT>
+                    <a:lnB w="12700" cap="flat" cmpd="sng" algn="ctr">
+                      <a:solidFill>
+                        <a:srgbClr val="30363D"/>
+                      </a:solidFill>
+                      <a:prstDash val="solid"/>
+                      <a:round/>
+                      <a:headEnd type="none" w="med" len="med"/>
+                      <a:tailEnd type="none" w="med" len="med"/>
+                    </a:lnB>
+                    <a:solidFill>
+                      <a:srgbClr val="0D1117"/>
+                    </a:solidFill>
+                  </a:tcPr>
+                </a:tc>
+                <a:tc>
+                  <a:txBody>
+                    <a:bodyPr/>
+                    <a:lstStyle/>
+                    <a:p>
+                      <a:pPr algn="l" indent="0" marL="0">
+                        <a:buNone/>
+                      </a:pPr>
+                      <a:r>
+                        <a:rPr lang="en-US" sz="1100" dirty="0">
+                          <a:solidFill>
+                            <a:srgbClr val="E6EDF3"/>
+                          </a:solidFill>
+                          <a:latin typeface="Helvetica" pitchFamily="34" charset="0"/>
+                          <a:ea typeface="Helvetica" pitchFamily="34" charset="-122"/>
+                          <a:cs typeface="Helvetica" pitchFamily="34" charset="-120"/>
+                        </a:rPr>
+                        <a:t>Reusable procedure</a:t>
+                      </a:r>
+                      <a:endParaRPr lang="en-US" sz="1100" dirty="0">
+                        <a:latin typeface="Helvetica" charset="0"/>
+                        <a:ea typeface="Helvetica" charset="0"/>
+                        <a:cs typeface="Helvetica" charset="0"/>
+                      </a:endParaRPr>
+                    </a:p>
+                  </a:txBody>
+                  <a:tcPr marL="63500" marR="63500" marT="38100" marB="38100" anchor="ctr">
+                    <a:lnL w="12700" cap="flat" cmpd="sng" algn="ctr">
+                      <a:solidFill>
+                        <a:srgbClr val="30363D"/>
+                      </a:solidFill>
+                      <a:prstDash val="solid"/>
+                      <a:round/>
+                      <a:headEnd type="none" w="med" len="med"/>
+                      <a:tailEnd type="none" w="med" len="med"/>
+                    </a:lnL>
+                    <a:lnR w="12700" cap="flat" cmpd="sng" algn="ctr">
+                      <a:solidFill>
+                        <a:srgbClr val="30363D"/>
+                      </a:solidFill>
+                      <a:prstDash val="solid"/>
+                      <a:round/>
+                      <a:headEnd type="none" w="med" len="med"/>
+                      <a:tailEnd type="none" w="med" len="med"/>
+                    </a:lnR>
+                    <a:lnT w="12700" cap="flat" cmpd="sng" algn="ctr">
+                      <a:solidFill>
+                        <a:srgbClr val="30363D"/>
+                      </a:solidFill>
+                      <a:prstDash val="solid"/>
+                      <a:round/>
+                      <a:headEnd type="none" w="med" len="med"/>
+                      <a:tailEnd type="none" w="med" len="med"/>
+                    </a:lnT>
+                    <a:lnB w="12700" cap="flat" cmpd="sng" algn="ctr">
+                      <a:solidFill>
+                        <a:srgbClr val="30363D"/>
+                      </a:solidFill>
+                      <a:prstDash val="solid"/>
+                      <a:round/>
+                      <a:headEnd type="none" w="med" len="med"/>
+                      <a:tailEnd type="none" w="med" len="med"/>
+                    </a:lnB>
+                    <a:solidFill>
+                      <a:srgbClr val="0D1117"/>
+                    </a:solidFill>
+                  </a:tcPr>
+                </a:tc>
+                <a:tc>
+                  <a:txBody>
+                    <a:bodyPr/>
+                    <a:lstStyle/>
+                    <a:p>
+                      <a:pPr algn="l" indent="0" marL="0">
+                        <a:buNone/>
+                      </a:pPr>
+                      <a:r>
+                        <a:rPr lang="en-US" sz="1100" dirty="0">
+                          <a:solidFill>
+                            <a:srgbClr val="E6EDF3"/>
+                          </a:solidFill>
+                          <a:latin typeface="Helvetica" pitchFamily="34" charset="0"/>
+                          <a:ea typeface="Helvetica" pitchFamily="34" charset="-122"/>
+                          <a:cs typeface="Helvetica" pitchFamily="34" charset="-120"/>
+                        </a:rPr>
+                        <a:t>Task shaping and decision support</a:t>
+                      </a:r>
+                      <a:endParaRPr lang="en-US" sz="1100" dirty="0">
+                        <a:latin typeface="Helvetica" charset="0"/>
+                        <a:ea typeface="Helvetica" charset="0"/>
+                        <a:cs typeface="Helvetica" charset="0"/>
+                      </a:endParaRPr>
+                    </a:p>
+                  </a:txBody>
+                  <a:tcPr marL="63500" marR="63500" marT="38100" marB="38100" anchor="ctr">
+                    <a:lnL w="12700" cap="flat" cmpd="sng" algn="ctr">
+                      <a:solidFill>
+                        <a:srgbClr val="30363D"/>
+                      </a:solidFill>
+                      <a:prstDash val="solid"/>
+                      <a:round/>
+                      <a:headEnd type="none" w="med" len="med"/>
+                      <a:tailEnd type="none" w="med" len="med"/>
+                    </a:lnL>
+                    <a:lnR w="12700" cap="flat" cmpd="sng" algn="ctr">
+                      <a:solidFill>
+                        <a:srgbClr val="30363D"/>
+                      </a:solidFill>
+                      <a:prstDash val="solid"/>
+                      <a:round/>
+                      <a:headEnd type="none" w="med" len="med"/>
+                      <a:tailEnd type="none" w="med" len="med"/>
+                    </a:lnR>
+                    <a:lnT w="12700" cap="flat" cmpd="sng" algn="ctr">
+                      <a:solidFill>
+                        <a:srgbClr val="30363D"/>
+                      </a:solidFill>
+                      <a:prstDash val="solid"/>
+                      <a:round/>
+                      <a:headEnd type="none" w="med" len="med"/>
+                      <a:tailEnd type="none" w="med" len="med"/>
+                    </a:lnT>
+                    <a:lnB w="12700" cap="flat" cmpd="sng" algn="ctr">
+                      <a:solidFill>
+                        <a:srgbClr val="30363D"/>
+                      </a:solidFill>
+                      <a:prstDash val="solid"/>
+                      <a:round/>
+                      <a:headEnd type="none" w="med" len="med"/>
+                      <a:tailEnd type="none" w="med" len="med"/>
+                    </a:lnB>
+                    <a:solidFill>
+                      <a:srgbClr val="0D1117"/>
+                    </a:solidFill>
+                  </a:tcPr>
+                </a:tc>
+                <a:tc>
+                  <a:txBody>
+                    <a:bodyPr/>
+                    <a:lstStyle/>
+                    <a:p>
+                      <a:pPr algn="l" indent="0" marL="0">
+                        <a:buNone/>
+                      </a:pPr>
+                      <a:r>
+                        <a:rPr lang="en-US" sz="1100" dirty="0">
+                          <a:solidFill>
+                            <a:srgbClr val="E6EDF3"/>
+                          </a:solidFill>
+                          <a:latin typeface="Helvetica" pitchFamily="34" charset="0"/>
+                          <a:ea typeface="Helvetica" pitchFamily="34" charset="-122"/>
+                          <a:cs typeface="Helvetica" pitchFamily="34" charset="-120"/>
+                        </a:rPr>
+                        <a:t>Repeatable, discoverable workflows</a:t>
+                      </a:r>
+                      <a:endParaRPr lang="en-US" sz="1100" dirty="0">
+                        <a:latin typeface="Helvetica" charset="0"/>
+                        <a:ea typeface="Helvetica" charset="0"/>
+                        <a:cs typeface="Helvetica" charset="0"/>
+                      </a:endParaRPr>
+                    </a:p>
+                  </a:txBody>
+                  <a:tcPr marL="63500" marR="63500" marT="38100" marB="38100" anchor="ctr">
+                    <a:lnL w="12700" cap="flat" cmpd="sng" algn="ctr">
+                      <a:solidFill>
+                        <a:srgbClr val="30363D"/>
+                      </a:solidFill>
+                      <a:prstDash val="solid"/>
+                      <a:round/>
+                      <a:headEnd type="none" w="med" len="med"/>
+                      <a:tailEnd type="none" w="med" len="med"/>
+                    </a:lnL>
+                    <a:lnR w="12700" cap="flat" cmpd="sng" algn="ctr">
+                      <a:solidFill>
+                        <a:srgbClr val="30363D"/>
+                      </a:solidFill>
+                      <a:prstDash val="solid"/>
+                      <a:round/>
+                      <a:headEnd type="none" w="med" len="med"/>
+                      <a:tailEnd type="none" w="med" len="med"/>
+                    </a:lnR>
+                    <a:lnT w="12700" cap="flat" cmpd="sng" algn="ctr">
+                      <a:solidFill>
+                        <a:srgbClr val="30363D"/>
+                      </a:solidFill>
+                      <a:prstDash val="solid"/>
+                      <a:round/>
+                      <a:headEnd type="none" w="med" len="med"/>
+                      <a:tailEnd type="none" w="med" len="med"/>
+                    </a:lnT>
+                    <a:lnB w="12700" cap="flat" cmpd="sng" algn="ctr">
+                      <a:solidFill>
+                        <a:srgbClr val="30363D"/>
+                      </a:solidFill>
+                      <a:prstDash val="solid"/>
+                      <a:round/>
+                      <a:headEnd type="none" w="med" len="med"/>
+                      <a:tailEnd type="none" w="med" len="med"/>
+                    </a:lnB>
+                    <a:solidFill>
+                      <a:srgbClr val="0D1117"/>
+                    </a:solidFill>
+                  </a:tcPr>
+                </a:tc>
+              </a:tr>
+              <a:tr h="508000">
+                <a:tc>
+                  <a:txBody>
+                    <a:bodyPr/>
+                    <a:lstStyle/>
+                    <a:p>
+                      <a:pPr algn="l" indent="0" marL="0">
+                        <a:buNone/>
+                      </a:pPr>
+                      <a:r>
+                        <a:rPr lang="en-US" sz="1100" b="1" dirty="0">
+                          <a:solidFill>
+                            <a:srgbClr val="58A6FF"/>
+                          </a:solidFill>
+                          <a:latin typeface="Helvetica" pitchFamily="34" charset="0"/>
+                          <a:ea typeface="Helvetica" pitchFamily="34" charset="-122"/>
+                          <a:cs typeface="Helvetica" pitchFamily="34" charset="-120"/>
+                        </a:rPr>
+                        <a:t>Custom Agents</a:t>
+                      </a:r>
+                      <a:endParaRPr lang="en-US" sz="1100" dirty="0">
+                        <a:latin typeface="Helvetica" charset="0"/>
+                        <a:ea typeface="Helvetica" charset="0"/>
+                        <a:cs typeface="Helvetica" charset="0"/>
+                      </a:endParaRPr>
+                    </a:p>
+                  </a:txBody>
+                  <a:tcPr marL="63500" marR="63500" marT="38100" marB="38100" anchor="ctr">
+                    <a:lnL w="12700" cap="flat" cmpd="sng" algn="ctr">
+                      <a:solidFill>
+                        <a:srgbClr val="30363D"/>
+                      </a:solidFill>
+                      <a:prstDash val="solid"/>
+                      <a:round/>
+                      <a:headEnd type="none" w="med" len="med"/>
+                      <a:tailEnd type="none" w="med" len="med"/>
+                    </a:lnL>
+                    <a:lnR w="12700" cap="flat" cmpd="sng" algn="ctr">
+                      <a:solidFill>
+                        <a:srgbClr val="30363D"/>
+                      </a:solidFill>
+                      <a:prstDash val="solid"/>
+                      <a:round/>
+                      <a:headEnd type="none" w="med" len="med"/>
+                      <a:tailEnd type="none" w="med" len="med"/>
+                    </a:lnR>
+                    <a:lnT w="12700" cap="flat" cmpd="sng" algn="ctr">
+                      <a:solidFill>
+                        <a:srgbClr val="30363D"/>
+                      </a:solidFill>
+                      <a:prstDash val="solid"/>
+                      <a:round/>
+                      <a:headEnd type="none" w="med" len="med"/>
+                      <a:tailEnd type="none" w="med" len="med"/>
+                    </a:lnT>
+                    <a:lnB w="12700" cap="flat" cmpd="sng" algn="ctr">
+                      <a:solidFill>
+                        <a:srgbClr val="30363D"/>
+                      </a:solidFill>
+                      <a:prstDash val="solid"/>
+                      <a:round/>
+                      <a:headEnd type="none" w="med" len="med"/>
+                      <a:tailEnd type="none" w="med" len="med"/>
+                    </a:lnB>
+                    <a:solidFill>
+                      <a:srgbClr val="161B22"/>
+                    </a:solidFill>
+                  </a:tcPr>
+                </a:tc>
+                <a:tc>
+                  <a:txBody>
+                    <a:bodyPr/>
+                    <a:lstStyle/>
+                    <a:p>
+                      <a:pPr algn="l" indent="0" marL="0">
+                        <a:buNone/>
+                      </a:pPr>
+                      <a:r>
+                        <a:rPr lang="en-US" sz="1100" dirty="0">
+                          <a:solidFill>
+                            <a:srgbClr val="E6EDF3"/>
+                          </a:solidFill>
+                          <a:latin typeface="Helvetica" pitchFamily="34" charset="0"/>
+                          <a:ea typeface="Helvetica" pitchFamily="34" charset="-122"/>
+                          <a:cs typeface="Helvetica" pitchFamily="34" charset="-120"/>
+                        </a:rPr>
+                        <a:t>Persistent role and posture</a:t>
+                      </a:r>
+                      <a:endParaRPr lang="en-US" sz="1100" dirty="0">
+                        <a:latin typeface="Helvetica" charset="0"/>
+                        <a:ea typeface="Helvetica" charset="0"/>
+                        <a:cs typeface="Helvetica" charset="0"/>
+                      </a:endParaRPr>
+                    </a:p>
+                  </a:txBody>
+                  <a:tcPr marL="63500" marR="63500" marT="38100" marB="38100" anchor="ctr">
+                    <a:lnL w="12700" cap="flat" cmpd="sng" algn="ctr">
+                      <a:solidFill>
+                        <a:srgbClr val="30363D"/>
+                      </a:solidFill>
+                      <a:prstDash val="solid"/>
+                      <a:round/>
+                      <a:headEnd type="none" w="med" len="med"/>
+                      <a:tailEnd type="none" w="med" len="med"/>
+                    </a:lnL>
+                    <a:lnR w="12700" cap="flat" cmpd="sng" algn="ctr">
+                      <a:solidFill>
+                        <a:srgbClr val="30363D"/>
+                      </a:solidFill>
+                      <a:prstDash val="solid"/>
+                      <a:round/>
+                      <a:headEnd type="none" w="med" len="med"/>
+                      <a:tailEnd type="none" w="med" len="med"/>
+                    </a:lnR>
+                    <a:lnT w="12700" cap="flat" cmpd="sng" algn="ctr">
+                      <a:solidFill>
+                        <a:srgbClr val="30363D"/>
+                      </a:solidFill>
+                      <a:prstDash val="solid"/>
+                      <a:round/>
+                      <a:headEnd type="none" w="med" len="med"/>
+                      <a:tailEnd type="none" w="med" len="med"/>
+                    </a:lnT>
+                    <a:lnB w="12700" cap="flat" cmpd="sng" algn="ctr">
+                      <a:solidFill>
+                        <a:srgbClr val="30363D"/>
+                      </a:solidFill>
+                      <a:prstDash val="solid"/>
+                      <a:round/>
+                      <a:headEnd type="none" w="med" len="med"/>
+                      <a:tailEnd type="none" w="med" len="med"/>
+                    </a:lnB>
+                    <a:solidFill>
+                      <a:srgbClr val="161B22"/>
+                    </a:solidFill>
+                  </a:tcPr>
+                </a:tc>
+                <a:tc>
+                  <a:txBody>
+                    <a:bodyPr/>
+                    <a:lstStyle/>
+                    <a:p>
+                      <a:pPr algn="l" indent="0" marL="0">
+                        <a:buNone/>
+                      </a:pPr>
+                      <a:r>
+                        <a:rPr lang="en-US" sz="1100" dirty="0">
+                          <a:solidFill>
+                            <a:srgbClr val="E6EDF3"/>
+                          </a:solidFill>
+                          <a:latin typeface="Helvetica" pitchFamily="34" charset="0"/>
+                          <a:ea typeface="Helvetica" pitchFamily="34" charset="-122"/>
+                          <a:cs typeface="Helvetica" pitchFamily="34" charset="-120"/>
+                        </a:rPr>
+                        <a:t>Task shaping across a conversation</a:t>
+                      </a:r>
+                      <a:endParaRPr lang="en-US" sz="1100" dirty="0">
+                        <a:latin typeface="Helvetica" charset="0"/>
+                        <a:ea typeface="Helvetica" charset="0"/>
+                        <a:cs typeface="Helvetica" charset="0"/>
+                      </a:endParaRPr>
+                    </a:p>
+                  </a:txBody>
+                  <a:tcPr marL="63500" marR="63500" marT="38100" marB="38100" anchor="ctr">
+                    <a:lnL w="12700" cap="flat" cmpd="sng" algn="ctr">
+                      <a:solidFill>
+                        <a:srgbClr val="30363D"/>
+                      </a:solidFill>
+                      <a:prstDash val="solid"/>
+                      <a:round/>
+                      <a:headEnd type="none" w="med" len="med"/>
+                      <a:tailEnd type="none" w="med" len="med"/>
+                    </a:lnL>
+                    <a:lnR w="12700" cap="flat" cmpd="sng" algn="ctr">
+                      <a:solidFill>
+                        <a:srgbClr val="30363D"/>
+                      </a:solidFill>
+                      <a:prstDash val="solid"/>
+                      <a:round/>
+                      <a:headEnd type="none" w="med" len="med"/>
+                      <a:tailEnd type="none" w="med" len="med"/>
+                    </a:lnR>
+                    <a:lnT w="12700" cap="flat" cmpd="sng" algn="ctr">
+                      <a:solidFill>
+                        <a:srgbClr val="30363D"/>
+                      </a:solidFill>
+                      <a:prstDash val="solid"/>
+                      <a:round/>
+                      <a:headEnd type="none" w="med" len="med"/>
+                      <a:tailEnd type="none" w="med" len="med"/>
+                    </a:lnT>
+                    <a:lnB w="12700" cap="flat" cmpd="sng" algn="ctr">
+                      <a:solidFill>
+                        <a:srgbClr val="30363D"/>
+                      </a:solidFill>
+                      <a:prstDash val="solid"/>
+                      <a:round/>
+                      <a:headEnd type="none" w="med" len="med"/>
+                      <a:tailEnd type="none" w="med" len="med"/>
+                    </a:lnB>
+                    <a:solidFill>
+                      <a:srgbClr val="161B22"/>
+                    </a:solidFill>
+                  </a:tcPr>
+                </a:tc>
+                <a:tc>
+                  <a:txBody>
+                    <a:bodyPr/>
+                    <a:lstStyle/>
+                    <a:p>
+                      <a:pPr algn="l" indent="0" marL="0">
+                        <a:buNone/>
+                      </a:pPr>
+                      <a:r>
+                        <a:rPr lang="en-US" sz="1100" dirty="0">
+                          <a:solidFill>
+                            <a:srgbClr val="E6EDF3"/>
+                          </a:solidFill>
+                          <a:latin typeface="Helvetica" pitchFamily="34" charset="0"/>
+                          <a:ea typeface="Helvetica" pitchFamily="34" charset="-122"/>
+                          <a:cs typeface="Helvetica" pitchFamily="34" charset="-120"/>
+                        </a:rPr>
+                        <a:t>Reviewer, architect, deployer, mentor modes</a:t>
+                      </a:r>
+                      <a:endParaRPr lang="en-US" sz="1100" dirty="0">
+                        <a:latin typeface="Helvetica" charset="0"/>
+                        <a:ea typeface="Helvetica" charset="0"/>
+                        <a:cs typeface="Helvetica" charset="0"/>
+                      </a:endParaRPr>
+                    </a:p>
+                  </a:txBody>
+                  <a:tcPr marL="63500" marR="63500" marT="38100" marB="38100" anchor="ctr">
+                    <a:lnL w="12700" cap="flat" cmpd="sng" algn="ctr">
+                      <a:solidFill>
+                        <a:srgbClr val="30363D"/>
+                      </a:solidFill>
+                      <a:prstDash val="solid"/>
+                      <a:round/>
+                      <a:headEnd type="none" w="med" len="med"/>
+                      <a:tailEnd type="none" w="med" len="med"/>
+                    </a:lnL>
+                    <a:lnR w="12700" cap="flat" cmpd="sng" algn="ctr">
+                      <a:solidFill>
+                        <a:srgbClr val="30363D"/>
+                      </a:solidFill>
+                      <a:prstDash val="solid"/>
+                      <a:round/>
+                      <a:headEnd type="none" w="med" len="med"/>
+                      <a:tailEnd type="none" w="med" len="med"/>
+                    </a:lnR>
+                    <a:lnT w="12700" cap="flat" cmpd="sng" algn="ctr">
+                      <a:solidFill>
+                        <a:srgbClr val="30363D"/>
+                      </a:solidFill>
+                      <a:prstDash val="solid"/>
+                      <a:round/>
+                      <a:headEnd type="none" w="med" len="med"/>
+                      <a:tailEnd type="none" w="med" len="med"/>
+                    </a:lnT>
+                    <a:lnB w="12700" cap="flat" cmpd="sng" algn="ctr">
+                      <a:solidFill>
+                        <a:srgbClr val="30363D"/>
+                      </a:solidFill>
+                      <a:prstDash val="solid"/>
+                      <a:round/>
+                      <a:headEnd type="none" w="med" len="med"/>
+                      <a:tailEnd type="none" w="med" len="med"/>
+                    </a:lnB>
+                    <a:solidFill>
+                      <a:srgbClr val="161B22"/>
+                    </a:solidFill>
+                  </a:tcPr>
+                </a:tc>
+              </a:tr>
+              <a:tr h="508000">
+                <a:tc>
+                  <a:txBody>
+                    <a:bodyPr/>
+                    <a:lstStyle/>
+                    <a:p>
+                      <a:pPr algn="l" indent="0" marL="0">
+                        <a:buNone/>
+                      </a:pPr>
+                      <a:r>
+                        <a:rPr lang="en-US" sz="1100" b="1" dirty="0">
+                          <a:solidFill>
+                            <a:srgbClr val="58A6FF"/>
+                          </a:solidFill>
+                          <a:latin typeface="Helvetica" pitchFamily="34" charset="0"/>
+                          <a:ea typeface="Helvetica" pitchFamily="34" charset="-122"/>
+                          <a:cs typeface="Helvetica" pitchFamily="34" charset="-120"/>
+                        </a:rPr>
+                        <a:t>MCP</a:t>
+                      </a:r>
+                      <a:endParaRPr lang="en-US" sz="1100" dirty="0">
+                        <a:latin typeface="Helvetica" charset="0"/>
+                        <a:ea typeface="Helvetica" charset="0"/>
+                        <a:cs typeface="Helvetica" charset="0"/>
+                      </a:endParaRPr>
+                    </a:p>
+                  </a:txBody>
+                  <a:tcPr marL="63500" marR="63500" marT="38100" marB="38100" anchor="ctr">
+                    <a:lnL w="12700" cap="flat" cmpd="sng" algn="ctr">
+                      <a:solidFill>
+                        <a:srgbClr val="30363D"/>
+                      </a:solidFill>
+                      <a:prstDash val="solid"/>
+                      <a:round/>
+                      <a:headEnd type="none" w="med" len="med"/>
+                      <a:tailEnd type="none" w="med" len="med"/>
+                    </a:lnL>
+                    <a:lnR w="12700" cap="flat" cmpd="sng" algn="ctr">
+                      <a:solidFill>
+                        <a:srgbClr val="30363D"/>
+                      </a:solidFill>
+                      <a:prstDash val="solid"/>
+                      <a:round/>
+                      <a:headEnd type="none" w="med" len="med"/>
+                      <a:tailEnd type="none" w="med" len="med"/>
+                    </a:lnR>
+                    <a:lnT w="12700" cap="flat" cmpd="sng" algn="ctr">
+                      <a:solidFill>
+                        <a:srgbClr val="30363D"/>
+                      </a:solidFill>
+                      <a:prstDash val="solid"/>
+                      <a:round/>
+                      <a:headEnd type="none" w="med" len="med"/>
+                      <a:tailEnd type="none" w="med" len="med"/>
+                    </a:lnT>
+                    <a:lnB w="12700" cap="flat" cmpd="sng" algn="ctr">
+                      <a:solidFill>
+                        <a:srgbClr val="30363D"/>
+                      </a:solidFill>
+                      <a:prstDash val="solid"/>
+                      <a:round/>
+                      <a:headEnd type="none" w="med" len="med"/>
+                      <a:tailEnd type="none" w="med" len="med"/>
+                    </a:lnB>
+                    <a:solidFill>
+                      <a:srgbClr val="0D1117"/>
+                    </a:solidFill>
+                  </a:tcPr>
+                </a:tc>
+                <a:tc>
+                  <a:txBody>
+                    <a:bodyPr/>
+                    <a:lstStyle/>
+                    <a:p>
+                      <a:pPr algn="l" indent="0" marL="0">
+                        <a:buNone/>
+                      </a:pPr>
+                      <a:r>
+                        <a:rPr lang="en-US" sz="1100" dirty="0">
+                          <a:solidFill>
+                            <a:srgbClr val="E6EDF3"/>
+                          </a:solidFill>
+                          <a:latin typeface="Helvetica" pitchFamily="34" charset="0"/>
+                          <a:ea typeface="Helvetica" pitchFamily="34" charset="-122"/>
+                          <a:cs typeface="Helvetica" pitchFamily="34" charset="-120"/>
+                        </a:rPr>
+                        <a:t>External reach</a:t>
+                      </a:r>
+                      <a:endParaRPr lang="en-US" sz="1100" dirty="0">
+                        <a:latin typeface="Helvetica" charset="0"/>
+                        <a:ea typeface="Helvetica" charset="0"/>
+                        <a:cs typeface="Helvetica" charset="0"/>
+                      </a:endParaRPr>
+                    </a:p>
+                  </a:txBody>
+                  <a:tcPr marL="63500" marR="63500" marT="38100" marB="38100" anchor="ctr">
+                    <a:lnL w="12700" cap="flat" cmpd="sng" algn="ctr">
+                      <a:solidFill>
+                        <a:srgbClr val="30363D"/>
+                      </a:solidFill>
+                      <a:prstDash val="solid"/>
+                      <a:round/>
+                      <a:headEnd type="none" w="med" len="med"/>
+                      <a:tailEnd type="none" w="med" len="med"/>
+                    </a:lnL>
+                    <a:lnR w="12700" cap="flat" cmpd="sng" algn="ctr">
+                      <a:solidFill>
+                        <a:srgbClr val="30363D"/>
+                      </a:solidFill>
+                      <a:prstDash val="solid"/>
+                      <a:round/>
+                      <a:headEnd type="none" w="med" len="med"/>
+                      <a:tailEnd type="none" w="med" len="med"/>
+                    </a:lnR>
+                    <a:lnT w="12700" cap="flat" cmpd="sng" algn="ctr">
+                      <a:solidFill>
+                        <a:srgbClr val="30363D"/>
+                      </a:solidFill>
+                      <a:prstDash val="solid"/>
+                      <a:round/>
+                      <a:headEnd type="none" w="med" len="med"/>
+                      <a:tailEnd type="none" w="med" len="med"/>
+                    </a:lnT>
+                    <a:lnB w="12700" cap="flat" cmpd="sng" algn="ctr">
+                      <a:solidFill>
+                        <a:srgbClr val="30363D"/>
+                      </a:solidFill>
+                      <a:prstDash val="solid"/>
+                      <a:round/>
+                      <a:headEnd type="none" w="med" len="med"/>
+                      <a:tailEnd type="none" w="med" len="med"/>
+                    </a:lnB>
+                    <a:solidFill>
+                      <a:srgbClr val="0D1117"/>
+                    </a:solidFill>
+                  </a:tcPr>
+                </a:tc>
+                <a:tc>
+                  <a:txBody>
+                    <a:bodyPr/>
+                    <a:lstStyle/>
+                    <a:p>
+                      <a:pPr algn="l" indent="0" marL="0">
+                        <a:buNone/>
+                      </a:pPr>
+                      <a:r>
+                        <a:rPr lang="en-US" sz="1100" dirty="0">
+                          <a:solidFill>
+                            <a:srgbClr val="E6EDF3"/>
+                          </a:solidFill>
+                          <a:latin typeface="Helvetica" pitchFamily="34" charset="0"/>
+                          <a:ea typeface="Helvetica" pitchFamily="34" charset="-122"/>
+                          <a:cs typeface="Helvetica" pitchFamily="34" charset="-120"/>
+                        </a:rPr>
+                        <a:t>Action selection and tool execution</a:t>
+                      </a:r>
+                      <a:endParaRPr lang="en-US" sz="1100" dirty="0">
+                        <a:latin typeface="Helvetica" charset="0"/>
+                        <a:ea typeface="Helvetica" charset="0"/>
+                        <a:cs typeface="Helvetica" charset="0"/>
+                      </a:endParaRPr>
+                    </a:p>
+                  </a:txBody>
+                  <a:tcPr marL="63500" marR="63500" marT="38100" marB="38100" anchor="ctr">
+                    <a:lnL w="12700" cap="flat" cmpd="sng" algn="ctr">
+                      <a:solidFill>
+                        <a:srgbClr val="30363D"/>
+                      </a:solidFill>
+                      <a:prstDash val="solid"/>
+                      <a:round/>
+                      <a:headEnd type="none" w="med" len="med"/>
+                      <a:tailEnd type="none" w="med" len="med"/>
+                    </a:lnL>
+                    <a:lnR w="12700" cap="flat" cmpd="sng" algn="ctr">
+                      <a:solidFill>
+                        <a:srgbClr val="30363D"/>
+                      </a:solidFill>
+                      <a:prstDash val="solid"/>
+                      <a:round/>
+                      <a:headEnd type="none" w="med" len="med"/>
+                      <a:tailEnd type="none" w="med" len="med"/>
+                    </a:lnR>
+                    <a:lnT w="12700" cap="flat" cmpd="sng" algn="ctr">
+                      <a:solidFill>
+                        <a:srgbClr val="30363D"/>
+                      </a:solidFill>
+                      <a:prstDash val="solid"/>
+                      <a:round/>
+                      <a:headEnd type="none" w="med" len="med"/>
+                      <a:tailEnd type="none" w="med" len="med"/>
+                    </a:lnT>
+                    <a:lnB w="12700" cap="flat" cmpd="sng" algn="ctr">
+                      <a:solidFill>
+                        <a:srgbClr val="30363D"/>
+                      </a:solidFill>
+                      <a:prstDash val="solid"/>
+                      <a:round/>
+                      <a:headEnd type="none" w="med" len="med"/>
+                      <a:tailEnd type="none" w="med" len="med"/>
+                    </a:lnB>
+                    <a:solidFill>
+                      <a:srgbClr val="0D1117"/>
+                    </a:solidFill>
+                  </a:tcPr>
+                </a:tc>
+                <a:tc>
+                  <a:txBody>
+                    <a:bodyPr/>
+                    <a:lstStyle/>
+                    <a:p>
+                      <a:pPr algn="l" indent="0" marL="0">
+                        <a:buNone/>
+                      </a:pPr>
+                      <a:r>
+                        <a:rPr lang="en-US" sz="1100" dirty="0">
+                          <a:solidFill>
+                            <a:srgbClr val="E6EDF3"/>
+                          </a:solidFill>
+                          <a:latin typeface="Helvetica" pitchFamily="34" charset="0"/>
+                          <a:ea typeface="Helvetica" pitchFamily="34" charset="-122"/>
+                          <a:cs typeface="Helvetica" pitchFamily="34" charset="-120"/>
+                        </a:rPr>
+                        <a:t>APIs, databases, issue trackers, internal systems</a:t>
+                      </a:r>
+                      <a:endParaRPr lang="en-US" sz="1100" dirty="0">
+                        <a:latin typeface="Helvetica" charset="0"/>
+                        <a:ea typeface="Helvetica" charset="0"/>
+                        <a:cs typeface="Helvetica" charset="0"/>
+                      </a:endParaRPr>
+                    </a:p>
+                  </a:txBody>
+                  <a:tcPr marL="63500" marR="63500" marT="38100" marB="38100" anchor="ctr">
+                    <a:lnL w="12700" cap="flat" cmpd="sng" algn="ctr">
+                      <a:solidFill>
+                        <a:srgbClr val="30363D"/>
+                      </a:solidFill>
+                      <a:prstDash val="solid"/>
+                      <a:round/>
+                      <a:headEnd type="none" w="med" len="med"/>
+                      <a:tailEnd type="none" w="med" len="med"/>
+                    </a:lnL>
+                    <a:lnR w="12700" cap="flat" cmpd="sng" algn="ctr">
+                      <a:solidFill>
+                        <a:srgbClr val="30363D"/>
+                      </a:solidFill>
+                      <a:prstDash val="solid"/>
+                      <a:round/>
+                      <a:headEnd type="none" w="med" len="med"/>
+                      <a:tailEnd type="none" w="med" len="med"/>
+                    </a:lnR>
+                    <a:lnT w="12700" cap="flat" cmpd="sng" algn="ctr">
+                      <a:solidFill>
+                        <a:srgbClr val="30363D"/>
+                      </a:solidFill>
+                      <a:prstDash val="solid"/>
+                      <a:round/>
+                      <a:headEnd type="none" w="med" len="med"/>
+                      <a:tailEnd type="none" w="med" len="med"/>
+                    </a:lnT>
+                    <a:lnB w="12700" cap="flat" cmpd="sng" algn="ctr">
+                      <a:solidFill>
+                        <a:srgbClr val="30363D"/>
+                      </a:solidFill>
+                      <a:prstDash val="solid"/>
+                      <a:round/>
+                      <a:headEnd type="none" w="med" len="med"/>
+                      <a:tailEnd type="none" w="med" len="med"/>
+                    </a:lnB>
+                    <a:solidFill>
+                      <a:srgbClr val="0D1117"/>
+                    </a:solidFill>
+                  </a:tcPr>
+                </a:tc>
+              </a:tr>
+              <a:tr h="508000">
+                <a:tc>
+                  <a:txBody>
+                    <a:bodyPr/>
+                    <a:lstStyle/>
+                    <a:p>
+                      <a:pPr algn="l" indent="0" marL="0">
+                        <a:buNone/>
+                      </a:pPr>
+                      <a:r>
+                        <a:rPr lang="en-US" sz="1100" b="1" dirty="0">
+                          <a:solidFill>
+                            <a:srgbClr val="58A6FF"/>
+                          </a:solidFill>
+                          <a:latin typeface="Helvetica" pitchFamily="34" charset="0"/>
+                          <a:ea typeface="Helvetica" pitchFamily="34" charset="-122"/>
+                          <a:cs typeface="Helvetica" pitchFamily="34" charset="-120"/>
+                        </a:rPr>
+                        <a:t>Hooks</a:t>
+                      </a:r>
+                      <a:endParaRPr lang="en-US" sz="1100" dirty="0">
+                        <a:latin typeface="Helvetica" charset="0"/>
+                        <a:ea typeface="Helvetica" charset="0"/>
+                        <a:cs typeface="Helvetica" charset="0"/>
+                      </a:endParaRPr>
+                    </a:p>
+                  </a:txBody>
+                  <a:tcPr marL="63500" marR="63500" marT="38100" marB="38100" anchor="ctr">
+                    <a:lnL w="12700" cap="flat" cmpd="sng" algn="ctr">
+                      <a:solidFill>
+                        <a:srgbClr val="30363D"/>
+                      </a:solidFill>
+                      <a:prstDash val="solid"/>
+                      <a:round/>
+                      <a:headEnd type="none" w="med" len="med"/>
+                      <a:tailEnd type="none" w="med" len="med"/>
+                    </a:lnL>
+                    <a:lnR w="12700" cap="flat" cmpd="sng" algn="ctr">
+                      <a:solidFill>
+                        <a:srgbClr val="30363D"/>
+                      </a:solidFill>
+                      <a:prstDash val="solid"/>
+                      <a:round/>
+                      <a:headEnd type="none" w="med" len="med"/>
+                      <a:tailEnd type="none" w="med" len="med"/>
+                    </a:lnR>
+                    <a:lnT w="12700" cap="flat" cmpd="sng" algn="ctr">
+                      <a:solidFill>
+                        <a:srgbClr val="30363D"/>
+                      </a:solidFill>
+                      <a:prstDash val="solid"/>
+                      <a:round/>
+                      <a:headEnd type="none" w="med" len="med"/>
+                      <a:tailEnd type="none" w="med" len="med"/>
+                    </a:lnT>
+                    <a:lnB w="12700" cap="flat" cmpd="sng" algn="ctr">
+                      <a:solidFill>
+                        <a:srgbClr val="30363D"/>
+                      </a:solidFill>
+                      <a:prstDash val="solid"/>
+                      <a:round/>
+                      <a:headEnd type="none" w="med" len="med"/>
+                      <a:tailEnd type="none" w="med" len="med"/>
+                    </a:lnB>
+                    <a:solidFill>
+                      <a:srgbClr val="161B22"/>
+                    </a:solidFill>
+                  </a:tcPr>
+                </a:tc>
+                <a:tc>
+                  <a:txBody>
+                    <a:bodyPr/>
+                    <a:lstStyle/>
+                    <a:p>
+                      <a:pPr algn="l" indent="0" marL="0">
+                        <a:buNone/>
+                      </a:pPr>
+                      <a:r>
+                        <a:rPr lang="en-US" sz="1100" dirty="0">
+                          <a:solidFill>
+                            <a:srgbClr val="E6EDF3"/>
+                          </a:solidFill>
+                          <a:latin typeface="Helvetica" pitchFamily="34" charset="0"/>
+                          <a:ea typeface="Helvetica" pitchFamily="34" charset="-122"/>
+                          <a:cs typeface="Helvetica" pitchFamily="34" charset="-120"/>
+                        </a:rPr>
+                        <a:t>Enforcement and audit</a:t>
+                      </a:r>
+                      <a:endParaRPr lang="en-US" sz="1100" dirty="0">
+                        <a:latin typeface="Helvetica" charset="0"/>
+                        <a:ea typeface="Helvetica" charset="0"/>
+                        <a:cs typeface="Helvetica" charset="0"/>
+                      </a:endParaRPr>
+                    </a:p>
+                  </a:txBody>
+                  <a:tcPr marL="63500" marR="63500" marT="38100" marB="38100" anchor="ctr">
+                    <a:lnL w="12700" cap="flat" cmpd="sng" algn="ctr">
+                      <a:solidFill>
+                        <a:srgbClr val="30363D"/>
+                      </a:solidFill>
+                      <a:prstDash val="solid"/>
+                      <a:round/>
+                      <a:headEnd type="none" w="med" len="med"/>
+                      <a:tailEnd type="none" w="med" len="med"/>
+                    </a:lnL>
+                    <a:lnR w="12700" cap="flat" cmpd="sng" algn="ctr">
+                      <a:solidFill>
+                        <a:srgbClr val="30363D"/>
+                      </a:solidFill>
+                      <a:prstDash val="solid"/>
+                      <a:round/>
+                      <a:headEnd type="none" w="med" len="med"/>
+                      <a:tailEnd type="none" w="med" len="med"/>
+                    </a:lnR>
+                    <a:lnT w="12700" cap="flat" cmpd="sng" algn="ctr">
+                      <a:solidFill>
+                        <a:srgbClr val="30363D"/>
+                      </a:solidFill>
+                      <a:prstDash val="solid"/>
+                      <a:round/>
+                      <a:headEnd type="none" w="med" len="med"/>
+                      <a:tailEnd type="none" w="med" len="med"/>
+                    </a:lnT>
+                    <a:lnB w="12700" cap="flat" cmpd="sng" algn="ctr">
+                      <a:solidFill>
+                        <a:srgbClr val="30363D"/>
+                      </a:solidFill>
+                      <a:prstDash val="solid"/>
+                      <a:round/>
+                      <a:headEnd type="none" w="med" len="med"/>
+                      <a:tailEnd type="none" w="med" len="med"/>
+                    </a:lnB>
+                    <a:solidFill>
+                      <a:srgbClr val="161B22"/>
+                    </a:solidFill>
+                  </a:tcPr>
+                </a:tc>
+                <a:tc>
+                  <a:txBody>
+                    <a:bodyPr/>
+                    <a:lstStyle/>
+                    <a:p>
+                      <a:pPr algn="l" indent="0" marL="0">
+                        <a:buNone/>
+                      </a:pPr>
+                      <a:r>
+                        <a:rPr lang="en-US" sz="1100" dirty="0">
+                          <a:solidFill>
+                            <a:srgbClr val="E6EDF3"/>
+                          </a:solidFill>
+                          <a:latin typeface="Helvetica" pitchFamily="34" charset="0"/>
+                          <a:ea typeface="Helvetica" pitchFamily="34" charset="-122"/>
+                          <a:cs typeface="Helvetica" pitchFamily="34" charset="-120"/>
+                        </a:rPr>
+                        <a:t>Lifecycle boundaries around execution</a:t>
+                      </a:r>
+                      <a:endParaRPr lang="en-US" sz="1100" dirty="0">
+                        <a:latin typeface="Helvetica" charset="0"/>
+                        <a:ea typeface="Helvetica" charset="0"/>
+                        <a:cs typeface="Helvetica" charset="0"/>
+                      </a:endParaRPr>
+                    </a:p>
+                  </a:txBody>
+                  <a:tcPr marL="63500" marR="63500" marT="38100" marB="38100" anchor="ctr">
+                    <a:lnL w="12700" cap="flat" cmpd="sng" algn="ctr">
+                      <a:solidFill>
+                        <a:srgbClr val="30363D"/>
+                      </a:solidFill>
+                      <a:prstDash val="solid"/>
+                      <a:round/>
+                      <a:headEnd type="none" w="med" len="med"/>
+                      <a:tailEnd type="none" w="med" len="med"/>
+                    </a:lnL>
+                    <a:lnR w="12700" cap="flat" cmpd="sng" algn="ctr">
+                      <a:solidFill>
+                        <a:srgbClr val="30363D"/>
+                      </a:solidFill>
+                      <a:prstDash val="solid"/>
+                      <a:round/>
+                      <a:headEnd type="none" w="med" len="med"/>
+                      <a:tailEnd type="none" w="med" len="med"/>
+                    </a:lnR>
+                    <a:lnT w="12700" cap="flat" cmpd="sng" algn="ctr">
+                      <a:solidFill>
+                        <a:srgbClr val="30363D"/>
+                      </a:solidFill>
+                      <a:prstDash val="solid"/>
+                      <a:round/>
+                      <a:headEnd type="none" w="med" len="med"/>
+                      <a:tailEnd type="none" w="med" len="med"/>
+                    </a:lnT>
+                    <a:lnB w="12700" cap="flat" cmpd="sng" algn="ctr">
+                      <a:solidFill>
+                        <a:srgbClr val="30363D"/>
+                      </a:solidFill>
+                      <a:prstDash val="solid"/>
+                      <a:round/>
+                      <a:headEnd type="none" w="med" len="med"/>
+                      <a:tailEnd type="none" w="med" len="med"/>
+                    </a:lnB>
+                    <a:solidFill>
+                      <a:srgbClr val="161B22"/>
+                    </a:solidFill>
+                  </a:tcPr>
+                </a:tc>
+                <a:tc>
+                  <a:txBody>
+                    <a:bodyPr/>
+                    <a:lstStyle/>
+                    <a:p>
+                      <a:pPr algn="l" indent="0" marL="0">
+                        <a:buNone/>
+                      </a:pPr>
+                      <a:r>
+                        <a:rPr lang="en-US" sz="1100" dirty="0">
+                          <a:solidFill>
+                            <a:srgbClr val="E6EDF3"/>
+                          </a:solidFill>
+                          <a:latin typeface="Helvetica" pitchFamily="34" charset="0"/>
+                          <a:ea typeface="Helvetica" pitchFamily="34" charset="-122"/>
+                          <a:cs typeface="Helvetica" pitchFamily="34" charset="-120"/>
+                        </a:rPr>
+                        <a:t>Deny, inspect, log, or constrain risky actions</a:t>
+                      </a:r>
+                      <a:endParaRPr lang="en-US" sz="1100" dirty="0">
+                        <a:latin typeface="Helvetica" charset="0"/>
+                        <a:ea typeface="Helvetica" charset="0"/>
+                        <a:cs typeface="Helvetica" charset="0"/>
+                      </a:endParaRPr>
+                    </a:p>
+                  </a:txBody>
+                  <a:tcPr marL="63500" marR="63500" marT="38100" marB="38100" anchor="ctr">
+                    <a:lnL w="12700" cap="flat" cmpd="sng" algn="ctr">
+                      <a:solidFill>
+                        <a:srgbClr val="30363D"/>
+                      </a:solidFill>
+                      <a:prstDash val="solid"/>
+                      <a:round/>
+                      <a:headEnd type="none" w="med" len="med"/>
+                      <a:tailEnd type="none" w="med" len="med"/>
+                    </a:lnL>
+                    <a:lnR w="12700" cap="flat" cmpd="sng" algn="ctr">
+                      <a:solidFill>
+                        <a:srgbClr val="30363D"/>
+                      </a:solidFill>
+                      <a:prstDash val="solid"/>
+                      <a:round/>
+                      <a:headEnd type="none" w="med" len="med"/>
+                      <a:tailEnd type="none" w="med" len="med"/>
+                    </a:lnR>
+                    <a:lnT w="12700" cap="flat" cmpd="sng" algn="ctr">
+                      <a:solidFill>
+                        <a:srgbClr val="30363D"/>
+                      </a:solidFill>
+                      <a:prstDash val="solid"/>
+                      <a:round/>
+                      <a:headEnd type="none" w="med" len="med"/>
+                      <a:tailEnd type="none" w="med" len="med"/>
+                    </a:lnT>
+                    <a:lnB w="12700" cap="flat" cmpd="sng" algn="ctr">
+                      <a:solidFill>
+                        <a:srgbClr val="30363D"/>
+                      </a:solidFill>
+                      <a:prstDash val="solid"/>
+                      <a:round/>
+                      <a:headEnd type="none" w="med" len="med"/>
+                      <a:tailEnd type="none" w="med" len="med"/>
+                    </a:lnB>
+                    <a:solidFill>
+                      <a:srgbClr val="161B22"/>
+                    </a:solidFill>
+                  </a:tcPr>
+                </a:tc>
+              </a:tr>
+              <a:tr h="508000">
+                <a:tc>
+                  <a:txBody>
+                    <a:bodyPr/>
+                    <a:lstStyle/>
+                    <a:p>
+                      <a:pPr algn="l" indent="0" marL="0">
+                        <a:buNone/>
+                      </a:pPr>
+                      <a:r>
+                        <a:rPr lang="en-US" sz="1100" b="1" dirty="0">
+                          <a:solidFill>
+                            <a:srgbClr val="58A6FF"/>
+                          </a:solidFill>
+                          <a:latin typeface="Helvetica" pitchFamily="34" charset="0"/>
+                          <a:ea typeface="Helvetica" pitchFamily="34" charset="-122"/>
+                          <a:cs typeface="Helvetica" pitchFamily="34" charset="-120"/>
+                        </a:rPr>
+                        <a:t>Memory</a:t>
+                      </a:r>
+                      <a:endParaRPr lang="en-US" sz="1100" dirty="0">
+                        <a:latin typeface="Helvetica" charset="0"/>
+                        <a:ea typeface="Helvetica" charset="0"/>
+                        <a:cs typeface="Helvetica" charset="0"/>
+                      </a:endParaRPr>
+                    </a:p>
+                  </a:txBody>
+                  <a:tcPr marL="63500" marR="63500" marT="38100" marB="38100" anchor="ctr">
+                    <a:lnL w="12700" cap="flat" cmpd="sng" algn="ctr">
+                      <a:solidFill>
+                        <a:srgbClr val="30363D"/>
+                      </a:solidFill>
+                      <a:prstDash val="solid"/>
+                      <a:round/>
+                      <a:headEnd type="none" w="med" len="med"/>
+                      <a:tailEnd type="none" w="med" len="med"/>
+                    </a:lnL>
+                    <a:lnR w="12700" cap="flat" cmpd="sng" algn="ctr">
+                      <a:solidFill>
+                        <a:srgbClr val="30363D"/>
+                      </a:solidFill>
+                      <a:prstDash val="solid"/>
+                      <a:round/>
+                      <a:headEnd type="none" w="med" len="med"/>
+                      <a:tailEnd type="none" w="med" len="med"/>
+                    </a:lnR>
+                    <a:lnT w="12700" cap="flat" cmpd="sng" algn="ctr">
+                      <a:solidFill>
+                        <a:srgbClr val="30363D"/>
+                      </a:solidFill>
+                      <a:prstDash val="solid"/>
+                      <a:round/>
+                      <a:headEnd type="none" w="med" len="med"/>
+                      <a:tailEnd type="none" w="med" len="med"/>
+                    </a:lnT>
+                    <a:lnB w="12700" cap="flat" cmpd="sng" algn="ctr">
+                      <a:solidFill>
+                        <a:srgbClr val="30363D"/>
+                      </a:solidFill>
+                      <a:prstDash val="solid"/>
+                      <a:round/>
+                      <a:headEnd type="none" w="med" len="med"/>
+                      <a:tailEnd type="none" w="med" len="med"/>
+                    </a:lnB>
+                    <a:solidFill>
+                      <a:srgbClr val="0D1117"/>
+                    </a:solidFill>
+                  </a:tcPr>
+                </a:tc>
+                <a:tc>
+                  <a:txBody>
+                    <a:bodyPr/>
+                    <a:lstStyle/>
+                    <a:p>
+                      <a:pPr algn="l" indent="0" marL="0">
+                        <a:buNone/>
+                      </a:pPr>
+                      <a:r>
+                        <a:rPr lang="en-US" sz="1100" dirty="0">
+                          <a:solidFill>
+                            <a:srgbClr val="E6EDF3"/>
+                          </a:solidFill>
+                          <a:latin typeface="Helvetica" pitchFamily="34" charset="0"/>
+                          <a:ea typeface="Helvetica" pitchFamily="34" charset="-122"/>
+                          <a:cs typeface="Helvetica" pitchFamily="34" charset="-120"/>
+                        </a:rPr>
+                        <a:t>Learned repo knowledge</a:t>
+                      </a:r>
+                      <a:endParaRPr lang="en-US" sz="1100" dirty="0">
+                        <a:latin typeface="Helvetica" charset="0"/>
+                        <a:ea typeface="Helvetica" charset="0"/>
+                        <a:cs typeface="Helvetica" charset="0"/>
+                      </a:endParaRPr>
+                    </a:p>
+                  </a:txBody>
+                  <a:tcPr marL="63500" marR="63500" marT="38100" marB="38100" anchor="ctr">
+                    <a:lnL w="12700" cap="flat" cmpd="sng" algn="ctr">
+                      <a:solidFill>
+                        <a:srgbClr val="30363D"/>
+                      </a:solidFill>
+                      <a:prstDash val="solid"/>
+                      <a:round/>
+                      <a:headEnd type="none" w="med" len="med"/>
+                      <a:tailEnd type="none" w="med" len="med"/>
+                    </a:lnL>
+                    <a:lnR w="12700" cap="flat" cmpd="sng" algn="ctr">
+                      <a:solidFill>
+                        <a:srgbClr val="30363D"/>
+                      </a:solidFill>
+                      <a:prstDash val="solid"/>
+                      <a:round/>
+                      <a:headEnd type="none" w="med" len="med"/>
+                      <a:tailEnd type="none" w="med" len="med"/>
+                    </a:lnR>
+                    <a:lnT w="12700" cap="flat" cmpd="sng" algn="ctr">
+                      <a:solidFill>
+                        <a:srgbClr val="30363D"/>
+                      </a:solidFill>
+                      <a:prstDash val="solid"/>
+                      <a:round/>
+                      <a:headEnd type="none" w="med" len="med"/>
+                      <a:tailEnd type="none" w="med" len="med"/>
+                    </a:lnT>
+                    <a:lnB w="12700" cap="flat" cmpd="sng" algn="ctr">
+                      <a:solidFill>
+                        <a:srgbClr val="30363D"/>
+                      </a:solidFill>
+                      <a:prstDash val="solid"/>
+                      <a:round/>
+                      <a:headEnd type="none" w="med" len="med"/>
+                      <a:tailEnd type="none" w="med" len="med"/>
+                    </a:lnB>
+                    <a:solidFill>
+                      <a:srgbClr val="0D1117"/>
+                    </a:solidFill>
+                  </a:tcPr>
+                </a:tc>
+                <a:tc>
+                  <a:txBody>
+                    <a:bodyPr/>
+                    <a:lstStyle/>
+                    <a:p>
+                      <a:pPr algn="l" indent="0" marL="0">
+                        <a:buNone/>
+                      </a:pPr>
+                      <a:r>
+                        <a:rPr lang="en-US" sz="1100" dirty="0">
+                          <a:solidFill>
+                            <a:srgbClr val="E6EDF3"/>
+                          </a:solidFill>
+                          <a:latin typeface="Helvetica" pitchFamily="34" charset="0"/>
+                          <a:ea typeface="Helvetica" pitchFamily="34" charset="-122"/>
+                          <a:cs typeface="Helvetica" pitchFamily="34" charset="-120"/>
+                        </a:rPr>
+                        <a:t>Context assembly and reasoning</a:t>
+                      </a:r>
+                      <a:endParaRPr lang="en-US" sz="1100" dirty="0">
+                        <a:latin typeface="Helvetica" charset="0"/>
+                        <a:ea typeface="Helvetica" charset="0"/>
+                        <a:cs typeface="Helvetica" charset="0"/>
+                      </a:endParaRPr>
+                    </a:p>
+                  </a:txBody>
+                  <a:tcPr marL="63500" marR="63500" marT="38100" marB="38100" anchor="ctr">
+                    <a:lnL w="12700" cap="flat" cmpd="sng" algn="ctr">
+                      <a:solidFill>
+                        <a:srgbClr val="30363D"/>
+                      </a:solidFill>
+                      <a:prstDash val="solid"/>
+                      <a:round/>
+                      <a:headEnd type="none" w="med" len="med"/>
+                      <a:tailEnd type="none" w="med" len="med"/>
+                    </a:lnL>
+                    <a:lnR w="12700" cap="flat" cmpd="sng" algn="ctr">
+                      <a:solidFill>
+                        <a:srgbClr val="30363D"/>
+                      </a:solidFill>
+                      <a:prstDash val="solid"/>
+                      <a:round/>
+                      <a:headEnd type="none" w="med" len="med"/>
+                      <a:tailEnd type="none" w="med" len="med"/>
+                    </a:lnR>
+                    <a:lnT w="12700" cap="flat" cmpd="sng" algn="ctr">
+                      <a:solidFill>
+                        <a:srgbClr val="30363D"/>
+                      </a:solidFill>
+                      <a:prstDash val="solid"/>
+                      <a:round/>
+                      <a:headEnd type="none" w="med" len="med"/>
+                      <a:tailEnd type="none" w="med" len="med"/>
+                    </a:lnT>
+                    <a:lnB w="12700" cap="flat" cmpd="sng" algn="ctr">
+                      <a:solidFill>
+                        <a:srgbClr val="30363D"/>
+                      </a:solidFill>
+                      <a:prstDash val="solid"/>
+                      <a:round/>
+                      <a:headEnd type="none" w="med" len="med"/>
+                      <a:tailEnd type="none" w="med" len="med"/>
+                    </a:lnB>
+                    <a:solidFill>
+                      <a:srgbClr val="0D1117"/>
+                    </a:solidFill>
+                  </a:tcPr>
+                </a:tc>
+                <a:tc>
+                  <a:txBody>
+                    <a:bodyPr/>
+                    <a:lstStyle/>
+                    <a:p>
+                      <a:pPr algn="l" indent="0" marL="0">
+                        <a:buNone/>
+                      </a:pPr>
+                      <a:r>
+                        <a:rPr lang="en-US" sz="1100" dirty="0">
+                          <a:solidFill>
+                            <a:srgbClr val="E6EDF3"/>
+                          </a:solidFill>
+                          <a:latin typeface="Helvetica" pitchFamily="34" charset="0"/>
+                          <a:ea typeface="Helvetica" pitchFamily="34" charset="-122"/>
+                          <a:cs typeface="Helvetica" pitchFamily="34" charset="-120"/>
+                        </a:rPr>
+                        <a:t>Patterns hard to author but easy to observe</a:t>
+                      </a:r>
+                      <a:endParaRPr lang="en-US" sz="1100" dirty="0">
+                        <a:latin typeface="Helvetica" charset="0"/>
+                        <a:ea typeface="Helvetica" charset="0"/>
+                        <a:cs typeface="Helvetica" charset="0"/>
+                      </a:endParaRPr>
+                    </a:p>
+                  </a:txBody>
+                  <a:tcPr marL="63500" marR="63500" marT="38100" marB="38100" anchor="ctr">
+                    <a:lnL w="12700" cap="flat" cmpd="sng" algn="ctr">
+                      <a:solidFill>
+                        <a:srgbClr val="30363D"/>
+                      </a:solidFill>
+                      <a:prstDash val="solid"/>
+                      <a:round/>
+                      <a:headEnd type="none" w="med" len="med"/>
+                      <a:tailEnd type="none" w="med" len="med"/>
+                    </a:lnL>
+                    <a:lnR w="12700" cap="flat" cmpd="sng" algn="ctr">
+                      <a:solidFill>
+                        <a:srgbClr val="30363D"/>
+                      </a:solidFill>
+                      <a:prstDash val="solid"/>
+                      <a:round/>
+                      <a:headEnd type="none" w="med" len="med"/>
+                      <a:tailEnd type="none" w="med" len="med"/>
+                    </a:lnR>
+                    <a:lnT w="12700" cap="flat" cmpd="sng" algn="ctr">
+                      <a:solidFill>
+                        <a:srgbClr val="30363D"/>
+                      </a:solidFill>
+                      <a:prstDash val="solid"/>
+                      <a:round/>
+                      <a:headEnd type="none" w="med" len="med"/>
+                      <a:tailEnd type="none" w="med" len="med"/>
+                    </a:lnT>
+                    <a:lnB w="12700" cap="flat" cmpd="sng" algn="ctr">
+                      <a:solidFill>
+                        <a:srgbClr val="30363D"/>
+                      </a:solidFill>
+                      <a:prstDash val="solid"/>
+                      <a:round/>
+                      <a:headEnd type="none" w="med" len="med"/>
+                      <a:tailEnd type="none" w="med" len="med"/>
+                    </a:lnB>
+                    <a:solidFill>
+                      <a:srgbClr val="0D1117"/>
+                    </a:solidFill>
+                  </a:tcPr>
+                </a:tc>
+              </a:tr>
+            </a:tbl>
+          </a:graphicData>
+        </a:graphic>
+      </p:graphicFrame>
+    </p:spTree>
+  </p:cSld>
+  <p:clrMapOvr>
+    <a:masterClrMapping/>
+  </p:clrMapOvr>
+</p:sld>
+</file>
+
+<file path=ppt/slides/slide5.xml><?xml version="1.0" encoding="utf-8"?>
+<p:sld xmlns:a="http://schemas.openxmlformats.org/drawingml/2006/main" xmlns:r="http://schemas.openxmlformats.org/officeDocument/2006/relationships" xmlns:p="http://schemas.openxmlformats.org/presentationml/2006/main">
+  <p:cSld name="Slide 5">
     <p:bg>
       <p:bgPr>
         <a:solidFill>

</xml_diff>

<commit_message>
Add presenter name and title to title slide
Co-authored-by: Copilot <223556219+Copilot@users.noreply.github.com>
</commit_message>
<xml_diff>
--- a/presentation/copilot-actions-overview.pptx
+++ b/presentation/copilot-actions-overview.pptx
@@ -1620,6 +1620,69 @@
           </a:p>
         </p:txBody>
       </p:sp>
+      <p:sp>
+        <p:nvSpPr>
+          <p:cNvPr id="12" name="Text 10"/>
+          <p:cNvSpPr/>
+          <p:nvPr/>
+        </p:nvSpPr>
+        <p:spPr>
+          <a:xfrm>
+            <a:off x="7132320" y="5806440"/>
+            <a:ext cx="4480560" cy="731520"/>
+          </a:xfrm>
+          <a:prstGeom prst="rect">
+            <a:avLst/>
+          </a:prstGeom>
+          <a:noFill/>
+          <a:ln/>
+        </p:spPr>
+        <p:txBody>
+          <a:bodyPr wrap="square" rtlCol="0" anchor="b"/>
+          <a:lstStyle/>
+          <a:p>
+            <a:pPr algn="r" indent="0" marL="0">
+              <a:lnSpc>
+                <a:spcPct val="110000"/>
+              </a:lnSpc>
+              <a:buNone/>
+            </a:pPr>
+            <a:r>
+              <a:rPr lang="en-US" sz="1800" b="1" dirty="0">
+                <a:solidFill>
+                  <a:srgbClr val="58A6FF"/>
+                </a:solidFill>
+                <a:latin typeface="Helvetica" pitchFamily="34" charset="0"/>
+                <a:ea typeface="Helvetica" pitchFamily="34" charset="-122"/>
+                <a:cs typeface="Helvetica" pitchFamily="34" charset="-120"/>
+              </a:rPr>
+              <a:t>Roshawn Reid
+</a:t>
+            </a:r>
+            <a:endParaRPr lang="en-US" sz="1800" dirty="0"/>
+          </a:p>
+          <a:p>
+            <a:pPr algn="r" indent="0" marL="0">
+              <a:lnSpc>
+                <a:spcPct val="110000"/>
+              </a:lnSpc>
+              <a:buNone/>
+            </a:pPr>
+            <a:r>
+              <a:rPr lang="en-US" sz="1400" dirty="0">
+                <a:solidFill>
+                  <a:srgbClr val="8B949E"/>
+                </a:solidFill>
+                <a:latin typeface="Helvetica" pitchFamily="34" charset="0"/>
+                <a:ea typeface="Helvetica" pitchFamily="34" charset="-122"/>
+                <a:cs typeface="Helvetica" pitchFamily="34" charset="-120"/>
+              </a:rPr>
+              <a:t>Solution Engineer</a:t>
+            </a:r>
+            <a:endParaRPr lang="en-US" sz="1800" dirty="0"/>
+          </a:p>
+        </p:txBody>
+      </p:sp>
     </p:spTree>
   </p:cSld>
   <p:clrMapOvr>

</xml_diff>

<commit_message>
Refine title slide: remove agenda list, center presenter name/title
Co-authored-by: Copilot <223556219+Copilot@users.noreply.github.com>
</commit_message>
<xml_diff>
--- a/presentation/copilot-actions-overview.pptx
+++ b/presentation/copilot-actions-overview.pptx
@@ -1505,8 +1505,8 @@
         </p:nvSpPr>
         <p:spPr>
           <a:xfrm>
-            <a:off x="640080" y="4114800"/>
-            <a:ext cx="5486400" cy="365760"/>
+            <a:off x="640080" y="4206240"/>
+            <a:ext cx="10972800" cy="914400"/>
           </a:xfrm>
           <a:prstGeom prst="rect">
             <a:avLst/>
@@ -1515,140 +1515,17 @@
           <a:ln/>
         </p:spPr>
         <p:txBody>
-          <a:bodyPr wrap="square" rtlCol="0" anchor="ctr"/>
+          <a:bodyPr wrap="square" rtlCol="0" anchor="t"/>
           <a:lstStyle/>
           <a:p>
-            <a:pPr indent="0" marL="0">
-              <a:buNone/>
-            </a:pPr>
-            <a:r>
-              <a:rPr lang="en-US" sz="1400" b="1" dirty="0">
-                <a:solidFill>
-                  <a:srgbClr val="8B949E"/>
-                </a:solidFill>
-                <a:latin typeface="Helvetica" pitchFamily="34" charset="0"/>
-                <a:ea typeface="Helvetica" pitchFamily="34" charset="-122"/>
-                <a:cs typeface="Helvetica" pitchFamily="34" charset="-120"/>
-              </a:rPr>
-              <a:t>Today's demo</a:t>
-            </a:r>
-            <a:endParaRPr lang="en-US" sz="1400" dirty="0"/>
-          </a:p>
-        </p:txBody>
-      </p:sp>
-      <p:sp>
-        <p:nvSpPr>
-          <p:cNvPr id="11" name="Text 9"/>
-          <p:cNvSpPr/>
-          <p:nvPr/>
-        </p:nvSpPr>
-        <p:spPr>
-          <a:xfrm>
-            <a:off x="731520" y="4480560"/>
-            <a:ext cx="10515600" cy="1463040"/>
-          </a:xfrm>
-          <a:prstGeom prst="rect">
-            <a:avLst/>
-          </a:prstGeom>
-          <a:noFill/>
-          <a:ln/>
-        </p:spPr>
-        <p:txBody>
-          <a:bodyPr wrap="square" rtlCol="0" anchor="ctr"/>
-          <a:lstStyle/>
-          <a:p>
-            <a:pPr indent="0" marL="0">
+            <a:pPr algn="ctr" indent="0" marL="0">
               <a:lnSpc>
-                <a:spcPct val="130000"/>
+                <a:spcPct val="115000"/>
               </a:lnSpc>
               <a:buNone/>
             </a:pPr>
             <a:r>
-              <a:rPr lang="en-US" sz="2000" dirty="0">
-                <a:solidFill>
-                  <a:srgbClr val="E6EDF3"/>
-                </a:solidFill>
-                <a:latin typeface="Helvetica" pitchFamily="34" charset="0"/>
-                <a:ea typeface="Helvetica" pitchFamily="34" charset="-122"/>
-                <a:cs typeface="Helvetica" pitchFamily="34" charset="-120"/>
-              </a:rPr>
-              <a:t>1.  Generate a CI workflow with a Copilot agent — in VS Code
-</a:t>
-            </a:r>
-            <a:endParaRPr lang="en-US" sz="2000" dirty="0"/>
-          </a:p>
-          <a:p>
-            <a:pPr indent="0" marL="0">
-              <a:lnSpc>
-                <a:spcPct val="130000"/>
-              </a:lnSpc>
-              <a:buNone/>
-            </a:pPr>
-            <a:r>
-              <a:rPr lang="en-US" sz="2000" dirty="0">
-                <a:solidFill>
-                  <a:srgbClr val="E6EDF3"/>
-                </a:solidFill>
-                <a:latin typeface="Helvetica" pitchFamily="34" charset="0"/>
-                <a:ea typeface="Helvetica" pitchFamily="34" charset="-122"/>
-                <a:cs typeface="Helvetica" pitchFamily="34" charset="-120"/>
-              </a:rPr>
-              <a:t>2.  Commit &amp; push to GitHub
-</a:t>
-            </a:r>
-            <a:endParaRPr lang="en-US" sz="2000" dirty="0"/>
-          </a:p>
-          <a:p>
-            <a:pPr indent="0" marL="0">
-              <a:lnSpc>
-                <a:spcPct val="130000"/>
-              </a:lnSpc>
-              <a:buNone/>
-            </a:pPr>
-            <a:r>
-              <a:rPr lang="en-US" sz="2000" dirty="0">
-                <a:solidFill>
-                  <a:srgbClr val="E6EDF3"/>
-                </a:solidFill>
-                <a:latin typeface="Helvetica" pitchFamily="34" charset="0"/>
-                <a:ea typeface="Helvetica" pitchFamily="34" charset="-122"/>
-                <a:cs typeface="Helvetica" pitchFamily="34" charset="-120"/>
-              </a:rPr>
-              <a:t>3.  Watch GitHub Actions build it live</a:t>
-            </a:r>
-            <a:endParaRPr lang="en-US" sz="2000" dirty="0"/>
-          </a:p>
-        </p:txBody>
-      </p:sp>
-      <p:sp>
-        <p:nvSpPr>
-          <p:cNvPr id="12" name="Text 10"/>
-          <p:cNvSpPr/>
-          <p:nvPr/>
-        </p:nvSpPr>
-        <p:spPr>
-          <a:xfrm>
-            <a:off x="7132320" y="5806440"/>
-            <a:ext cx="4480560" cy="731520"/>
-          </a:xfrm>
-          <a:prstGeom prst="rect">
-            <a:avLst/>
-          </a:prstGeom>
-          <a:noFill/>
-          <a:ln/>
-        </p:spPr>
-        <p:txBody>
-          <a:bodyPr wrap="square" rtlCol="0" anchor="b"/>
-          <a:lstStyle/>
-          <a:p>
-            <a:pPr algn="r" indent="0" marL="0">
-              <a:lnSpc>
-                <a:spcPct val="110000"/>
-              </a:lnSpc>
-              <a:buNone/>
-            </a:pPr>
-            <a:r>
-              <a:rPr lang="en-US" sz="1800" b="1" dirty="0">
+              <a:rPr lang="en-US" sz="2000" b="1" dirty="0">
                 <a:solidFill>
                   <a:srgbClr val="58A6FF"/>
                 </a:solidFill>
@@ -1659,17 +1536,17 @@
               <a:t>Roshawn Reid
 </a:t>
             </a:r>
-            <a:endParaRPr lang="en-US" sz="1800" dirty="0"/>
-          </a:p>
-          <a:p>
-            <a:pPr algn="r" indent="0" marL="0">
+            <a:endParaRPr lang="en-US" sz="2000" dirty="0"/>
+          </a:p>
+          <a:p>
+            <a:pPr algn="ctr" indent="0" marL="0">
               <a:lnSpc>
-                <a:spcPct val="110000"/>
+                <a:spcPct val="115000"/>
               </a:lnSpc>
               <a:buNone/>
             </a:pPr>
             <a:r>
-              <a:rPr lang="en-US" sz="1400" dirty="0">
+              <a:rPr lang="en-US" sz="1500" dirty="0">
                 <a:solidFill>
                   <a:srgbClr val="8B949E"/>
                 </a:solidFill>
@@ -1679,7 +1556,7 @@
               </a:rPr>
               <a:t>Solution Engineer</a:t>
             </a:r>
-            <a:endParaRPr lang="en-US" sz="1800" dirty="0"/>
+            <a:endParaRPr lang="en-US" sz="2000" dirty="0"/>
           </a:p>
         </p:txBody>
       </p:sp>

</xml_diff>

<commit_message>
Move presenter name under subtitle, left-aligned to match formatting
Co-authored-by: Copilot <223556219+Copilot@users.noreply.github.com>
</commit_message>
<xml_diff>
--- a/presentation/copilot-actions-overview.pptx
+++ b/presentation/copilot-actions-overview.pptx
@@ -1505,7 +1505,7 @@
         </p:nvSpPr>
         <p:spPr>
           <a:xfrm>
-            <a:off x="640080" y="4206240"/>
+            <a:off x="640080" y="3840480"/>
             <a:ext cx="10972800" cy="914400"/>
           </a:xfrm>
           <a:prstGeom prst="rect">
@@ -1518,7 +1518,7 @@
           <a:bodyPr wrap="square" rtlCol="0" anchor="t"/>
           <a:lstStyle/>
           <a:p>
-            <a:pPr algn="ctr" indent="0" marL="0">
+            <a:pPr algn="l" indent="0" marL="0">
               <a:lnSpc>
                 <a:spcPct val="115000"/>
               </a:lnSpc>
@@ -1539,7 +1539,7 @@
             <a:endParaRPr lang="en-US" sz="2000" dirty="0"/>
           </a:p>
           <a:p>
-            <a:pPr algn="ctr" indent="0" marL="0">
+            <a:pPr algn="l" indent="0" marL="0">
               <a:lnSpc>
                 <a:spcPct val="115000"/>
               </a:lnSpc>

</xml_diff>

<commit_message>
Tighten spacing between presenter name and title
Co-authored-by: Copilot <223556219+Copilot@users.noreply.github.com>
</commit_message>
<xml_diff>
--- a/presentation/copilot-actions-overview.pptx
+++ b/presentation/copilot-actions-overview.pptx
@@ -1520,7 +1520,7 @@
           <a:p>
             <a:pPr algn="l" indent="0" marL="0">
               <a:lnSpc>
-                <a:spcPct val="115000"/>
+                <a:spcPct val="90000"/>
               </a:lnSpc>
               <a:buNone/>
             </a:pPr>
@@ -1541,7 +1541,7 @@
           <a:p>
             <a:pPr algn="l" indent="0" marL="0">
               <a:lnSpc>
-                <a:spcPct val="115000"/>
+                <a:spcPct val="90000"/>
               </a:lnSpc>
               <a:buNone/>
             </a:pPr>

</xml_diff>

<commit_message>
Use GitHub Copilot logo on title slide
- Replace drawn octocat mark with Assets/github-copilot-logo.jpg (circular crop)
- Update wordmark to 'GitHub Copilot'

Co-authored-by: Copilot <223556219+Copilot@users.noreply.github.com>
</commit_message>
<xml_diff>
--- a/presentation/copilot-actions-overview.pptx
+++ b/presentation/copilot-actions-overview.pptx
@@ -1290,78 +1290,40 @@
           </a:p>
         </p:txBody>
       </p:sp>
-      <p:sp>
-        <p:nvSpPr>
-          <p:cNvPr id="4" name="Shape 2"/>
-          <p:cNvSpPr/>
-          <p:nvPr/>
-        </p:nvSpPr>
+      <p:pic>
+        <p:nvPicPr>
+          <p:cNvPr id="4" name="Image 0" descr="../Assets/github-copilot-logo.jpg">    </p:cNvPr>
+          <p:cNvPicPr>
+            <a:picLocks noChangeAspect="1"/>
+          </p:cNvPicPr>
+          <p:nvPr/>
+        </p:nvPicPr>
+        <p:blipFill>
+          <a:blip r:embed="rId1"/>
+          <a:stretch>
+            <a:fillRect/>
+          </a:stretch>
+        </p:blipFill>
         <p:spPr>
           <a:xfrm>
             <a:off x="640080" y="640080"/>
             <a:ext cx="822960" cy="822960"/>
           </a:xfrm>
-          <a:prstGeom prst="roundRect">
-            <a:avLst>
-              <a:gd name="adj" fmla="val 45000"/>
-            </a:avLst>
-          </a:prstGeom>
-          <a:solidFill>
-            <a:srgbClr val="FFFFFF"/>
-          </a:solidFill>
-          <a:ln/>
-        </p:spPr>
-      </p:sp>
-      <p:sp>
-        <p:nvSpPr>
-          <p:cNvPr id="5" name="Shape 3"/>
-          <p:cNvSpPr/>
-          <p:nvPr/>
-        </p:nvSpPr>
-        <p:spPr>
-          <a:xfrm>
-            <a:off x="903427" y="919886"/>
-            <a:ext cx="98755" cy="131674"/>
-          </a:xfrm>
           <a:prstGeom prst="ellipse">
             <a:avLst/>
           </a:prstGeom>
-          <a:solidFill>
-            <a:srgbClr val="0D1117"/>
-          </a:solidFill>
-          <a:ln/>
-        </p:spPr>
-      </p:sp>
-      <p:sp>
-        <p:nvSpPr>
-          <p:cNvPr id="6" name="Shape 4"/>
+        </p:spPr>
+      </p:pic>
+      <p:sp>
+        <p:nvSpPr>
+          <p:cNvPr id="5" name="Text 2"/>
           <p:cNvSpPr/>
           <p:nvPr/>
         </p:nvSpPr>
         <p:spPr>
           <a:xfrm>
-            <a:off x="1100938" y="919886"/>
-            <a:ext cx="98755" cy="131674"/>
-          </a:xfrm>
-          <a:prstGeom prst="ellipse">
-            <a:avLst/>
-          </a:prstGeom>
-          <a:solidFill>
-            <a:srgbClr val="0D1117"/>
-          </a:solidFill>
-          <a:ln/>
-        </p:spPr>
-      </p:sp>
-      <p:sp>
-        <p:nvSpPr>
-          <p:cNvPr id="7" name="Text 5"/>
-          <p:cNvSpPr/>
-          <p:nvPr/>
-        </p:nvSpPr>
-        <p:spPr>
-          <a:xfrm>
             <a:off x="1600200" y="658368"/>
-            <a:ext cx="4572000" cy="822960"/>
+            <a:ext cx="5486400" cy="822960"/>
           </a:xfrm>
           <a:prstGeom prst="rect">
             <a:avLst/>
@@ -1385,7 +1347,7 @@
                 <a:ea typeface="Helvetica" pitchFamily="34" charset="-122"/>
                 <a:cs typeface="Helvetica" pitchFamily="34" charset="-120"/>
               </a:rPr>
-              <a:t>GitHub</a:t>
+              <a:t>GitHub Copilot</a:t>
             </a:r>
             <a:endParaRPr lang="en-US" sz="3000" dirty="0"/>
           </a:p>
@@ -1393,7 +1355,7 @@
       </p:sp>
       <p:sp>
         <p:nvSpPr>
-          <p:cNvPr id="8" name="Text 6"/>
+          <p:cNvPr id="6" name="Text 3"/>
           <p:cNvSpPr/>
           <p:nvPr/>
         </p:nvSpPr>
@@ -1432,7 +1394,7 @@
       </p:sp>
       <p:sp>
         <p:nvSpPr>
-          <p:cNvPr id="9" name="Text 7"/>
+          <p:cNvPr id="7" name="Text 4"/>
           <p:cNvSpPr/>
           <p:nvPr/>
         </p:nvSpPr>
@@ -1499,7 +1461,7 @@
       </p:sp>
       <p:sp>
         <p:nvSpPr>
-          <p:cNvPr id="10" name="Text 8"/>
+          <p:cNvPr id="8" name="Text 5"/>
           <p:cNvSpPr/>
           <p:nvPr/>
         </p:nvSpPr>

</xml_diff>

<commit_message>
Use transparent Copilot logo on title slide (remove white background)
- Add Assets/github-copilot-logo.png (white made transparent, autocropped)
- Embed PNG without circular crop; correct aspect ratio

Co-authored-by: Copilot <223556219+Copilot@users.noreply.github.com>
</commit_message>
<xml_diff>
--- a/presentation/copilot-actions-overview.pptx
+++ b/presentation/copilot-actions-overview.pptx
@@ -1292,7 +1292,7 @@
       </p:sp>
       <p:pic>
         <p:nvPicPr>
-          <p:cNvPr id="4" name="Image 0" descr="../Assets/github-copilot-logo.jpg">    </p:cNvPr>
+          <p:cNvPr id="4" name="Image 0" descr="../Assets/github-copilot-logo.png">    </p:cNvPr>
           <p:cNvPicPr>
             <a:picLocks noChangeAspect="1"/>
           </p:cNvPicPr>
@@ -1306,10 +1306,10 @@
         </p:blipFill>
         <p:spPr>
           <a:xfrm>
-            <a:off x="640080" y="640080"/>
-            <a:ext cx="822960" cy="822960"/>
-          </a:xfrm>
-          <a:prstGeom prst="ellipse">
+            <a:off x="640080" y="676656"/>
+            <a:ext cx="868680" cy="704088"/>
+          </a:xfrm>
+          <a:prstGeom prst="rect">
             <a:avLst/>
           </a:prstGeom>
         </p:spPr>
@@ -1322,7 +1322,7 @@
         </p:nvSpPr>
         <p:spPr>
           <a:xfrm>
-            <a:off x="1600200" y="658368"/>
+            <a:off x="1645920" y="658368"/>
             <a:ext cx="5486400" cy="822960"/>
           </a:xfrm>
           <a:prstGeom prst="rect">

</xml_diff>

<commit_message>
Add Agentic Workflows slide and gh-aw build metadata
Co-authored-by: Copilot <223556219+Copilot@users.noreply.github.com>
</commit_message>
<xml_diff>
--- a/presentation/copilot-actions-overview.pptx
+++ b/presentation/copilot-actions-overview.pptx
@@ -10,9 +10,10 @@
     <p:sldId id="258" r:id="rId4"/>
     <p:sldId id="259" r:id="rId5"/>
     <p:sldId id="260" r:id="rId6"/>
+    <p:sldId id="261" r:id="rId7"/>
   </p:sldIdLst>
   <p:notesMasterIdLst>
-    <p:notesMasterId r:id="rId7"/>
+    <p:notesMasterId r:id="rId8"/>
   </p:notesMasterIdLst>
   <p:sldSz cx="12191695" cy="6858000"/>
   <p:notesSz cx="6858000" cy="12191695"/>
@@ -882,6 +883,94 @@
             <a:fld id="{F7021451-1387-4CA6-816F-3879F97B5CBC}" type="slidenum">
               <a:rPr lang="en-US"/>
               <a:t>5</a:t>
+            </a:fld>
+            <a:endParaRPr lang="en-US"/>
+          </a:p>
+        </p:txBody>
+      </p:sp>
+    </p:spTree>
+    <p:extLst>
+      <p:ext uri="{BB962C8B-B14F-4D97-AF65-F5344CB8AC3E}">
+        <p14:creationId xmlns:p14="http://schemas.microsoft.com/office/powerpoint/2010/main" val="1024086991"/>
+      </p:ext>
+    </p:extLst>
+  </p:cSld>
+  <p:clrMapOvr>
+    <a:masterClrMapping/>
+  </p:clrMapOvr>
+</p:notes>
+</file>
+
+<file path=ppt/notesSlides/notesSlide6.xml><?xml version="1.0" encoding="utf-8"?>
+<p:notes xmlns:a="http://schemas.openxmlformats.org/drawingml/2006/main" xmlns:r="http://schemas.openxmlformats.org/officeDocument/2006/relationships" xmlns:p="http://schemas.openxmlformats.org/presentationml/2006/main">
+  <p:cSld>
+    <p:spTree>
+      <p:nvGrpSpPr>
+        <p:cNvPr id="1" name=""/>
+        <p:cNvGrpSpPr/>
+        <p:nvPr/>
+      </p:nvGrpSpPr>
+      <p:grpSpPr>
+        <a:xfrm>
+          <a:off x="0" y="0"/>
+          <a:ext cx="0" cy="0"/>
+          <a:chOff x="0" y="0"/>
+          <a:chExt cx="0" cy="0"/>
+        </a:xfrm>
+      </p:grpSpPr>
+      <p:sp>
+        <p:nvSpPr>
+          <p:cNvPr id="2" name="Slide Image Placeholder 1"/>
+          <p:cNvSpPr>
+            <a:spLocks noGrp="1" noRot="1" noChangeAspect="1"/>
+          </p:cNvSpPr>
+          <p:nvPr>
+            <p:ph type="sldImg"/>
+          </p:nvPr>
+        </p:nvSpPr>
+        <p:spPr/>
+      </p:sp>
+      <p:sp>
+        <p:nvSpPr>
+          <p:cNvPr id="3" name="Notes Placeholder 2"/>
+          <p:cNvSpPr>
+            <a:spLocks noGrp="1"/>
+          </p:cNvSpPr>
+          <p:nvPr>
+            <p:ph type="body" idx="1"/>
+          </p:nvPr>
+        </p:nvSpPr>
+        <p:spPr/>
+        <p:txBody>
+          <a:bodyPr/>
+          <a:lstStyle/>
+          <a:p>
+            <a:r>
+              <a:rPr lang="en-US" dirty="0"/>
+              <a:t/>
+            </a:r>
+            <a:endParaRPr lang="en-US" dirty="0"/>
+          </a:p>
+        </p:txBody>
+      </p:sp>
+      <p:sp>
+        <p:nvSpPr>
+          <p:cNvPr id="4" name="Slide Number Placeholder 3"/>
+          <p:cNvSpPr>
+            <a:spLocks noGrp="1"/>
+          </p:cNvSpPr>
+          <p:nvPr>
+            <p:ph type="sldNum" sz="quarter" idx="10"/>
+          </p:nvPr>
+        </p:nvSpPr>
+        <p:spPr/>
+        <p:txBody>
+          <a:bodyPr/>
+          <a:lstStyle/>
+          <a:p>
+            <a:fld id="{F7021451-1387-4CA6-816F-3879F97B5CBC}" type="slidenum">
+              <a:rPr lang="en-US"/>
+              <a:t>6</a:t>
             </a:fld>
             <a:endParaRPr lang="en-US"/>
           </a:p>
@@ -1703,8 +1792,8 @@
         </p:nvSpPr>
         <p:spPr>
           <a:xfrm>
-            <a:off x="640080" y="2240280"/>
-            <a:ext cx="914400" cy="822960"/>
+            <a:off x="640080" y="2148840"/>
+            <a:ext cx="914400" cy="731520"/>
           </a:xfrm>
           <a:prstGeom prst="rect">
             <a:avLst/>
@@ -1720,7 +1809,7 @@
               <a:buNone/>
             </a:pPr>
             <a:r>
-              <a:rPr lang="en-US" sz="3400" b="1" dirty="0">
+              <a:rPr lang="en-US" sz="3000" b="1" dirty="0">
                 <a:solidFill>
                   <a:srgbClr val="A371F7"/>
                 </a:solidFill>
@@ -1730,7 +1819,7 @@
               </a:rPr>
               <a:t>01</a:t>
             </a:r>
-            <a:endParaRPr lang="en-US" sz="3400" dirty="0"/>
+            <a:endParaRPr lang="en-US" sz="3000" dirty="0"/>
           </a:p>
         </p:txBody>
       </p:sp>
@@ -1742,8 +1831,8 @@
         </p:nvSpPr>
         <p:spPr>
           <a:xfrm>
-            <a:off x="1691640" y="2286000"/>
-            <a:ext cx="0" cy="731520"/>
+            <a:off x="1691640" y="2194560"/>
+            <a:ext cx="0" cy="658368"/>
           </a:xfrm>
           <a:prstGeom prst="line">
             <a:avLst/>
@@ -1765,8 +1854,8 @@
         </p:nvSpPr>
         <p:spPr>
           <a:xfrm>
-            <a:off x="1920240" y="2258568"/>
-            <a:ext cx="9601200" cy="457200"/>
+            <a:off x="1920240" y="2148840"/>
+            <a:ext cx="9601200" cy="411480"/>
           </a:xfrm>
           <a:prstGeom prst="rect">
             <a:avLst/>
@@ -1782,7 +1871,7 @@
               <a:buNone/>
             </a:pPr>
             <a:r>
-              <a:rPr lang="en-US" sz="2000" b="1" dirty="0">
+              <a:rPr lang="en-US" sz="1900" b="1" dirty="0">
                 <a:solidFill>
                   <a:srgbClr val="E6EDF3"/>
                 </a:solidFill>
@@ -1792,7 +1881,7 @@
               </a:rPr>
               <a:t>GitHub Copilot</a:t>
             </a:r>
-            <a:endParaRPr lang="en-US" sz="2000" dirty="0"/>
+            <a:endParaRPr lang="en-US" sz="1900" dirty="0"/>
           </a:p>
         </p:txBody>
       </p:sp>
@@ -1804,7 +1893,7 @@
         </p:nvSpPr>
         <p:spPr>
           <a:xfrm>
-            <a:off x="1920240" y="2697480"/>
+            <a:off x="1920240" y="2551176"/>
             <a:ext cx="9601200" cy="365760"/>
           </a:xfrm>
           <a:prstGeom prst="rect">
@@ -1821,7 +1910,7 @@
               <a:buNone/>
             </a:pPr>
             <a:r>
-              <a:rPr lang="en-US" sz="1400" dirty="0">
+              <a:rPr lang="en-US" sz="1350" dirty="0">
                 <a:solidFill>
                   <a:srgbClr val="8B949E"/>
                 </a:solidFill>
@@ -1831,7 +1920,7 @@
               </a:rPr>
               <a:t>Your AI pair programmer — completions, chat, and agents.</a:t>
             </a:r>
-            <a:endParaRPr lang="en-US" sz="1400" dirty="0"/>
+            <a:endParaRPr lang="en-US" sz="1350" dirty="0"/>
           </a:p>
         </p:txBody>
       </p:sp>
@@ -1843,8 +1932,8 @@
         </p:nvSpPr>
         <p:spPr>
           <a:xfrm>
-            <a:off x="640080" y="3200400"/>
-            <a:ext cx="914400" cy="822960"/>
+            <a:off x="640080" y="3017520"/>
+            <a:ext cx="914400" cy="731520"/>
           </a:xfrm>
           <a:prstGeom prst="rect">
             <a:avLst/>
@@ -1860,7 +1949,7 @@
               <a:buNone/>
             </a:pPr>
             <a:r>
-              <a:rPr lang="en-US" sz="3400" b="1" dirty="0">
+              <a:rPr lang="en-US" sz="3000" b="1" dirty="0">
                 <a:solidFill>
                   <a:srgbClr val="58A6FF"/>
                 </a:solidFill>
@@ -1870,7 +1959,7 @@
               </a:rPr>
               <a:t>02</a:t>
             </a:r>
-            <a:endParaRPr lang="en-US" sz="3400" dirty="0"/>
+            <a:endParaRPr lang="en-US" sz="3000" dirty="0"/>
           </a:p>
         </p:txBody>
       </p:sp>
@@ -1882,8 +1971,8 @@
         </p:nvSpPr>
         <p:spPr>
           <a:xfrm>
-            <a:off x="1691640" y="3246120"/>
-            <a:ext cx="0" cy="731520"/>
+            <a:off x="1691640" y="3063240"/>
+            <a:ext cx="0" cy="658368"/>
           </a:xfrm>
           <a:prstGeom prst="line">
             <a:avLst/>
@@ -1905,8 +1994,8 @@
         </p:nvSpPr>
         <p:spPr>
           <a:xfrm>
-            <a:off x="1920240" y="3218688"/>
-            <a:ext cx="9601200" cy="457200"/>
+            <a:off x="1920240" y="3017520"/>
+            <a:ext cx="9601200" cy="411480"/>
           </a:xfrm>
           <a:prstGeom prst="rect">
             <a:avLst/>
@@ -1922,7 +2011,7 @@
               <a:buNone/>
             </a:pPr>
             <a:r>
-              <a:rPr lang="en-US" sz="2000" b="1" dirty="0">
+              <a:rPr lang="en-US" sz="1900" b="1" dirty="0">
                 <a:solidFill>
                   <a:srgbClr val="E6EDF3"/>
                 </a:solidFill>
@@ -1932,7 +2021,7 @@
               </a:rPr>
               <a:t>Customizing Copilot</a:t>
             </a:r>
-            <a:endParaRPr lang="en-US" sz="2000" dirty="0"/>
+            <a:endParaRPr lang="en-US" sz="1900" dirty="0"/>
           </a:p>
         </p:txBody>
       </p:sp>
@@ -1944,7 +2033,7 @@
         </p:nvSpPr>
         <p:spPr>
           <a:xfrm>
-            <a:off x="1920240" y="3657600"/>
+            <a:off x="1920240" y="3419856"/>
             <a:ext cx="9601200" cy="365760"/>
           </a:xfrm>
           <a:prstGeom prst="rect">
@@ -1961,7 +2050,7 @@
               <a:buNone/>
             </a:pPr>
             <a:r>
-              <a:rPr lang="en-US" sz="1400" dirty="0">
+              <a:rPr lang="en-US" sz="1350" dirty="0">
                 <a:solidFill>
                   <a:srgbClr val="8B949E"/>
                 </a:solidFill>
@@ -1971,7 +2060,7 @@
               </a:rPr>
               <a:t>The primitives that ground Copilot in your repo and team.</a:t>
             </a:r>
-            <a:endParaRPr lang="en-US" sz="1400" dirty="0"/>
+            <a:endParaRPr lang="en-US" sz="1350" dirty="0"/>
           </a:p>
         </p:txBody>
       </p:sp>
@@ -1983,8 +2072,8 @@
         </p:nvSpPr>
         <p:spPr>
           <a:xfrm>
-            <a:off x="640080" y="4160520"/>
-            <a:ext cx="914400" cy="822960"/>
+            <a:off x="640080" y="3886200"/>
+            <a:ext cx="914400" cy="731520"/>
           </a:xfrm>
           <a:prstGeom prst="rect">
             <a:avLst/>
@@ -2000,7 +2089,7 @@
               <a:buNone/>
             </a:pPr>
             <a:r>
-              <a:rPr lang="en-US" sz="3400" b="1" dirty="0">
+              <a:rPr lang="en-US" sz="3000" b="1" dirty="0">
                 <a:solidFill>
                   <a:srgbClr val="3FB950"/>
                 </a:solidFill>
@@ -2010,7 +2099,7 @@
               </a:rPr>
               <a:t>03</a:t>
             </a:r>
-            <a:endParaRPr lang="en-US" sz="3400" dirty="0"/>
+            <a:endParaRPr lang="en-US" sz="3000" dirty="0"/>
           </a:p>
         </p:txBody>
       </p:sp>
@@ -2022,8 +2111,8 @@
         </p:nvSpPr>
         <p:spPr>
           <a:xfrm>
-            <a:off x="1691640" y="4206240"/>
-            <a:ext cx="0" cy="731520"/>
+            <a:off x="1691640" y="3931920"/>
+            <a:ext cx="0" cy="658368"/>
           </a:xfrm>
           <a:prstGeom prst="line">
             <a:avLst/>
@@ -2045,8 +2134,8 @@
         </p:nvSpPr>
         <p:spPr>
           <a:xfrm>
-            <a:off x="1920240" y="4178808"/>
-            <a:ext cx="9601200" cy="457200"/>
+            <a:off x="1920240" y="3886200"/>
+            <a:ext cx="9601200" cy="411480"/>
           </a:xfrm>
           <a:prstGeom prst="rect">
             <a:avLst/>
@@ -2062,7 +2151,7 @@
               <a:buNone/>
             </a:pPr>
             <a:r>
-              <a:rPr lang="en-US" sz="2000" b="1" dirty="0">
+              <a:rPr lang="en-US" sz="1900" b="1" dirty="0">
                 <a:solidFill>
                   <a:srgbClr val="E6EDF3"/>
                 </a:solidFill>
@@ -2072,7 +2161,7 @@
               </a:rPr>
               <a:t>GitHub Actions</a:t>
             </a:r>
-            <a:endParaRPr lang="en-US" sz="2000" dirty="0"/>
+            <a:endParaRPr lang="en-US" sz="1900" dirty="0"/>
           </a:p>
         </p:txBody>
       </p:sp>
@@ -2084,7 +2173,7 @@
         </p:nvSpPr>
         <p:spPr>
           <a:xfrm>
-            <a:off x="1920240" y="4617720"/>
+            <a:off x="1920240" y="4288536"/>
             <a:ext cx="9601200" cy="365760"/>
           </a:xfrm>
           <a:prstGeom prst="rect">
@@ -2101,7 +2190,7 @@
               <a:buNone/>
             </a:pPr>
             <a:r>
-              <a:rPr lang="en-US" sz="1400" dirty="0">
+              <a:rPr lang="en-US" sz="1350" dirty="0">
                 <a:solidFill>
                   <a:srgbClr val="8B949E"/>
                 </a:solidFill>
@@ -2111,7 +2200,7 @@
               </a:rPr>
               <a:t>CI/CD native to GitHub — events, workflows, runners.</a:t>
             </a:r>
-            <a:endParaRPr lang="en-US" sz="1400" dirty="0"/>
+            <a:endParaRPr lang="en-US" sz="1350" dirty="0"/>
           </a:p>
         </p:txBody>
       </p:sp>
@@ -2123,8 +2212,8 @@
         </p:nvSpPr>
         <p:spPr>
           <a:xfrm>
-            <a:off x="640080" y="5120640"/>
-            <a:ext cx="914400" cy="822960"/>
+            <a:off x="640080" y="4754880"/>
+            <a:ext cx="914400" cy="731520"/>
           </a:xfrm>
           <a:prstGeom prst="rect">
             <a:avLst/>
@@ -2140,9 +2229,9 @@
               <a:buNone/>
             </a:pPr>
             <a:r>
-              <a:rPr lang="en-US" sz="3400" b="1" dirty="0">
-                <a:solidFill>
-                  <a:srgbClr val="E6EDF3"/>
+              <a:rPr lang="en-US" sz="3000" b="1" dirty="0">
+                <a:solidFill>
+                  <a:srgbClr val="A371F7"/>
                 </a:solidFill>
                 <a:latin typeface="Helvetica" pitchFamily="34" charset="0"/>
                 <a:ea typeface="Helvetica" pitchFamily="34" charset="-122"/>
@@ -2150,7 +2239,7 @@
               </a:rPr>
               <a:t>04</a:t>
             </a:r>
-            <a:endParaRPr lang="en-US" sz="3400" dirty="0"/>
+            <a:endParaRPr lang="en-US" sz="3000" dirty="0"/>
           </a:p>
         </p:txBody>
       </p:sp>
@@ -2162,8 +2251,8 @@
         </p:nvSpPr>
         <p:spPr>
           <a:xfrm>
-            <a:off x="1691640" y="5166360"/>
-            <a:ext cx="0" cy="731520"/>
+            <a:off x="1691640" y="4800600"/>
+            <a:ext cx="0" cy="658368"/>
           </a:xfrm>
           <a:prstGeom prst="line">
             <a:avLst/>
@@ -2185,8 +2274,8 @@
         </p:nvSpPr>
         <p:spPr>
           <a:xfrm>
-            <a:off x="1920240" y="5138928"/>
-            <a:ext cx="9601200" cy="457200"/>
+            <a:off x="1920240" y="4754880"/>
+            <a:ext cx="9601200" cy="411480"/>
           </a:xfrm>
           <a:prstGeom prst="rect">
             <a:avLst/>
@@ -2202,7 +2291,7 @@
               <a:buNone/>
             </a:pPr>
             <a:r>
-              <a:rPr lang="en-US" sz="2000" b="1" dirty="0">
+              <a:rPr lang="en-US" sz="1900" b="1" dirty="0">
                 <a:solidFill>
                   <a:srgbClr val="E6EDF3"/>
                 </a:solidFill>
@@ -2210,9 +2299,9 @@
                 <a:ea typeface="Helvetica" pitchFamily="34" charset="-122"/>
                 <a:cs typeface="Helvetica" pitchFamily="34" charset="-120"/>
               </a:rPr>
-              <a:t>Live demo</a:t>
-            </a:r>
-            <a:endParaRPr lang="en-US" sz="2000" dirty="0"/>
+              <a:t>Agentic Workflows</a:t>
+            </a:r>
+            <a:endParaRPr lang="en-US" sz="1900" dirty="0"/>
           </a:p>
         </p:txBody>
       </p:sp>
@@ -2224,7 +2313,7 @@
         </p:nvSpPr>
         <p:spPr>
           <a:xfrm>
-            <a:off x="1920240" y="5577840"/>
+            <a:off x="1920240" y="5157216"/>
             <a:ext cx="9601200" cy="365760"/>
           </a:xfrm>
           <a:prstGeom prst="rect">
@@ -2241,7 +2330,7 @@
               <a:buNone/>
             </a:pPr>
             <a:r>
-              <a:rPr lang="en-US" sz="1400" dirty="0">
+              <a:rPr lang="en-US" sz="1350" dirty="0">
                 <a:solidFill>
                   <a:srgbClr val="8B949E"/>
                 </a:solidFill>
@@ -2249,9 +2338,149 @@
                 <a:ea typeface="Helvetica" pitchFamily="34" charset="-122"/>
                 <a:cs typeface="Helvetica" pitchFamily="34" charset="-120"/>
               </a:rPr>
-              <a:t>Generate a workflow with an agent, push it, watch it run.</a:t>
-            </a:r>
-            <a:endParaRPr lang="en-US" sz="1400" dirty="0"/>
+              <a:t>Continuous AI — automation that opens issues &amp; PRs on its own.</a:t>
+            </a:r>
+            <a:endParaRPr lang="en-US" sz="1350" dirty="0"/>
+          </a:p>
+        </p:txBody>
+      </p:sp>
+      <p:sp>
+        <p:nvSpPr>
+          <p:cNvPr id="22" name="Text 20"/>
+          <p:cNvSpPr/>
+          <p:nvPr/>
+        </p:nvSpPr>
+        <p:spPr>
+          <a:xfrm>
+            <a:off x="640080" y="5623560"/>
+            <a:ext cx="914400" cy="731520"/>
+          </a:xfrm>
+          <a:prstGeom prst="rect">
+            <a:avLst/>
+          </a:prstGeom>
+          <a:noFill/>
+          <a:ln/>
+        </p:spPr>
+        <p:txBody>
+          <a:bodyPr wrap="square" rtlCol="0" anchor="ctr"/>
+          <a:lstStyle/>
+          <a:p>
+            <a:pPr indent="0" marL="0">
+              <a:buNone/>
+            </a:pPr>
+            <a:r>
+              <a:rPr lang="en-US" sz="3000" b="1" dirty="0">
+                <a:solidFill>
+                  <a:srgbClr val="E6EDF3"/>
+                </a:solidFill>
+                <a:latin typeface="Helvetica" pitchFamily="34" charset="0"/>
+                <a:ea typeface="Helvetica" pitchFamily="34" charset="-122"/>
+                <a:cs typeface="Helvetica" pitchFamily="34" charset="-120"/>
+              </a:rPr>
+              <a:t>05</a:t>
+            </a:r>
+            <a:endParaRPr lang="en-US" sz="3000" dirty="0"/>
+          </a:p>
+        </p:txBody>
+      </p:sp>
+      <p:sp>
+        <p:nvSpPr>
+          <p:cNvPr id="23" name="Shape 21"/>
+          <p:cNvSpPr/>
+          <p:nvPr/>
+        </p:nvSpPr>
+        <p:spPr>
+          <a:xfrm>
+            <a:off x="1691640" y="5669280"/>
+            <a:ext cx="0" cy="658368"/>
+          </a:xfrm>
+          <a:prstGeom prst="line">
+            <a:avLst/>
+          </a:prstGeom>
+          <a:noFill/>
+          <a:ln w="19050">
+            <a:solidFill>
+              <a:srgbClr val="30363D"/>
+            </a:solidFill>
+            <a:prstDash val="solid"/>
+          </a:ln>
+        </p:spPr>
+      </p:sp>
+      <p:sp>
+        <p:nvSpPr>
+          <p:cNvPr id="24" name="Text 22"/>
+          <p:cNvSpPr/>
+          <p:nvPr/>
+        </p:nvSpPr>
+        <p:spPr>
+          <a:xfrm>
+            <a:off x="1920240" y="5623560"/>
+            <a:ext cx="9601200" cy="411480"/>
+          </a:xfrm>
+          <a:prstGeom prst="rect">
+            <a:avLst/>
+          </a:prstGeom>
+          <a:noFill/>
+          <a:ln/>
+        </p:spPr>
+        <p:txBody>
+          <a:bodyPr wrap="square" rtlCol="0" anchor="ctr"/>
+          <a:lstStyle/>
+          <a:p>
+            <a:pPr indent="0" marL="0">
+              <a:buNone/>
+            </a:pPr>
+            <a:r>
+              <a:rPr lang="en-US" sz="1900" b="1" dirty="0">
+                <a:solidFill>
+                  <a:srgbClr val="E6EDF3"/>
+                </a:solidFill>
+                <a:latin typeface="Helvetica" pitchFamily="34" charset="0"/>
+                <a:ea typeface="Helvetica" pitchFamily="34" charset="-122"/>
+                <a:cs typeface="Helvetica" pitchFamily="34" charset="-120"/>
+              </a:rPr>
+              <a:t>Live demo</a:t>
+            </a:r>
+            <a:endParaRPr lang="en-US" sz="1900" dirty="0"/>
+          </a:p>
+        </p:txBody>
+      </p:sp>
+      <p:sp>
+        <p:nvSpPr>
+          <p:cNvPr id="25" name="Text 23"/>
+          <p:cNvSpPr/>
+          <p:nvPr/>
+        </p:nvSpPr>
+        <p:spPr>
+          <a:xfrm>
+            <a:off x="1920240" y="6025896"/>
+            <a:ext cx="9601200" cy="365760"/>
+          </a:xfrm>
+          <a:prstGeom prst="rect">
+            <a:avLst/>
+          </a:prstGeom>
+          <a:noFill/>
+          <a:ln/>
+        </p:spPr>
+        <p:txBody>
+          <a:bodyPr wrap="square" rtlCol="0" anchor="ctr"/>
+          <a:lstStyle/>
+          <a:p>
+            <a:pPr indent="0" marL="0">
+              <a:buNone/>
+            </a:pPr>
+            <a:r>
+              <a:rPr lang="en-US" sz="1350" dirty="0">
+                <a:solidFill>
+                  <a:srgbClr val="8B949E"/>
+                </a:solidFill>
+                <a:latin typeface="Helvetica" pitchFamily="34" charset="0"/>
+                <a:ea typeface="Helvetica" pitchFamily="34" charset="-122"/>
+                <a:cs typeface="Helvetica" pitchFamily="34" charset="-120"/>
+              </a:rPr>
+              <a:t>Agent writes CI, push it, watch Actions run + an agentic workflow.</a:t>
+            </a:r>
+            <a:endParaRPr lang="en-US" sz="1350" dirty="0"/>
           </a:p>
         </p:txBody>
       </p:sp>
@@ -6382,6 +6611,835 @@
                 <a:cs typeface="Helvetica" pitchFamily="34" charset="-120"/>
               </a:rPr>
               <a:t>Copilot writes the YAML — Actions runs it on every push.</a:t>
+            </a:r>
+            <a:endParaRPr lang="en-US" sz="1400" dirty="0"/>
+          </a:p>
+        </p:txBody>
+      </p:sp>
+    </p:spTree>
+  </p:cSld>
+  <p:clrMapOvr>
+    <a:masterClrMapping/>
+  </p:clrMapOvr>
+</p:sld>
+</file>
+
+<file path=ppt/slides/slide6.xml><?xml version="1.0" encoding="utf-8"?>
+<p:sld xmlns:a="http://schemas.openxmlformats.org/drawingml/2006/main" xmlns:r="http://schemas.openxmlformats.org/officeDocument/2006/relationships" xmlns:p="http://schemas.openxmlformats.org/presentationml/2006/main">
+  <p:cSld name="Slide 6">
+    <p:bg>
+      <p:bgPr>
+        <a:solidFill>
+          <a:srgbClr val="0D1117"/>
+        </a:solidFill>
+      </p:bgPr>
+    </p:bg>
+    <p:spTree>
+      <p:nvGrpSpPr>
+        <p:cNvPr id="1" name=""/>
+        <p:cNvGrpSpPr/>
+        <p:nvPr/>
+      </p:nvGrpSpPr>
+      <p:grpSpPr>
+        <a:xfrm>
+          <a:off x="0" y="0"/>
+          <a:ext cx="0" cy="0"/>
+          <a:chOff x="0" y="0"/>
+          <a:chExt cx="0" cy="0"/>
+        </a:xfrm>
+      </p:grpSpPr>
+      <p:sp>
+        <p:nvSpPr>
+          <p:cNvPr id="2" name="Shape 0"/>
+          <p:cNvSpPr/>
+          <p:nvPr/>
+        </p:nvSpPr>
+        <p:spPr>
+          <a:xfrm>
+            <a:off x="0" y="0"/>
+            <a:ext cx="12191695" cy="109728"/>
+          </a:xfrm>
+          <a:prstGeom prst="rect">
+            <a:avLst/>
+          </a:prstGeom>
+          <a:solidFill>
+            <a:srgbClr val="A371F7"/>
+          </a:solidFill>
+          <a:ln/>
+        </p:spPr>
+      </p:sp>
+      <p:sp>
+        <p:nvSpPr>
+          <p:cNvPr id="3" name="Text 1"/>
+          <p:cNvSpPr/>
+          <p:nvPr/>
+        </p:nvSpPr>
+        <p:spPr>
+          <a:xfrm>
+            <a:off x="548640" y="6400800"/>
+            <a:ext cx="8229600" cy="274320"/>
+          </a:xfrm>
+          <a:prstGeom prst="rect">
+            <a:avLst/>
+          </a:prstGeom>
+          <a:noFill/>
+          <a:ln/>
+        </p:spPr>
+        <p:txBody>
+          <a:bodyPr wrap="square" rtlCol="0" anchor="ctr"/>
+          <a:lstStyle/>
+          <a:p>
+            <a:pPr algn="l" indent="0" marL="0">
+              <a:buNone/>
+            </a:pPr>
+            <a:r>
+              <a:rPr lang="en-US" sz="1000" dirty="0">
+                <a:solidFill>
+                  <a:srgbClr val="8B949E"/>
+                </a:solidFill>
+                <a:latin typeface="Helvetica" pitchFamily="34" charset="0"/>
+                <a:ea typeface="Helvetica" pitchFamily="34" charset="-122"/>
+                <a:cs typeface="Helvetica" pitchFamily="34" charset="-120"/>
+              </a:rPr>
+              <a:t>GitHub Copilot + GitHub Actions  ·  Live Demo</a:t>
+            </a:r>
+            <a:endParaRPr lang="en-US" sz="1000" dirty="0"/>
+          </a:p>
+        </p:txBody>
+      </p:sp>
+      <p:sp>
+        <p:nvSpPr>
+          <p:cNvPr id="4" name="Text 2"/>
+          <p:cNvSpPr/>
+          <p:nvPr/>
+        </p:nvSpPr>
+        <p:spPr>
+          <a:xfrm>
+            <a:off x="640080" y="548640"/>
+            <a:ext cx="2011680" cy="384048"/>
+          </a:xfrm>
+          <a:prstGeom prst="roundRect">
+            <a:avLst>
+              <a:gd name="adj" fmla="val 50000"/>
+            </a:avLst>
+          </a:prstGeom>
+          <a:solidFill>
+            <a:srgbClr val="A371F7"/>
+          </a:solidFill>
+          <a:ln/>
+        </p:spPr>
+        <p:txBody>
+          <a:bodyPr wrap="square" rtlCol="0" anchor="ctr"/>
+          <a:lstStyle/>
+          <a:p>
+            <a:pPr algn="ctr" indent="0" marL="0">
+              <a:buNone/>
+            </a:pPr>
+            <a:r>
+              <a:rPr lang="en-US" sz="1200" b="1" dirty="0">
+                <a:solidFill>
+                  <a:srgbClr val="0D1117"/>
+                </a:solidFill>
+                <a:latin typeface="Helvetica" pitchFamily="34" charset="0"/>
+                <a:ea typeface="Helvetica" pitchFamily="34" charset="-122"/>
+                <a:cs typeface="Helvetica" pitchFamily="34" charset="-120"/>
+              </a:rPr>
+              <a:t>AGENTIC</a:t>
+            </a:r>
+            <a:endParaRPr lang="en-US" sz="1200" dirty="0"/>
+          </a:p>
+        </p:txBody>
+      </p:sp>
+      <p:sp>
+        <p:nvSpPr>
+          <p:cNvPr id="5" name="Text 3"/>
+          <p:cNvSpPr/>
+          <p:nvPr/>
+        </p:nvSpPr>
+        <p:spPr>
+          <a:xfrm>
+            <a:off x="640080" y="1051560"/>
+            <a:ext cx="10972800" cy="822960"/>
+          </a:xfrm>
+          <a:prstGeom prst="rect">
+            <a:avLst/>
+          </a:prstGeom>
+          <a:noFill/>
+          <a:ln/>
+        </p:spPr>
+        <p:txBody>
+          <a:bodyPr wrap="square" rtlCol="0" anchor="ctr"/>
+          <a:lstStyle/>
+          <a:p>
+            <a:pPr indent="0" marL="0">
+              <a:buNone/>
+            </a:pPr>
+            <a:r>
+              <a:rPr lang="en-US" sz="3400" b="1" dirty="0">
+                <a:solidFill>
+                  <a:srgbClr val="E6EDF3"/>
+                </a:solidFill>
+                <a:latin typeface="Helvetica" pitchFamily="34" charset="0"/>
+                <a:ea typeface="Helvetica" pitchFamily="34" charset="-122"/>
+                <a:cs typeface="Helvetica" pitchFamily="34" charset="-120"/>
+              </a:rPr>
+              <a:t>Agentic Workflows — Continuous AI</a:t>
+            </a:r>
+            <a:endParaRPr lang="en-US" sz="3400" dirty="0"/>
+          </a:p>
+        </p:txBody>
+      </p:sp>
+      <p:sp>
+        <p:nvSpPr>
+          <p:cNvPr id="6" name="Text 4"/>
+          <p:cNvSpPr/>
+          <p:nvPr/>
+        </p:nvSpPr>
+        <p:spPr>
+          <a:xfrm>
+            <a:off x="640080" y="1828800"/>
+            <a:ext cx="10972800" cy="457200"/>
+          </a:xfrm>
+          <a:prstGeom prst="rect">
+            <a:avLst/>
+          </a:prstGeom>
+          <a:noFill/>
+          <a:ln/>
+        </p:spPr>
+        <p:txBody>
+          <a:bodyPr wrap="square" rtlCol="0" anchor="ctr"/>
+          <a:lstStyle/>
+          <a:p>
+            <a:pPr indent="0" marL="0">
+              <a:buNone/>
+            </a:pPr>
+            <a:r>
+              <a:rPr lang="en-US" sz="1600" dirty="0">
+                <a:solidFill>
+                  <a:srgbClr val="8B949E"/>
+                </a:solidFill>
+                <a:latin typeface="Helvetica" pitchFamily="34" charset="0"/>
+                <a:ea typeface="Helvetica" pitchFamily="34" charset="-122"/>
+                <a:cs typeface="Helvetica" pitchFamily="34" charset="-120"/>
+              </a:rPr>
+              <a:t>The same repo knowledge, running in Actions when no one is at the editor.</a:t>
+            </a:r>
+            <a:endParaRPr lang="en-US" sz="1600" dirty="0"/>
+          </a:p>
+        </p:txBody>
+      </p:sp>
+      <p:sp>
+        <p:nvSpPr>
+          <p:cNvPr id="7" name="Shape 5"/>
+          <p:cNvSpPr/>
+          <p:nvPr/>
+        </p:nvSpPr>
+        <p:spPr>
+          <a:xfrm>
+            <a:off x="640080" y="2606040"/>
+            <a:ext cx="2514600" cy="822960"/>
+          </a:xfrm>
+          <a:prstGeom prst="roundRect">
+            <a:avLst>
+              <a:gd name="adj" fmla="val 13333"/>
+            </a:avLst>
+          </a:prstGeom>
+          <a:solidFill>
+            <a:srgbClr val="161B22"/>
+          </a:solidFill>
+          <a:ln w="19050">
+            <a:solidFill>
+              <a:srgbClr val="A371F7"/>
+            </a:solidFill>
+            <a:prstDash val="solid"/>
+          </a:ln>
+        </p:spPr>
+      </p:sp>
+      <p:sp>
+        <p:nvSpPr>
+          <p:cNvPr id="8" name="Text 6"/>
+          <p:cNvSpPr/>
+          <p:nvPr/>
+        </p:nvSpPr>
+        <p:spPr>
+          <a:xfrm>
+            <a:off x="685800" y="2606040"/>
+            <a:ext cx="2423160" cy="822960"/>
+          </a:xfrm>
+          <a:prstGeom prst="rect">
+            <a:avLst/>
+          </a:prstGeom>
+          <a:noFill/>
+          <a:ln/>
+        </p:spPr>
+        <p:txBody>
+          <a:bodyPr wrap="square" rtlCol="0" anchor="ctr"/>
+          <a:lstStyle/>
+          <a:p>
+            <a:pPr algn="ctr" indent="0" marL="0">
+              <a:buNone/>
+            </a:pPr>
+            <a:r>
+              <a:rPr lang="en-US" sz="1350" b="1" dirty="0">
+                <a:solidFill>
+                  <a:srgbClr val="E6EDF3"/>
+                </a:solidFill>
+                <a:latin typeface="Helvetica" pitchFamily="34" charset="0"/>
+                <a:ea typeface="Helvetica" pitchFamily="34" charset="-122"/>
+                <a:cs typeface="Helvetica" pitchFamily="34" charset="-120"/>
+              </a:rPr>
+              <a:t>Trigger</a:t>
+            </a:r>
+            <a:endParaRPr lang="en-US" sz="1350" dirty="0"/>
+          </a:p>
+        </p:txBody>
+      </p:sp>
+      <p:sp>
+        <p:nvSpPr>
+          <p:cNvPr id="9" name="Text 7"/>
+          <p:cNvSpPr/>
+          <p:nvPr/>
+        </p:nvSpPr>
+        <p:spPr>
+          <a:xfrm>
+            <a:off x="3154680" y="2606040"/>
+            <a:ext cx="384048" cy="822960"/>
+          </a:xfrm>
+          <a:prstGeom prst="rect">
+            <a:avLst/>
+          </a:prstGeom>
+          <a:noFill/>
+          <a:ln/>
+        </p:spPr>
+        <p:txBody>
+          <a:bodyPr wrap="square" rtlCol="0" anchor="ctr"/>
+          <a:lstStyle/>
+          <a:p>
+            <a:pPr algn="ctr" indent="0" marL="0">
+              <a:buNone/>
+            </a:pPr>
+            <a:r>
+              <a:rPr lang="en-US" sz="1800" dirty="0">
+                <a:solidFill>
+                  <a:srgbClr val="A371F7"/>
+                </a:solidFill>
+                <a:latin typeface="Helvetica" pitchFamily="34" charset="0"/>
+                <a:ea typeface="Helvetica" pitchFamily="34" charset="-122"/>
+                <a:cs typeface="Helvetica" pitchFamily="34" charset="-120"/>
+              </a:rPr>
+              <a:t>→</a:t>
+            </a:r>
+            <a:endParaRPr lang="en-US" sz="1800" dirty="0"/>
+          </a:p>
+        </p:txBody>
+      </p:sp>
+      <p:sp>
+        <p:nvSpPr>
+          <p:cNvPr id="10" name="Shape 8"/>
+          <p:cNvSpPr/>
+          <p:nvPr/>
+        </p:nvSpPr>
+        <p:spPr>
+          <a:xfrm>
+            <a:off x="3538728" y="2606040"/>
+            <a:ext cx="2514600" cy="822960"/>
+          </a:xfrm>
+          <a:prstGeom prst="roundRect">
+            <a:avLst>
+              <a:gd name="adj" fmla="val 13333"/>
+            </a:avLst>
+          </a:prstGeom>
+          <a:solidFill>
+            <a:srgbClr val="161B22"/>
+          </a:solidFill>
+          <a:ln w="19050">
+            <a:solidFill>
+              <a:srgbClr val="A371F7"/>
+            </a:solidFill>
+            <a:prstDash val="solid"/>
+          </a:ln>
+        </p:spPr>
+      </p:sp>
+      <p:sp>
+        <p:nvSpPr>
+          <p:cNvPr id="11" name="Text 9"/>
+          <p:cNvSpPr/>
+          <p:nvPr/>
+        </p:nvSpPr>
+        <p:spPr>
+          <a:xfrm>
+            <a:off x="3584448" y="2606040"/>
+            <a:ext cx="2423160" cy="822960"/>
+          </a:xfrm>
+          <a:prstGeom prst="rect">
+            <a:avLst/>
+          </a:prstGeom>
+          <a:noFill/>
+          <a:ln/>
+        </p:spPr>
+        <p:txBody>
+          <a:bodyPr wrap="square" rtlCol="0" anchor="ctr"/>
+          <a:lstStyle/>
+          <a:p>
+            <a:pPr algn="ctr" indent="0" marL="0">
+              <a:buNone/>
+            </a:pPr>
+            <a:r>
+              <a:rPr lang="en-US" sz="1350" b="1" dirty="0">
+                <a:solidFill>
+                  <a:srgbClr val="E6EDF3"/>
+                </a:solidFill>
+                <a:latin typeface="Helvetica" pitchFamily="34" charset="0"/>
+                <a:ea typeface="Helvetica" pitchFamily="34" charset="-122"/>
+                <a:cs typeface="Helvetica" pitchFamily="34" charset="-120"/>
+              </a:rPr>
+              <a:t>Agent (read-only)</a:t>
+            </a:r>
+            <a:endParaRPr lang="en-US" sz="1350" dirty="0"/>
+          </a:p>
+        </p:txBody>
+      </p:sp>
+      <p:sp>
+        <p:nvSpPr>
+          <p:cNvPr id="12" name="Text 10"/>
+          <p:cNvSpPr/>
+          <p:nvPr/>
+        </p:nvSpPr>
+        <p:spPr>
+          <a:xfrm>
+            <a:off x="6053328" y="2606040"/>
+            <a:ext cx="384048" cy="822960"/>
+          </a:xfrm>
+          <a:prstGeom prst="rect">
+            <a:avLst/>
+          </a:prstGeom>
+          <a:noFill/>
+          <a:ln/>
+        </p:spPr>
+        <p:txBody>
+          <a:bodyPr wrap="square" rtlCol="0" anchor="ctr"/>
+          <a:lstStyle/>
+          <a:p>
+            <a:pPr algn="ctr" indent="0" marL="0">
+              <a:buNone/>
+            </a:pPr>
+            <a:r>
+              <a:rPr lang="en-US" sz="1800" dirty="0">
+                <a:solidFill>
+                  <a:srgbClr val="A371F7"/>
+                </a:solidFill>
+                <a:latin typeface="Helvetica" pitchFamily="34" charset="0"/>
+                <a:ea typeface="Helvetica" pitchFamily="34" charset="-122"/>
+                <a:cs typeface="Helvetica" pitchFamily="34" charset="-120"/>
+              </a:rPr>
+              <a:t>→</a:t>
+            </a:r>
+            <a:endParaRPr lang="en-US" sz="1800" dirty="0"/>
+          </a:p>
+        </p:txBody>
+      </p:sp>
+      <p:sp>
+        <p:nvSpPr>
+          <p:cNvPr id="13" name="Shape 11"/>
+          <p:cNvSpPr/>
+          <p:nvPr/>
+        </p:nvSpPr>
+        <p:spPr>
+          <a:xfrm>
+            <a:off x="6437376" y="2606040"/>
+            <a:ext cx="2514600" cy="822960"/>
+          </a:xfrm>
+          <a:prstGeom prst="roundRect">
+            <a:avLst>
+              <a:gd name="adj" fmla="val 13333"/>
+            </a:avLst>
+          </a:prstGeom>
+          <a:solidFill>
+            <a:srgbClr val="161B22"/>
+          </a:solidFill>
+          <a:ln w="19050">
+            <a:solidFill>
+              <a:srgbClr val="A371F7"/>
+            </a:solidFill>
+            <a:prstDash val="solid"/>
+          </a:ln>
+        </p:spPr>
+      </p:sp>
+      <p:sp>
+        <p:nvSpPr>
+          <p:cNvPr id="14" name="Text 12"/>
+          <p:cNvSpPr/>
+          <p:nvPr/>
+        </p:nvSpPr>
+        <p:spPr>
+          <a:xfrm>
+            <a:off x="6483096" y="2606040"/>
+            <a:ext cx="2423160" cy="822960"/>
+          </a:xfrm>
+          <a:prstGeom prst="rect">
+            <a:avLst/>
+          </a:prstGeom>
+          <a:noFill/>
+          <a:ln/>
+        </p:spPr>
+        <p:txBody>
+          <a:bodyPr wrap="square" rtlCol="0" anchor="ctr"/>
+          <a:lstStyle/>
+          <a:p>
+            <a:pPr algn="ctr" indent="0" marL="0">
+              <a:buNone/>
+            </a:pPr>
+            <a:r>
+              <a:rPr lang="en-US" sz="1350" b="1" dirty="0">
+                <a:solidFill>
+                  <a:srgbClr val="E6EDF3"/>
+                </a:solidFill>
+                <a:latin typeface="Helvetica" pitchFamily="34" charset="0"/>
+                <a:ea typeface="Helvetica" pitchFamily="34" charset="-122"/>
+                <a:cs typeface="Helvetica" pitchFamily="34" charset="-120"/>
+              </a:rPr>
+              <a:t>Safe outputs</a:t>
+            </a:r>
+            <a:endParaRPr lang="en-US" sz="1350" dirty="0"/>
+          </a:p>
+        </p:txBody>
+      </p:sp>
+      <p:sp>
+        <p:nvSpPr>
+          <p:cNvPr id="15" name="Text 13"/>
+          <p:cNvSpPr/>
+          <p:nvPr/>
+        </p:nvSpPr>
+        <p:spPr>
+          <a:xfrm>
+            <a:off x="8951976" y="2606040"/>
+            <a:ext cx="384048" cy="822960"/>
+          </a:xfrm>
+          <a:prstGeom prst="rect">
+            <a:avLst/>
+          </a:prstGeom>
+          <a:noFill/>
+          <a:ln/>
+        </p:spPr>
+        <p:txBody>
+          <a:bodyPr wrap="square" rtlCol="0" anchor="ctr"/>
+          <a:lstStyle/>
+          <a:p>
+            <a:pPr algn="ctr" indent="0" marL="0">
+              <a:buNone/>
+            </a:pPr>
+            <a:r>
+              <a:rPr lang="en-US" sz="1800" dirty="0">
+                <a:solidFill>
+                  <a:srgbClr val="A371F7"/>
+                </a:solidFill>
+                <a:latin typeface="Helvetica" pitchFamily="34" charset="0"/>
+                <a:ea typeface="Helvetica" pitchFamily="34" charset="-122"/>
+                <a:cs typeface="Helvetica" pitchFamily="34" charset="-120"/>
+              </a:rPr>
+              <a:t>→</a:t>
+            </a:r>
+            <a:endParaRPr lang="en-US" sz="1800" dirty="0"/>
+          </a:p>
+        </p:txBody>
+      </p:sp>
+      <p:sp>
+        <p:nvSpPr>
+          <p:cNvPr id="16" name="Shape 14"/>
+          <p:cNvSpPr/>
+          <p:nvPr/>
+        </p:nvSpPr>
+        <p:spPr>
+          <a:xfrm>
+            <a:off x="9336024" y="2606040"/>
+            <a:ext cx="2514600" cy="822960"/>
+          </a:xfrm>
+          <a:prstGeom prst="roundRect">
+            <a:avLst>
+              <a:gd name="adj" fmla="val 13333"/>
+            </a:avLst>
+          </a:prstGeom>
+          <a:solidFill>
+            <a:srgbClr val="161B22"/>
+          </a:solidFill>
+          <a:ln w="19050">
+            <a:solidFill>
+              <a:srgbClr val="A371F7"/>
+            </a:solidFill>
+            <a:prstDash val="solid"/>
+          </a:ln>
+        </p:spPr>
+      </p:sp>
+      <p:sp>
+        <p:nvSpPr>
+          <p:cNvPr id="17" name="Text 15"/>
+          <p:cNvSpPr/>
+          <p:nvPr/>
+        </p:nvSpPr>
+        <p:spPr>
+          <a:xfrm>
+            <a:off x="9381744" y="2606040"/>
+            <a:ext cx="2423160" cy="822960"/>
+          </a:xfrm>
+          <a:prstGeom prst="rect">
+            <a:avLst/>
+          </a:prstGeom>
+          <a:noFill/>
+          <a:ln/>
+        </p:spPr>
+        <p:txBody>
+          <a:bodyPr wrap="square" rtlCol="0" anchor="ctr"/>
+          <a:lstStyle/>
+          <a:p>
+            <a:pPr algn="ctr" indent="0" marL="0">
+              <a:buNone/>
+            </a:pPr>
+            <a:r>
+              <a:rPr lang="en-US" sz="1350" b="1" dirty="0">
+                <a:solidFill>
+                  <a:srgbClr val="E6EDF3"/>
+                </a:solidFill>
+                <a:latin typeface="Helvetica" pitchFamily="34" charset="0"/>
+                <a:ea typeface="Helvetica" pitchFamily="34" charset="-122"/>
+                <a:cs typeface="Helvetica" pitchFamily="34" charset="-120"/>
+              </a:rPr>
+              <a:t>Issue / PR</a:t>
+            </a:r>
+            <a:endParaRPr lang="en-US" sz="1350" dirty="0"/>
+          </a:p>
+        </p:txBody>
+      </p:sp>
+      <p:sp>
+        <p:nvSpPr>
+          <p:cNvPr id="18" name="Text 16"/>
+          <p:cNvSpPr/>
+          <p:nvPr/>
+        </p:nvSpPr>
+        <p:spPr>
+          <a:xfrm>
+            <a:off x="640080" y="3840480"/>
+            <a:ext cx="5394960" cy="1097280"/>
+          </a:xfrm>
+          <a:prstGeom prst="rect">
+            <a:avLst/>
+          </a:prstGeom>
+          <a:noFill/>
+          <a:ln/>
+        </p:spPr>
+        <p:txBody>
+          <a:bodyPr wrap="square" rtlCol="0" anchor="t"/>
+          <a:lstStyle/>
+          <a:p>
+            <a:pPr indent="0" marL="0">
+              <a:lnSpc>
+                <a:spcPct val="110000"/>
+              </a:lnSpc>
+              <a:buNone/>
+            </a:pPr>
+            <a:r>
+              <a:rPr lang="en-US" sz="1400" b="1" dirty="0">
+                <a:solidFill>
+                  <a:srgbClr val="A371F7"/>
+                </a:solidFill>
+                <a:latin typeface="Helvetica" pitchFamily="34" charset="0"/>
+                <a:ea typeface="Helvetica" pitchFamily="34" charset="-122"/>
+                <a:cs typeface="Helvetica" pitchFamily="34" charset="-120"/>
+              </a:rPr>
+              <a:t>Markdown + frontmatter  —  </a:t>
+            </a:r>
+            <a:pPr indent="0" marL="0">
+              <a:lnSpc>
+                <a:spcPct val="110000"/>
+              </a:lnSpc>
+              <a:buNone/>
+            </a:pPr>
+            <a:r>
+              <a:rPr lang="en-US" sz="1400" dirty="0">
+                <a:solidFill>
+                  <a:srgbClr val="E6EDF3"/>
+                </a:solidFill>
+                <a:latin typeface="Helvetica" pitchFamily="34" charset="0"/>
+                <a:ea typeface="Helvetica" pitchFamily="34" charset="-122"/>
+                <a:cs typeface="Helvetica" pitchFamily="34" charset="-120"/>
+              </a:rPr>
+              <a:t>A .md file in .github/workflows: YAML config + plain-English task.</a:t>
+            </a:r>
+            <a:endParaRPr lang="en-US" sz="1400" dirty="0"/>
+          </a:p>
+        </p:txBody>
+      </p:sp>
+      <p:sp>
+        <p:nvSpPr>
+          <p:cNvPr id="19" name="Text 17"/>
+          <p:cNvSpPr/>
+          <p:nvPr/>
+        </p:nvSpPr>
+        <p:spPr>
+          <a:xfrm>
+            <a:off x="6217920" y="3840480"/>
+            <a:ext cx="5394960" cy="1097280"/>
+          </a:xfrm>
+          <a:prstGeom prst="rect">
+            <a:avLst/>
+          </a:prstGeom>
+          <a:noFill/>
+          <a:ln/>
+        </p:spPr>
+        <p:txBody>
+          <a:bodyPr wrap="square" rtlCol="0" anchor="t"/>
+          <a:lstStyle/>
+          <a:p>
+            <a:pPr indent="0" marL="0">
+              <a:lnSpc>
+                <a:spcPct val="110000"/>
+              </a:lnSpc>
+              <a:buNone/>
+            </a:pPr>
+            <a:r>
+              <a:rPr lang="en-US" sz="1400" b="1" dirty="0">
+                <a:solidFill>
+                  <a:srgbClr val="A371F7"/>
+                </a:solidFill>
+                <a:latin typeface="Helvetica" pitchFamily="34" charset="0"/>
+                <a:ea typeface="Helvetica" pitchFamily="34" charset="-122"/>
+                <a:cs typeface="Helvetica" pitchFamily="34" charset="-120"/>
+              </a:rPr>
+              <a:t>Safe outputs  —  </a:t>
+            </a:r>
+            <a:pPr indent="0" marL="0">
+              <a:lnSpc>
+                <a:spcPct val="110000"/>
+              </a:lnSpc>
+              <a:buNone/>
+            </a:pPr>
+            <a:r>
+              <a:rPr lang="en-US" sz="1400" dirty="0">
+                <a:solidFill>
+                  <a:srgbClr val="E6EDF3"/>
+                </a:solidFill>
+                <a:latin typeface="Helvetica" pitchFamily="34" charset="0"/>
+                <a:ea typeface="Helvetica" pitchFamily="34" charset="-122"/>
+                <a:cs typeface="Helvetica" pitchFamily="34" charset="-120"/>
+              </a:rPr>
+              <a:t>Agent runs read-only; a separate job opens the issue/PR it requests.</a:t>
+            </a:r>
+            <a:endParaRPr lang="en-US" sz="1400" dirty="0"/>
+          </a:p>
+        </p:txBody>
+      </p:sp>
+      <p:sp>
+        <p:nvSpPr>
+          <p:cNvPr id="20" name="Text 18"/>
+          <p:cNvSpPr/>
+          <p:nvPr/>
+        </p:nvSpPr>
+        <p:spPr>
+          <a:xfrm>
+            <a:off x="640080" y="5074920"/>
+            <a:ext cx="5394960" cy="1097280"/>
+          </a:xfrm>
+          <a:prstGeom prst="rect">
+            <a:avLst/>
+          </a:prstGeom>
+          <a:noFill/>
+          <a:ln/>
+        </p:spPr>
+        <p:txBody>
+          <a:bodyPr wrap="square" rtlCol="0" anchor="t"/>
+          <a:lstStyle/>
+          <a:p>
+            <a:pPr indent="0" marL="0">
+              <a:lnSpc>
+                <a:spcPct val="110000"/>
+              </a:lnSpc>
+              <a:buNone/>
+            </a:pPr>
+            <a:r>
+              <a:rPr lang="en-US" sz="1400" b="1" dirty="0">
+                <a:solidFill>
+                  <a:srgbClr val="A371F7"/>
+                </a:solidFill>
+                <a:latin typeface="Helvetica" pitchFamily="34" charset="0"/>
+                <a:ea typeface="Helvetica" pitchFamily="34" charset="-122"/>
+                <a:cs typeface="Helvetica" pitchFamily="34" charset="-120"/>
+              </a:rPr>
+              <a:t>Good fits  —  </a:t>
+            </a:r>
+            <a:pPr indent="0" marL="0">
+              <a:lnSpc>
+                <a:spcPct val="110000"/>
+              </a:lnSpc>
+              <a:buNone/>
+            </a:pPr>
+            <a:r>
+              <a:rPr lang="en-US" sz="1400" dirty="0">
+                <a:solidFill>
+                  <a:srgbClr val="E6EDF3"/>
+                </a:solidFill>
+                <a:latin typeface="Helvetica" pitchFamily="34" charset="0"/>
+                <a:ea typeface="Helvetica" pitchFamily="34" charset="-122"/>
+                <a:cs typeface="Helvetica" pitchFamily="34" charset="-120"/>
+              </a:rPr>
+              <a:t>Triage, status reports, docs drift, test gaps, routine repo hygiene.</a:t>
+            </a:r>
+            <a:endParaRPr lang="en-US" sz="1400" dirty="0"/>
+          </a:p>
+        </p:txBody>
+      </p:sp>
+      <p:sp>
+        <p:nvSpPr>
+          <p:cNvPr id="21" name="Text 19"/>
+          <p:cNvSpPr/>
+          <p:nvPr/>
+        </p:nvSpPr>
+        <p:spPr>
+          <a:xfrm>
+            <a:off x="6217920" y="5074920"/>
+            <a:ext cx="5394960" cy="1097280"/>
+          </a:xfrm>
+          <a:prstGeom prst="rect">
+            <a:avLst/>
+          </a:prstGeom>
+          <a:noFill/>
+          <a:ln/>
+        </p:spPr>
+        <p:txBody>
+          <a:bodyPr wrap="square" rtlCol="0" anchor="t"/>
+          <a:lstStyle/>
+          <a:p>
+            <a:pPr indent="0" marL="0">
+              <a:lnSpc>
+                <a:spcPct val="110000"/>
+              </a:lnSpc>
+              <a:buNone/>
+            </a:pPr>
+            <a:r>
+              <a:rPr lang="en-US" sz="1400" b="1" dirty="0">
+                <a:solidFill>
+                  <a:srgbClr val="A371F7"/>
+                </a:solidFill>
+                <a:latin typeface="Helvetica" pitchFamily="34" charset="0"/>
+                <a:ea typeface="Helvetica" pitchFamily="34" charset="-122"/>
+                <a:cs typeface="Helvetica" pitchFamily="34" charset="-120"/>
+              </a:rPr>
+              <a:t>This demo  —  </a:t>
+            </a:r>
+            <a:pPr indent="0" marL="0">
+              <a:lnSpc>
+                <a:spcPct val="110000"/>
+              </a:lnSpc>
+              <a:buNone/>
+            </a:pPr>
+            <a:r>
+              <a:rPr lang="en-US" sz="1400" dirty="0">
+                <a:solidFill>
+                  <a:srgbClr val="E6EDF3"/>
+                </a:solidFill>
+                <a:latin typeface="Helvetica" pitchFamily="34" charset="0"/>
+                <a:ea typeface="Helvetica" pitchFamily="34" charset="-122"/>
+                <a:cs typeface="Helvetica" pitchFamily="34" charset="-120"/>
+              </a:rPr>
+              <a:t>A scheduled CI Health report that opens an issue — automatically.</a:t>
             </a:r>
             <a:endParaRPr lang="en-US" sz="1400" dirty="0"/>
           </a:p>

</xml_diff>